<commit_message>
docs: add target demographic and user personas slide to pitch deck
</commit_message>
<xml_diff>
--- a/ZeroTouch_PitchDeck.pptx
+++ b/ZeroTouch_PitchDeck.pptx
@@ -10,6 +10,7 @@
     <p:sldId id="258" r:id="rId9"/>
     <p:sldId id="259" r:id="rId10"/>
     <p:sldId id="260" r:id="rId11"/>
+    <p:sldId id="261" r:id="rId12"/>
   </p:sldIdLst>
   <p:sldSz cx="12191695" cy="6858000" type="screen4x3"/>
   <p:notesSz cx="6858000" cy="9144000"/>
@@ -3232,7 +3233,7 @@
               </a:spcBef>
               <a:defRPr sz="1300">
                 <a:solidFill>
-                  <a:srgbClr val="B59350"/>
+                  <a:srgbClr val="A0824B"/>
                 </a:solidFill>
                 <a:latin typeface="Segoe UI"/>
               </a:defRPr>
@@ -3312,8 +3313,8 @@
         </p:nvSpPr>
         <p:spPr>
           <a:xfrm>
-            <a:off x="731520" y="411480"/>
-            <a:ext cx="10515600" cy="365760"/>
+            <a:off x="731520" y="502920"/>
+            <a:ext cx="10728655" cy="1005840"/>
           </a:xfrm>
           <a:prstGeom prst="rect">
             <a:avLst/>
@@ -3331,39 +3332,19 @@
                 <a:solidFill>
                   <a:srgbClr val="D4AF6A"/>
                 </a:solidFill>
-                <a:latin typeface="Segoe UI"/>
+                <a:latin typeface="Consolas"/>
               </a:defRPr>
             </a:pPr>
             <a:r>
               <a:t>01 • PROBLEM &amp; THESIS</a:t>
             </a:r>
           </a:p>
-        </p:txBody>
-      </p:sp>
-      <p:sp>
-        <p:nvSpPr>
-          <p:cNvPr id="4" name="TextBox 3"/>
-          <p:cNvSpPr txBox="1"/>
-          <p:nvPr/>
-        </p:nvSpPr>
-        <p:spPr>
-          <a:xfrm>
-            <a:off x="731520" y="731520"/>
-            <a:ext cx="10515600" cy="822960"/>
-          </a:xfrm>
-          <a:prstGeom prst="rect">
-            <a:avLst/>
-          </a:prstGeom>
-          <a:noFill/>
-        </p:spPr>
-        <p:txBody>
-          <a:bodyPr wrap="square">
-            <a:spAutoFit/>
-          </a:bodyPr>
-          <a:lstStyle/>
-          <a:p>
-            <a:pPr>
-              <a:defRPr sz="2800" b="1">
+          <a:p>
+            <a:pPr>
+              <a:spcBef>
+                <a:spcPts val="400"/>
+              </a:spcBef>
+              <a:defRPr sz="2600" b="1">
                 <a:solidFill>
                   <a:srgbClr val="F2EFE9"/>
                 </a:solidFill>
@@ -3378,7 +3359,7 @@
       </p:sp>
       <p:sp>
         <p:nvSpPr>
-          <p:cNvPr id="5" name="Rounded Rectangle 4"/>
+          <p:cNvPr id="4" name="Rounded Rectangle 3"/>
           <p:cNvSpPr/>
           <p:nvPr/>
         </p:nvSpPr>
@@ -3423,14 +3404,14 @@
       </p:sp>
       <p:sp>
         <p:nvSpPr>
-          <p:cNvPr id="6" name="TextBox 5"/>
+          <p:cNvPr id="5" name="TextBox 4"/>
           <p:cNvSpPr txBox="1"/>
           <p:nvPr/>
         </p:nvSpPr>
         <p:spPr>
           <a:xfrm>
-            <a:off x="987552" y="1993392"/>
-            <a:ext cx="4608576" cy="3877056"/>
+            <a:off x="960120" y="1965960"/>
+            <a:ext cx="4663440" cy="3931920"/>
           </a:xfrm>
           <a:prstGeom prst="rect">
             <a:avLst/>
@@ -3444,7 +3425,7 @@
           <a:lstStyle/>
           <a:p>
             <a:pPr>
-              <a:defRPr sz="1900" b="1">
+              <a:defRPr sz="1800" b="1">
                 <a:solidFill>
                   <a:srgbClr val="D4AF6A"/>
                 </a:solidFill>
@@ -3458,9 +3439,9 @@
           <a:p>
             <a:pPr>
               <a:spcBef>
-                <a:spcPts val="800"/>
+                <a:spcPts val="600"/>
               </a:spcBef>
-              <a:defRPr sz="1400">
+              <a:defRPr sz="1300">
                 <a:solidFill>
                   <a:srgbClr val="F2EFE9"/>
                 </a:solidFill>
@@ -3474,9 +3455,9 @@
           <a:p>
             <a:pPr>
               <a:spcBef>
-                <a:spcPts val="800"/>
+                <a:spcPts val="600"/>
               </a:spcBef>
-              <a:defRPr sz="1400">
+              <a:defRPr sz="1300">
                 <a:solidFill>
                   <a:srgbClr val="F2EFE9"/>
                 </a:solidFill>
@@ -3490,9 +3471,9 @@
           <a:p>
             <a:pPr>
               <a:spcBef>
-                <a:spcPts val="800"/>
+                <a:spcPts val="600"/>
               </a:spcBef>
-              <a:defRPr sz="1400">
+              <a:defRPr sz="1300">
                 <a:solidFill>
                   <a:srgbClr val="F2EFE9"/>
                 </a:solidFill>
@@ -3506,9 +3487,9 @@
           <a:p>
             <a:pPr>
               <a:spcBef>
-                <a:spcPts val="800"/>
+                <a:spcPts val="600"/>
               </a:spcBef>
-              <a:defRPr sz="1400">
+              <a:defRPr sz="1300">
                 <a:solidFill>
                   <a:srgbClr val="F2EFE9"/>
                 </a:solidFill>
@@ -3523,7 +3504,7 @@
       </p:sp>
       <p:sp>
         <p:nvSpPr>
-          <p:cNvPr id="7" name="Rounded Rectangle 6"/>
+          <p:cNvPr id="6" name="Rounded Rectangle 5"/>
           <p:cNvSpPr/>
           <p:nvPr/>
         </p:nvSpPr>
@@ -3568,14 +3549,14 @@
       </p:sp>
       <p:sp>
         <p:nvSpPr>
-          <p:cNvPr id="8" name="TextBox 7"/>
+          <p:cNvPr id="7" name="TextBox 6"/>
           <p:cNvSpPr txBox="1"/>
           <p:nvPr/>
         </p:nvSpPr>
         <p:spPr>
           <a:xfrm>
-            <a:off x="6473952" y="1993392"/>
-            <a:ext cx="4700016" cy="3877056"/>
+            <a:off x="6446520" y="1965960"/>
+            <a:ext cx="4754880" cy="3931920"/>
           </a:xfrm>
           <a:prstGeom prst="rect">
             <a:avLst/>
@@ -3589,7 +3570,7 @@
           <a:lstStyle/>
           <a:p>
             <a:pPr>
-              <a:defRPr sz="1900" b="1">
+              <a:defRPr sz="1800" b="1">
                 <a:solidFill>
                   <a:srgbClr val="F2EFE9"/>
                 </a:solidFill>
@@ -3603,9 +3584,9 @@
           <a:p>
             <a:pPr>
               <a:spcBef>
-                <a:spcPts val="800"/>
+                <a:spcPts val="600"/>
               </a:spcBef>
-              <a:defRPr sz="1400">
+              <a:defRPr sz="1300">
                 <a:solidFill>
                   <a:srgbClr val="F2EFE9"/>
                 </a:solidFill>
@@ -3619,9 +3600,9 @@
           <a:p>
             <a:pPr>
               <a:spcBef>
-                <a:spcPts val="800"/>
+                <a:spcPts val="600"/>
               </a:spcBef>
-              <a:defRPr sz="1400">
+              <a:defRPr sz="1300">
                 <a:solidFill>
                   <a:srgbClr val="F2EFE9"/>
                 </a:solidFill>
@@ -3635,9 +3616,9 @@
           <a:p>
             <a:pPr>
               <a:spcBef>
-                <a:spcPts val="800"/>
+                <a:spcPts val="600"/>
               </a:spcBef>
-              <a:defRPr sz="1400">
+              <a:defRPr sz="1300">
                 <a:solidFill>
                   <a:srgbClr val="F2EFE9"/>
                 </a:solidFill>
@@ -3651,9 +3632,9 @@
           <a:p>
             <a:pPr>
               <a:spcBef>
-                <a:spcPts val="800"/>
+                <a:spcPts val="600"/>
               </a:spcBef>
-              <a:defRPr sz="1400">
+              <a:defRPr sz="1300">
                 <a:solidFill>
                   <a:srgbClr val="F2EFE9"/>
                 </a:solidFill>
@@ -3735,8 +3716,8 @@
         </p:nvSpPr>
         <p:spPr>
           <a:xfrm>
-            <a:off x="731520" y="411480"/>
-            <a:ext cx="10515600" cy="365760"/>
+            <a:off x="731520" y="502920"/>
+            <a:ext cx="10728655" cy="1005840"/>
           </a:xfrm>
           <a:prstGeom prst="rect">
             <a:avLst/>
@@ -3754,39 +3735,19 @@
                 <a:solidFill>
                   <a:srgbClr val="D4AF6A"/>
                 </a:solidFill>
-                <a:latin typeface="Segoe UI"/>
-              </a:defRPr>
-            </a:pPr>
-            <a:r>
-              <a:t>02 • SPATIAL WORKFLOW</a:t>
-            </a:r>
-          </a:p>
-        </p:txBody>
-      </p:sp>
-      <p:sp>
-        <p:nvSpPr>
-          <p:cNvPr id="4" name="TextBox 3"/>
-          <p:cNvSpPr txBox="1"/>
-          <p:nvPr/>
-        </p:nvSpPr>
-        <p:spPr>
-          <a:xfrm>
-            <a:off x="731520" y="731520"/>
-            <a:ext cx="10515600" cy="822960"/>
-          </a:xfrm>
-          <a:prstGeom prst="rect">
-            <a:avLst/>
-          </a:prstGeom>
-          <a:noFill/>
-        </p:spPr>
-        <p:txBody>
-          <a:bodyPr wrap="square">
-            <a:spAutoFit/>
-          </a:bodyPr>
-          <a:lstStyle/>
-          <a:p>
-            <a:pPr>
-              <a:defRPr sz="2800" b="1">
+                <a:latin typeface="Consolas"/>
+              </a:defRPr>
+            </a:pPr>
+            <a:r>
+              <a:t>02 • MARKET &amp; AUDIENCE</a:t>
+            </a:r>
+          </a:p>
+          <a:p>
+            <a:pPr>
+              <a:spcBef>
+                <a:spcPts val="400"/>
+              </a:spcBef>
+              <a:defRPr sz="2600" b="1">
                 <a:solidFill>
                   <a:srgbClr val="F2EFE9"/>
                 </a:solidFill>
@@ -3794,14 +3755,14 @@
               </a:defRPr>
             </a:pPr>
             <a:r>
-              <a:t>Context-Aware Architecture: One Engine, Three Modes</a:t>
-            </a:r>
-          </a:p>
-        </p:txBody>
-      </p:sp>
-      <p:sp>
-        <p:nvSpPr>
-          <p:cNvPr id="5" name="Rounded Rectangle 4"/>
+              <a:t>Target Demographic &amp; Real-World User Personas</a:t>
+            </a:r>
+          </a:p>
+        </p:txBody>
+      </p:sp>
+      <p:sp>
+        <p:nvSpPr>
+          <p:cNvPr id="4" name="Rounded Rectangle 3"/>
           <p:cNvSpPr/>
           <p:nvPr/>
         </p:nvSpPr>
@@ -3846,14 +3807,14 @@
       </p:sp>
       <p:sp>
         <p:nvSpPr>
-          <p:cNvPr id="6" name="TextBox 5"/>
+          <p:cNvPr id="5" name="TextBox 4"/>
           <p:cNvSpPr txBox="1"/>
           <p:nvPr/>
         </p:nvSpPr>
         <p:spPr>
           <a:xfrm>
-            <a:off x="987552" y="1993392"/>
-            <a:ext cx="2871216" cy="3877056"/>
+            <a:off x="960120" y="1965960"/>
+            <a:ext cx="2926080" cy="3931920"/>
           </a:xfrm>
           <a:prstGeom prst="rect">
             <a:avLst/>
@@ -3867,7 +3828,7 @@
           <a:lstStyle/>
           <a:p>
             <a:pPr>
-              <a:defRPr sz="1900" b="1">
+              <a:defRPr sz="1800" b="1">
                 <a:solidFill>
                   <a:srgbClr val="D4AF6A"/>
                 </a:solidFill>
@@ -3875,15 +3836,34 @@
               </a:defRPr>
             </a:pPr>
             <a:r>
-              <a:t>Presentation Mode</a:t>
+              <a:t>Corporate &amp; Remote Pros</a:t>
             </a:r>
           </a:p>
           <a:p>
             <a:pPr>
               <a:spcBef>
-                <a:spcPts val="800"/>
+                <a:spcPts val="200"/>
               </a:spcBef>
-              <a:defRPr sz="1400">
+              <a:spcAft>
+                <a:spcPts val="400"/>
+              </a:spcAft>
+              <a:defRPr sz="1200" b="1">
+                <a:solidFill>
+                  <a:srgbClr val="8A8D93"/>
+                </a:solidFill>
+                <a:latin typeface="Segoe UI"/>
+              </a:defRPr>
+            </a:pPr>
+            <a:r>
+              <a:t>Knowledge Workers &amp; Remote Teams</a:t>
+            </a:r>
+          </a:p>
+          <a:p>
+            <a:pPr>
+              <a:spcBef>
+                <a:spcPts val="600"/>
+              </a:spcBef>
+              <a:defRPr sz="1300">
                 <a:solidFill>
                   <a:srgbClr val="F2EFE9"/>
                 </a:solidFill>
@@ -3891,15 +3871,15 @@
               </a:defRPr>
             </a:pPr>
             <a:r>
-              <a:t>• Targets: PowerPoint, Google Slides, Keynote, PDF.</a:t>
+              <a:t>• Profile: Spends 4–6 hrs/day in virtual meetings (Google Meet, Microsoft Teams, Zoom).</a:t>
             </a:r>
           </a:p>
           <a:p>
             <a:pPr>
               <a:spcBef>
-                <a:spcPts val="800"/>
+                <a:spcPts val="600"/>
               </a:spcBef>
-              <a:defRPr sz="1400">
+              <a:defRPr sz="1300">
                 <a:solidFill>
                   <a:srgbClr val="F2EFE9"/>
                 </a:solidFill>
@@ -3907,15 +3887,15 @@
               </a:defRPr>
             </a:pPr>
             <a:r>
-              <a:t>• Back-of-Hand Swipe: Advance or return slides seamlessly across the room.</a:t>
+              <a:t>• Pain Point: Scrambling across 5 open windows to find the mute button while coughing or interrupted.</a:t>
             </a:r>
           </a:p>
           <a:p>
             <a:pPr>
               <a:spcBef>
-                <a:spcPts val="800"/>
+                <a:spcPts val="600"/>
               </a:spcBef>
-              <a:defRPr sz="1400">
+              <a:defRPr sz="1300">
                 <a:solidFill>
                   <a:srgbClr val="F2EFE9"/>
                 </a:solidFill>
@@ -3923,15 +3903,15 @@
               </a:defRPr>
             </a:pPr>
             <a:r>
-              <a:t>• Open Palm Hold (0.5s): Blank/resume screen ('B').</a:t>
+              <a:t>• ZeroTouch Value: Ghost-Mute (Shh to lips) toggles hardware mic instantly with zero window focus needed.</a:t>
             </a:r>
           </a:p>
           <a:p>
             <a:pPr>
               <a:spcBef>
-                <a:spcPts val="800"/>
+                <a:spcPts val="600"/>
               </a:spcBef>
-              <a:defRPr sz="1400">
+              <a:defRPr sz="1300">
                 <a:solidFill>
                   <a:srgbClr val="F2EFE9"/>
                 </a:solidFill>
@@ -3939,14 +3919,14 @@
               </a:defRPr>
             </a:pPr>
             <a:r>
-              <a:t>• Stage Optimization: Disengages desk gaze lockouts so presenters can look at audience or slides freely.</a:t>
-            </a:r>
-          </a:p>
-        </p:txBody>
-      </p:sp>
-      <p:sp>
-        <p:nvSpPr>
-          <p:cNvPr id="7" name="Rounded Rectangle 6"/>
+              <a:t>• Enterprise Fit: 100% local RAM execution complies with corporate IT security &amp; data privacy mandates.</a:t>
+            </a:r>
+          </a:p>
+        </p:txBody>
+      </p:sp>
+      <p:sp>
+        <p:nvSpPr>
+          <p:cNvPr id="6" name="Rounded Rectangle 5"/>
           <p:cNvSpPr/>
           <p:nvPr/>
         </p:nvSpPr>
@@ -3991,14 +3971,14 @@
       </p:sp>
       <p:sp>
         <p:nvSpPr>
-          <p:cNvPr id="8" name="TextBox 7"/>
+          <p:cNvPr id="7" name="TextBox 6"/>
           <p:cNvSpPr txBox="1"/>
           <p:nvPr/>
         </p:nvSpPr>
         <p:spPr>
           <a:xfrm>
-            <a:off x="4645152" y="1993392"/>
-            <a:ext cx="2871216" cy="3877056"/>
+            <a:off x="4617720" y="1965960"/>
+            <a:ext cx="2926080" cy="3931920"/>
           </a:xfrm>
           <a:prstGeom prst="rect">
             <a:avLst/>
@@ -4012,7 +3992,7 @@
           <a:lstStyle/>
           <a:p>
             <a:pPr>
-              <a:defRPr sz="1900" b="1">
+              <a:defRPr sz="1800" b="1">
                 <a:solidFill>
                   <a:srgbClr val="F2EFE9"/>
                 </a:solidFill>
@@ -4020,15 +4000,34 @@
               </a:defRPr>
             </a:pPr>
             <a:r>
-              <a:t>Video Meeting Mode</a:t>
+              <a:t>Presenters &amp; Educators</a:t>
             </a:r>
           </a:p>
           <a:p>
             <a:pPr>
               <a:spcBef>
-                <a:spcPts val="800"/>
+                <a:spcPts val="200"/>
               </a:spcBef>
-              <a:defRPr sz="1400">
+              <a:spcAft>
+                <a:spcPts val="400"/>
+              </a:spcAft>
+              <a:defRPr sz="1200" b="1">
+                <a:solidFill>
+                  <a:srgbClr val="8A8D93"/>
+                </a:solidFill>
+                <a:latin typeface="Segoe UI"/>
+              </a:defRPr>
+            </a:pPr>
+            <a:r>
+              <a:t>Speakers, Lecturers &amp; Pitch Teams</a:t>
+            </a:r>
+          </a:p>
+          <a:p>
+            <a:pPr>
+              <a:spcBef>
+                <a:spcPts val="600"/>
+              </a:spcBef>
+              <a:defRPr sz="1300">
                 <a:solidFill>
                   <a:srgbClr val="F2EFE9"/>
                 </a:solidFill>
@@ -4036,15 +4035,15 @@
               </a:defRPr>
             </a:pPr>
             <a:r>
-              <a:t>• Targets: Google Meet, Zoom, MS Teams, Webex.</a:t>
+              <a:t>• Profile: Keynote speakers, university lecturers, sales executives, and conference presenters.</a:t>
             </a:r>
           </a:p>
           <a:p>
             <a:pPr>
               <a:spcBef>
-                <a:spcPts val="800"/>
+                <a:spcPts val="600"/>
               </a:spcBef>
-              <a:defRPr sz="1400">
+              <a:defRPr sz="1300">
                 <a:solidFill>
                   <a:srgbClr val="F2EFE9"/>
                 </a:solidFill>
@@ -4052,15 +4051,15 @@
               </a:defRPr>
             </a:pPr>
             <a:r>
-              <a:t>• Ghost-Mute (Shh): Index finger to mouth directly toggles hardware microphone mute via Windows Core Audio.</a:t>
+              <a:t>• Pain Point: Tethered to podium laptop, dealing with broken/dead clicker dongles, or awkward pacing.</a:t>
             </a:r>
           </a:p>
           <a:p>
             <a:pPr>
               <a:spcBef>
-                <a:spcPts val="800"/>
+                <a:spcPts val="600"/>
               </a:spcBef>
-              <a:defRPr sz="1400">
+              <a:defRPr sz="1300">
                 <a:solidFill>
                   <a:srgbClr val="F2EFE9"/>
                 </a:solidFill>
@@ -4068,15 +4067,15 @@
               </a:defRPr>
             </a:pPr>
             <a:r>
-              <a:t>• Open Palm Hold: Instant camera toggle ('Alt + V').</a:t>
+              <a:t>• ZeroTouch Value: Stage Mode lets presenters navigate slides from 6–10 feet away with natural gestures.</a:t>
             </a:r>
           </a:p>
           <a:p>
             <a:pPr>
               <a:spcBef>
-                <a:spcPts val="800"/>
+                <a:spcPts val="600"/>
               </a:spcBef>
-              <a:defRPr sz="1400">
+              <a:defRPr sz="1300">
                 <a:solidFill>
                   <a:srgbClr val="F2EFE9"/>
                 </a:solidFill>
@@ -4084,14 +4083,14 @@
               </a:defRPr>
             </a:pPr>
             <a:r>
-              <a:t>• Back-of-Hand Swipe: Toggle participant views.</a:t>
-            </a:r>
-          </a:p>
-        </p:txBody>
-      </p:sp>
-      <p:sp>
-        <p:nvSpPr>
-          <p:cNvPr id="9" name="Rounded Rectangle 8"/>
+              <a:t>• Audience Engagement: Blank/resume slides instantly ('B') to command room attention without touching hardware.</a:t>
+            </a:r>
+          </a:p>
+        </p:txBody>
+      </p:sp>
+      <p:sp>
+        <p:nvSpPr>
+          <p:cNvPr id="8" name="Rounded Rectangle 7"/>
           <p:cNvSpPr/>
           <p:nvPr/>
         </p:nvSpPr>
@@ -4136,14 +4135,14 @@
       </p:sp>
       <p:sp>
         <p:nvSpPr>
-          <p:cNvPr id="10" name="TextBox 9"/>
+          <p:cNvPr id="9" name="TextBox 8"/>
           <p:cNvSpPr txBox="1"/>
           <p:nvPr/>
         </p:nvSpPr>
         <p:spPr>
           <a:xfrm>
-            <a:off x="8302752" y="1993392"/>
-            <a:ext cx="2871216" cy="3877056"/>
+            <a:off x="8275320" y="1965960"/>
+            <a:ext cx="2926080" cy="3931920"/>
           </a:xfrm>
           <a:prstGeom prst="rect">
             <a:avLst/>
@@ -4157,7 +4156,7 @@
           <a:lstStyle/>
           <a:p>
             <a:pPr>
-              <a:defRPr sz="1900" b="1">
+              <a:defRPr sz="1800" b="1">
                 <a:solidFill>
                   <a:srgbClr val="4A6FA5"/>
                 </a:solidFill>
@@ -4165,15 +4164,34 @@
               </a:defRPr>
             </a:pPr>
             <a:r>
-              <a:t>Media &amp; Default Mode</a:t>
+              <a:t>Power Users &amp; Ergonomics</a:t>
             </a:r>
           </a:p>
           <a:p>
             <a:pPr>
               <a:spcBef>
-                <a:spcPts val="800"/>
+                <a:spcPts val="200"/>
               </a:spcBef>
-              <a:defRPr sz="1400">
+              <a:spcAft>
+                <a:spcPts val="400"/>
+              </a:spcAft>
+              <a:defRPr sz="1200" b="1">
+                <a:solidFill>
+                  <a:srgbClr val="8A8D93"/>
+                </a:solidFill>
+                <a:latin typeface="Segoe UI"/>
+              </a:defRPr>
+            </a:pPr>
+            <a:r>
+              <a:t>Workstation Operators &amp; Accessibility</a:t>
+            </a:r>
+          </a:p>
+          <a:p>
+            <a:pPr>
+              <a:spcBef>
+                <a:spcPts val="600"/>
+              </a:spcBef>
+              <a:defRPr sz="1300">
                 <a:solidFill>
                   <a:srgbClr val="F2EFE9"/>
                 </a:solidFill>
@@ -4181,15 +4199,15 @@
               </a:defRPr>
             </a:pPr>
             <a:r>
-              <a:t>• Targets: Spotify, YouTube, Netflix, Desktop.</a:t>
+              <a:t>• Profile: Multi-monitor developers, creative pros, and users managing RSI/carpal tunnel fatigue.</a:t>
             </a:r>
           </a:p>
           <a:p>
             <a:pPr>
               <a:spcBef>
-                <a:spcPts val="800"/>
+                <a:spcPts val="600"/>
               </a:spcBef>
-              <a:defRPr sz="1400">
+              <a:defRPr sz="1300">
                 <a:solidFill>
                   <a:srgbClr val="F2EFE9"/>
                 </a:solidFill>
@@ -4197,15 +4215,15 @@
               </a:defRPr>
             </a:pPr>
             <a:r>
-              <a:t>• Open Palm Hold: Smooth play/pause toggle.</a:t>
+              <a:t>• Pain Point: Constant Alt-Tab context switching to adjust media volume or tracks interrupts deep flow.</a:t>
             </a:r>
           </a:p>
           <a:p>
             <a:pPr>
               <a:spcBef>
-                <a:spcPts val="800"/>
+                <a:spcPts val="600"/>
               </a:spcBef>
-              <a:defRPr sz="1400">
+              <a:defRPr sz="1300">
                 <a:solidFill>
                   <a:srgbClr val="F2EFE9"/>
                 </a:solidFill>
@@ -4213,15 +4231,15 @@
               </a:defRPr>
             </a:pPr>
             <a:r>
-              <a:t>• Dynamic Vertical Pinch: Continuous master volume control with live capsule HUD updates.</a:t>
+              <a:t>• ZeroTouch Value: Frictionless spatial volume and media playback without stealing active keyboard focus.</a:t>
             </a:r>
           </a:p>
           <a:p>
             <a:pPr>
               <a:spcBef>
-                <a:spcPts val="800"/>
+                <a:spcPts val="600"/>
               </a:spcBef>
-              <a:defRPr sz="1400">
+              <a:defRPr sz="1300">
                 <a:solidFill>
                   <a:srgbClr val="F2EFE9"/>
                 </a:solidFill>
@@ -4229,7 +4247,7 @@
               </a:defRPr>
             </a:pPr>
             <a:r>
-              <a:t>• Back-of-Hand Swipe: Skip or previous track.</a:t>
+              <a:t>• Accessibility: Effortless micro-gestures reduce repetitive wrist and finger strain from mouse clutching.</a:t>
             </a:r>
           </a:p>
         </p:txBody>
@@ -4303,8 +4321,8 @@
         </p:nvSpPr>
         <p:spPr>
           <a:xfrm>
-            <a:off x="731520" y="411480"/>
-            <a:ext cx="10515600" cy="365760"/>
+            <a:off x="731520" y="502920"/>
+            <a:ext cx="10728655" cy="1005840"/>
           </a:xfrm>
           <a:prstGeom prst="rect">
             <a:avLst/>
@@ -4322,39 +4340,19 @@
                 <a:solidFill>
                   <a:srgbClr val="D4AF6A"/>
                 </a:solidFill>
-                <a:latin typeface="Segoe UI"/>
-              </a:defRPr>
-            </a:pPr>
-            <a:r>
-              <a:t>03 • COMPUTER VISION DEFENSE</a:t>
-            </a:r>
-          </a:p>
-        </p:txBody>
-      </p:sp>
-      <p:sp>
-        <p:nvSpPr>
-          <p:cNvPr id="4" name="TextBox 3"/>
-          <p:cNvSpPr txBox="1"/>
-          <p:nvPr/>
-        </p:nvSpPr>
-        <p:spPr>
-          <a:xfrm>
-            <a:off x="731520" y="731520"/>
-            <a:ext cx="10515600" cy="822960"/>
-          </a:xfrm>
-          <a:prstGeom prst="rect">
-            <a:avLst/>
-          </a:prstGeom>
-          <a:noFill/>
-        </p:spPr>
-        <p:txBody>
-          <a:bodyPr wrap="square">
-            <a:spAutoFit/>
-          </a:bodyPr>
-          <a:lstStyle/>
-          <a:p>
-            <a:pPr>
-              <a:defRPr sz="2800" b="1">
+                <a:latin typeface="Consolas"/>
+              </a:defRPr>
+            </a:pPr>
+            <a:r>
+              <a:t>03 • SPATIAL WORKFLOW</a:t>
+            </a:r>
+          </a:p>
+          <a:p>
+            <a:pPr>
+              <a:spcBef>
+                <a:spcPts val="400"/>
+              </a:spcBef>
+              <a:defRPr sz="2600" b="1">
                 <a:solidFill>
                   <a:srgbClr val="F2EFE9"/>
                 </a:solidFill>
@@ -4362,21 +4360,21 @@
               </a:defRPr>
             </a:pPr>
             <a:r>
-              <a:t>Noise Defense: How We Eliminated False Triggers</a:t>
-            </a:r>
-          </a:p>
-        </p:txBody>
-      </p:sp>
-      <p:sp>
-        <p:nvSpPr>
-          <p:cNvPr id="5" name="Rounded Rectangle 4"/>
+              <a:t>Context-Aware Architecture: One Engine, Three Modes</a:t>
+            </a:r>
+          </a:p>
+        </p:txBody>
+      </p:sp>
+      <p:sp>
+        <p:nvSpPr>
+          <p:cNvPr id="4" name="Rounded Rectangle 3"/>
           <p:cNvSpPr/>
           <p:nvPr/>
         </p:nvSpPr>
         <p:spPr>
           <a:xfrm>
             <a:off x="731520" y="1737360"/>
-            <a:ext cx="5120640" cy="2103120"/>
+            <a:ext cx="3383280" cy="4389120"/>
           </a:xfrm>
           <a:prstGeom prst="roundRect">
             <a:avLst/>
@@ -4414,14 +4412,14 @@
       </p:sp>
       <p:sp>
         <p:nvSpPr>
-          <p:cNvPr id="6" name="TextBox 5"/>
+          <p:cNvPr id="5" name="TextBox 4"/>
           <p:cNvSpPr txBox="1"/>
           <p:nvPr/>
         </p:nvSpPr>
         <p:spPr>
           <a:xfrm>
-            <a:off x="987552" y="1993392"/>
-            <a:ext cx="4608576" cy="1591056"/>
+            <a:off x="960120" y="1965960"/>
+            <a:ext cx="2926080" cy="3931920"/>
           </a:xfrm>
           <a:prstGeom prst="rect">
             <a:avLst/>
@@ -4435,7 +4433,7 @@
           <a:lstStyle/>
           <a:p>
             <a:pPr>
-              <a:defRPr sz="1900" b="1">
+              <a:defRPr sz="1800" b="1">
                 <a:solidFill>
                   <a:srgbClr val="D4AF6A"/>
                 </a:solidFill>
@@ -4443,15 +4441,15 @@
               </a:defRPr>
             </a:pPr>
             <a:r>
-              <a:t>Smart Activity Lockout (Type &amp; Click)</a:t>
+              <a:t>Presentation Mode</a:t>
             </a:r>
           </a:p>
           <a:p>
             <a:pPr>
               <a:spcBef>
-                <a:spcPts val="800"/>
+                <a:spcPts val="600"/>
               </a:spcBef>
-              <a:defRPr sz="1400">
+              <a:defRPr sz="1300">
                 <a:solidFill>
                   <a:srgbClr val="F2EFE9"/>
                 </a:solidFill>
@@ -4459,15 +4457,15 @@
               </a:defRPr>
             </a:pPr>
             <a:r>
-              <a:t>• Background hardware hooks (Pynput) detect keyboard typing and mouse clicks.</a:t>
+              <a:t>• Targets: PowerPoint, Google Slides, Keynote, PDF Reader.</a:t>
             </a:r>
           </a:p>
           <a:p>
             <a:pPr>
               <a:spcBef>
-                <a:spcPts val="800"/>
+                <a:spcPts val="600"/>
               </a:spcBef>
-              <a:defRPr sz="1400">
+              <a:defRPr sz="1300">
                 <a:solidFill>
                   <a:srgbClr val="F2EFE9"/>
                 </a:solidFill>
@@ -4475,21 +4473,53 @@
               </a:defRPr>
             </a:pPr>
             <a:r>
-              <a:t>• While typing or resting hands above the keyboard, gestures sleep for 1.8s.</a:t>
-            </a:r>
-          </a:p>
-        </p:txBody>
-      </p:sp>
-      <p:sp>
-        <p:nvSpPr>
-          <p:cNvPr id="7" name="Rounded Rectangle 6"/>
+              <a:t>• Back-of-Hand Swipe: Advance (Right) or return (Left) slides seamlessly across the room.</a:t>
+            </a:r>
+          </a:p>
+          <a:p>
+            <a:pPr>
+              <a:spcBef>
+                <a:spcPts val="600"/>
+              </a:spcBef>
+              <a:defRPr sz="1300">
+                <a:solidFill>
+                  <a:srgbClr val="F2EFE9"/>
+                </a:solidFill>
+                <a:latin typeface="Segoe UI"/>
+              </a:defRPr>
+            </a:pPr>
+            <a:r>
+              <a:t>• Open Palm Hold (0.5s): Blank/resume screen ('B').</a:t>
+            </a:r>
+          </a:p>
+          <a:p>
+            <a:pPr>
+              <a:spcBef>
+                <a:spcPts val="600"/>
+              </a:spcBef>
+              <a:defRPr sz="1300">
+                <a:solidFill>
+                  <a:srgbClr val="F2EFE9"/>
+                </a:solidFill>
+                <a:latin typeface="Segoe UI"/>
+              </a:defRPr>
+            </a:pPr>
+            <a:r>
+              <a:t>• Stage Optimization: Disengages desk gaze lockouts so presenters can look at audience or slides freely.</a:t>
+            </a:r>
+          </a:p>
+        </p:txBody>
+      </p:sp>
+      <p:sp>
+        <p:nvSpPr>
+          <p:cNvPr id="6" name="Rounded Rectangle 5"/>
           <p:cNvSpPr/>
           <p:nvPr/>
         </p:nvSpPr>
         <p:spPr>
           <a:xfrm>
-            <a:off x="731520" y="4069080"/>
-            <a:ext cx="5120640" cy="2103120"/>
+            <a:off x="4389120" y="1737360"/>
+            <a:ext cx="3383280" cy="4389120"/>
           </a:xfrm>
           <a:prstGeom prst="roundRect">
             <a:avLst/>
@@ -4527,14 +4557,14 @@
       </p:sp>
       <p:sp>
         <p:nvSpPr>
-          <p:cNvPr id="8" name="TextBox 7"/>
+          <p:cNvPr id="7" name="TextBox 6"/>
           <p:cNvSpPr txBox="1"/>
           <p:nvPr/>
         </p:nvSpPr>
         <p:spPr>
           <a:xfrm>
-            <a:off x="987552" y="4325112"/>
-            <a:ext cx="4608576" cy="1591056"/>
+            <a:off x="4617720" y="1965960"/>
+            <a:ext cx="2926080" cy="3931920"/>
           </a:xfrm>
           <a:prstGeom prst="rect">
             <a:avLst/>
@@ -4548,7 +4578,7 @@
           <a:lstStyle/>
           <a:p>
             <a:pPr>
-              <a:defRPr sz="1900" b="1">
+              <a:defRPr sz="1800" b="1">
                 <a:solidFill>
                   <a:srgbClr val="F2EFE9"/>
                 </a:solidFill>
@@ -4556,15 +4586,15 @@
               </a:defRPr>
             </a:pPr>
             <a:r>
-              <a:t>Gaze-Clutch (Look-to-Control)</a:t>
+              <a:t>Video Meeting Mode</a:t>
             </a:r>
           </a:p>
           <a:p>
             <a:pPr>
               <a:spcBef>
-                <a:spcPts val="800"/>
+                <a:spcPts val="600"/>
               </a:spcBef>
-              <a:defRPr sz="1400">
+              <a:defRPr sz="1300">
                 <a:solidFill>
                   <a:srgbClr val="F2EFE9"/>
                 </a:solidFill>
@@ -4572,15 +4602,15 @@
               </a:defRPr>
             </a:pPr>
             <a:r>
-              <a:t>• Real-time 3D head yaw and pupillary distance tracking.</a:t>
+              <a:t>• Targets: Google Meet, Zoom, MS Teams, Webex.</a:t>
             </a:r>
           </a:p>
           <a:p>
             <a:pPr>
               <a:spcBef>
-                <a:spcPts val="800"/>
+                <a:spcPts val="600"/>
               </a:spcBef>
-              <a:defRPr sz="1400">
+              <a:defRPr sz="1300">
                 <a:solidFill>
                   <a:srgbClr val="F2EFE9"/>
                 </a:solidFill>
@@ -4588,21 +4618,53 @@
               </a:defRPr>
             </a:pPr>
             <a:r>
-              <a:t>• Glancing away at another screen automatically clutches gestures to standby.</a:t>
-            </a:r>
-          </a:p>
-        </p:txBody>
-      </p:sp>
-      <p:sp>
-        <p:nvSpPr>
-          <p:cNvPr id="9" name="Rounded Rectangle 8"/>
+              <a:t>• Ghost-Mute (Shh): Index finger to mouth directly toggles hardware mic via Windows Core Audio + in-app sync.</a:t>
+            </a:r>
+          </a:p>
+          <a:p>
+            <a:pPr>
+              <a:spcBef>
+                <a:spcPts val="600"/>
+              </a:spcBef>
+              <a:defRPr sz="1300">
+                <a:solidFill>
+                  <a:srgbClr val="F2EFE9"/>
+                </a:solidFill>
+                <a:latin typeface="Segoe UI"/>
+              </a:defRPr>
+            </a:pPr>
+            <a:r>
+              <a:t>• Open Palm Hold: Instant camera toggle (Ctrl+E in Meet, Ctrl+Shift+O in Teams, Alt+V in Zoom).</a:t>
+            </a:r>
+          </a:p>
+          <a:p>
+            <a:pPr>
+              <a:spcBef>
+                <a:spcPts val="600"/>
+              </a:spcBef>
+              <a:defRPr sz="1300">
+                <a:solidFill>
+                  <a:srgbClr val="F2EFE9"/>
+                </a:solidFill>
+                <a:latin typeface="Segoe UI"/>
+              </a:defRPr>
+            </a:pPr>
+            <a:r>
+              <a:t>• Back-of-Hand Swipe: Toggle People panel or Raise/Lower Hand without clicking.</a:t>
+            </a:r>
+          </a:p>
+        </p:txBody>
+      </p:sp>
+      <p:sp>
+        <p:nvSpPr>
+          <p:cNvPr id="8" name="Rounded Rectangle 7"/>
           <p:cNvSpPr/>
           <p:nvPr/>
         </p:nvSpPr>
         <p:spPr>
           <a:xfrm>
-            <a:off x="6217920" y="1737360"/>
-            <a:ext cx="5212080" cy="2103120"/>
+            <a:off x="8046720" y="1737360"/>
+            <a:ext cx="3383280" cy="4389120"/>
           </a:xfrm>
           <a:prstGeom prst="roundRect">
             <a:avLst/>
@@ -4640,14 +4702,14 @@
       </p:sp>
       <p:sp>
         <p:nvSpPr>
-          <p:cNvPr id="10" name="TextBox 9"/>
+          <p:cNvPr id="9" name="TextBox 8"/>
           <p:cNvSpPr txBox="1"/>
           <p:nvPr/>
         </p:nvSpPr>
         <p:spPr>
           <a:xfrm>
-            <a:off x="6473952" y="1993392"/>
-            <a:ext cx="4700016" cy="1591056"/>
+            <a:off x="8275320" y="1965960"/>
+            <a:ext cx="2926080" cy="3931920"/>
           </a:xfrm>
           <a:prstGeom prst="rect">
             <a:avLst/>
@@ -4661,7 +4723,7 @@
           <a:lstStyle/>
           <a:p>
             <a:pPr>
-              <a:defRPr sz="1900" b="1">
+              <a:defRPr sz="1800" b="1">
                 <a:solidFill>
                   <a:srgbClr val="4A6FA5"/>
                 </a:solidFill>
@@ -4669,15 +4731,15 @@
               </a:defRPr>
             </a:pPr>
             <a:r>
-              <a:t>ShoulderGuard Intruder Shield</a:t>
+              <a:t>Media &amp; Default Mode</a:t>
             </a:r>
           </a:p>
           <a:p>
             <a:pPr>
               <a:spcBef>
-                <a:spcPts val="800"/>
+                <a:spcPts val="600"/>
               </a:spcBef>
-              <a:defRPr sz="1400">
+              <a:defRPr sz="1300">
                 <a:solidFill>
                   <a:srgbClr val="F2EFE9"/>
                 </a:solidFill>
@@ -4685,15 +4747,15 @@
               </a:defRPr>
             </a:pPr>
             <a:r>
-              <a:t>• Continuous BlazeFace scan monitors for shoulder surfers in public spaces.</a:t>
+              <a:t>• Targets: Spotify, YouTube, Netflix, Desktop.</a:t>
             </a:r>
           </a:p>
           <a:p>
             <a:pPr>
               <a:spcBef>
-                <a:spcPts val="800"/>
+                <a:spcPts val="600"/>
               </a:spcBef>
-              <a:defRPr sz="1400">
+              <a:defRPr sz="1300">
                 <a:solidFill>
                   <a:srgbClr val="F2EFE9"/>
                 </a:solidFill>
@@ -4701,96 +4763,15 @@
               </a:defRPr>
             </a:pPr>
             <a:r>
-              <a:t>• If a second face appears behind you, automatically fires Win+D to protect sensitive work.</a:t>
-            </a:r>
-          </a:p>
-        </p:txBody>
-      </p:sp>
-      <p:sp>
-        <p:nvSpPr>
-          <p:cNvPr id="11" name="Rounded Rectangle 10"/>
-          <p:cNvSpPr/>
-          <p:nvPr/>
-        </p:nvSpPr>
-        <p:spPr>
-          <a:xfrm>
-            <a:off x="6217920" y="4069080"/>
-            <a:ext cx="5212080" cy="2103120"/>
-          </a:xfrm>
-          <a:prstGeom prst="roundRect">
-            <a:avLst/>
-          </a:prstGeom>
-          <a:solidFill>
-            <a:srgbClr val="181820"/>
-          </a:solidFill>
-          <a:ln w="12700">
-            <a:solidFill>
-              <a:srgbClr val="D4AF6A"/>
-            </a:solidFill>
-          </a:ln>
-        </p:spPr>
-        <p:style>
-          <a:lnRef idx="1">
-            <a:schemeClr val="accent1"/>
-          </a:lnRef>
-          <a:fillRef idx="3">
-            <a:schemeClr val="accent1"/>
-          </a:fillRef>
-          <a:effectRef idx="2">
-            <a:schemeClr val="accent1"/>
-          </a:effectRef>
-          <a:fontRef idx="minor">
-            <a:schemeClr val="lt1"/>
-          </a:fontRef>
-        </p:style>
-        <p:txBody>
-          <a:bodyPr rtlCol="0" anchor="ctr"/>
-          <a:lstStyle/>
-          <a:p>
-            <a:pPr algn="ctr"/>
-          </a:p>
-        </p:txBody>
-      </p:sp>
-      <p:sp>
-        <p:nvSpPr>
-          <p:cNvPr id="12" name="TextBox 11"/>
-          <p:cNvSpPr txBox="1"/>
-          <p:nvPr/>
-        </p:nvSpPr>
-        <p:spPr>
-          <a:xfrm>
-            <a:off x="6473952" y="4325112"/>
-            <a:ext cx="4700016" cy="1591056"/>
-          </a:xfrm>
-          <a:prstGeom prst="rect">
-            <a:avLst/>
-          </a:prstGeom>
-          <a:noFill/>
-        </p:spPr>
-        <p:txBody>
-          <a:bodyPr wrap="square">
-            <a:spAutoFit/>
-          </a:bodyPr>
-          <a:lstStyle/>
-          <a:p>
-            <a:pPr>
-              <a:defRPr sz="1900" b="1">
-                <a:solidFill>
-                  <a:srgbClr val="D4AF6A"/>
-                </a:solidFill>
-                <a:latin typeface="Segoe UI"/>
-              </a:defRPr>
-            </a:pPr>
-            <a:r>
-              <a:t>Body Ownership &amp; Anti-Jitter Physics</a:t>
+              <a:t>• Open Palm Hold: Smooth play/pause toggle.</a:t>
             </a:r>
           </a:p>
           <a:p>
             <a:pPr>
               <a:spcBef>
-                <a:spcPts val="800"/>
+                <a:spcPts val="600"/>
               </a:spcBef>
-              <a:defRPr sz="1400">
+              <a:defRPr sz="1300">
                 <a:solidFill>
                   <a:srgbClr val="F2EFE9"/>
                 </a:solidFill>
@@ -4798,15 +4779,15 @@
               </a:defRPr>
             </a:pPr>
             <a:r>
-              <a:t>• Calculates Euclidean distance between wrist and face; rejects passerby hands.</a:t>
+              <a:t>• Dynamic Vertical Pinch: Continuous master volume control with live capsule HUD updates.</a:t>
             </a:r>
           </a:p>
           <a:p>
             <a:pPr>
               <a:spcBef>
-                <a:spcPts val="800"/>
+                <a:spcPts val="600"/>
               </a:spcBef>
-              <a:defRPr sz="1400">
+              <a:defRPr sz="1300">
                 <a:solidFill>
                   <a:srgbClr val="F2EFE9"/>
                 </a:solidFill>
@@ -4814,7 +4795,7 @@
               </a:defRPr>
             </a:pPr>
             <a:r>
-              <a:t>• Bone length stability and acceleration checks freeze hallucinated hand joints.</a:t>
+              <a:t>• Back-of-Hand Swipe: Skip or previous track.</a:t>
             </a:r>
           </a:p>
         </p:txBody>
@@ -4888,8 +4869,8 @@
         </p:nvSpPr>
         <p:spPr>
           <a:xfrm>
-            <a:off x="731520" y="411480"/>
-            <a:ext cx="10515600" cy="365760"/>
+            <a:off x="731520" y="502920"/>
+            <a:ext cx="10728655" cy="1005840"/>
           </a:xfrm>
           <a:prstGeom prst="rect">
             <a:avLst/>
@@ -4907,39 +4888,19 @@
                 <a:solidFill>
                   <a:srgbClr val="D4AF6A"/>
                 </a:solidFill>
-                <a:latin typeface="Segoe UI"/>
-              </a:defRPr>
-            </a:pPr>
-            <a:r>
-              <a:t>04 • ARCHITECTURE &amp; SUMMARY</a:t>
-            </a:r>
-          </a:p>
-        </p:txBody>
-      </p:sp>
-      <p:sp>
-        <p:nvSpPr>
-          <p:cNvPr id="4" name="TextBox 3"/>
-          <p:cNvSpPr txBox="1"/>
-          <p:nvPr/>
-        </p:nvSpPr>
-        <p:spPr>
-          <a:xfrm>
-            <a:off x="731520" y="731520"/>
-            <a:ext cx="10515600" cy="822960"/>
-          </a:xfrm>
-          <a:prstGeom prst="rect">
-            <a:avLst/>
-          </a:prstGeom>
-          <a:noFill/>
-        </p:spPr>
-        <p:txBody>
-          <a:bodyPr wrap="square">
-            <a:spAutoFit/>
-          </a:bodyPr>
-          <a:lstStyle/>
-          <a:p>
-            <a:pPr>
-              <a:defRPr sz="2800" b="1">
+                <a:latin typeface="Consolas"/>
+              </a:defRPr>
+            </a:pPr>
+            <a:r>
+              <a:t>04 • COMPUTER VISION DEFENSE</a:t>
+            </a:r>
+          </a:p>
+          <a:p>
+            <a:pPr>
+              <a:spcBef>
+                <a:spcPts val="400"/>
+              </a:spcBef>
+              <a:defRPr sz="2600" b="1">
                 <a:solidFill>
                   <a:srgbClr val="F2EFE9"/>
                 </a:solidFill>
@@ -4947,21 +4908,21 @@
               </a:defRPr>
             </a:pPr>
             <a:r>
-              <a:t>Technical Architecture &amp; Hackathon Wrap-Up</a:t>
-            </a:r>
-          </a:p>
-        </p:txBody>
-      </p:sp>
-      <p:sp>
-        <p:nvSpPr>
-          <p:cNvPr id="5" name="Rounded Rectangle 4"/>
+              <a:t>Noise Defense: How We Eliminated False Triggers</a:t>
+            </a:r>
+          </a:p>
+        </p:txBody>
+      </p:sp>
+      <p:sp>
+        <p:nvSpPr>
+          <p:cNvPr id="4" name="Rounded Rectangle 3"/>
           <p:cNvSpPr/>
           <p:nvPr/>
         </p:nvSpPr>
         <p:spPr>
           <a:xfrm>
             <a:off x="731520" y="1737360"/>
-            <a:ext cx="5120640" cy="4389120"/>
+            <a:ext cx="5120640" cy="2103120"/>
           </a:xfrm>
           <a:prstGeom prst="roundRect">
             <a:avLst/>
@@ -4971,7 +4932,7 @@
           </a:solidFill>
           <a:ln w="12700">
             <a:solidFill>
-              <a:srgbClr val="4A6FA5"/>
+              <a:srgbClr val="D4AF6A"/>
             </a:solidFill>
           </a:ln>
         </p:spPr>
@@ -4999,14 +4960,14 @@
       </p:sp>
       <p:sp>
         <p:nvSpPr>
-          <p:cNvPr id="6" name="TextBox 5"/>
+          <p:cNvPr id="5" name="TextBox 4"/>
           <p:cNvSpPr txBox="1"/>
           <p:nvPr/>
         </p:nvSpPr>
         <p:spPr>
           <a:xfrm>
-            <a:off x="987552" y="1993392"/>
-            <a:ext cx="4608576" cy="3877056"/>
+            <a:off x="960120" y="1965960"/>
+            <a:ext cx="4663440" cy="1645920"/>
           </a:xfrm>
           <a:prstGeom prst="rect">
             <a:avLst/>
@@ -5020,23 +4981,23 @@
           <a:lstStyle/>
           <a:p>
             <a:pPr>
-              <a:defRPr sz="1900" b="1">
-                <a:solidFill>
-                  <a:srgbClr val="4A6FA5"/>
-                </a:solidFill>
-                <a:latin typeface="Segoe UI"/>
-              </a:defRPr>
-            </a:pPr>
-            <a:r>
-              <a:t>High-Performance System Architecture</a:t>
+              <a:defRPr sz="1800" b="1">
+                <a:solidFill>
+                  <a:srgbClr val="D4AF6A"/>
+                </a:solidFill>
+                <a:latin typeface="Segoe UI"/>
+              </a:defRPr>
+            </a:pPr>
+            <a:r>
+              <a:t>Smart Activity Lockout (Type &amp; Click)</a:t>
             </a:r>
           </a:p>
           <a:p>
             <a:pPr>
               <a:spcBef>
-                <a:spcPts val="800"/>
+                <a:spcPts val="600"/>
               </a:spcBef>
-              <a:defRPr sz="1400">
+              <a:defRPr sz="1300">
                 <a:solidFill>
                   <a:srgbClr val="F2EFE9"/>
                 </a:solidFill>
@@ -5044,15 +5005,15 @@
               </a:defRPr>
             </a:pPr>
             <a:r>
-              <a:t>• Shared Memory IPC: Zero-copy multiprocessing.shared_memory streams 30 FPS telemetry and previews to GUI.</a:t>
+              <a:t>• Background hardware hooks (Pynput) detect keyboard typing and mouse clicks.</a:t>
             </a:r>
           </a:p>
           <a:p>
             <a:pPr>
               <a:spcBef>
-                <a:spcPts val="800"/>
+                <a:spcPts val="600"/>
               </a:spcBef>
-              <a:defRPr sz="1400">
+              <a:defRPr sz="1300">
                 <a:solidFill>
                   <a:srgbClr val="F2EFE9"/>
                 </a:solidFill>
@@ -5060,53 +5021,21 @@
               </a:defRPr>
             </a:pPr>
             <a:r>
-              <a:t>• Hardware Audio Hook: Direct Windows Core Audio (Pycaw) input endpoint volume control.</a:t>
-            </a:r>
-          </a:p>
-          <a:p>
-            <a:pPr>
-              <a:spcBef>
-                <a:spcPts val="800"/>
-              </a:spcBef>
-              <a:defRPr sz="1400">
-                <a:solidFill>
-                  <a:srgbClr val="F2EFE9"/>
-                </a:solidFill>
-                <a:latin typeface="Segoe UI"/>
-              </a:defRPr>
-            </a:pPr>
-            <a:r>
-              <a:t>• Windows Camera Frame Server: OpenCV MSMF backend hooks svchost.exe -k Camera for native multi-app streaming.</a:t>
-            </a:r>
-          </a:p>
-          <a:p>
-            <a:pPr>
-              <a:spcBef>
-                <a:spcPts val="800"/>
-              </a:spcBef>
-              <a:defRPr sz="1400">
-                <a:solidFill>
-                  <a:srgbClr val="F2EFE9"/>
-                </a:solidFill>
-                <a:latin typeface="Segoe UI"/>
-              </a:defRPr>
-            </a:pPr>
-            <a:r>
-              <a:t>• Ambient HUD: CustomTkinter executive dashboard + topmost micro-pill Floating Capsule.</a:t>
-            </a:r>
-          </a:p>
-        </p:txBody>
-      </p:sp>
-      <p:sp>
-        <p:nvSpPr>
-          <p:cNvPr id="7" name="Rounded Rectangle 6"/>
+              <a:t>• While typing or resting hands above keyboard, gestures sleep to prevent false firing.</a:t>
+            </a:r>
+          </a:p>
+        </p:txBody>
+      </p:sp>
+      <p:sp>
+        <p:nvSpPr>
+          <p:cNvPr id="6" name="Rounded Rectangle 5"/>
           <p:cNvSpPr/>
           <p:nvPr/>
         </p:nvSpPr>
         <p:spPr>
           <a:xfrm>
-            <a:off x="6217920" y="1737360"/>
-            <a:ext cx="5212080" cy="4389120"/>
+            <a:off x="731520" y="4069080"/>
+            <a:ext cx="5120640" cy="2103120"/>
           </a:xfrm>
           <a:prstGeom prst="roundRect">
             <a:avLst/>
@@ -5116,7 +5045,7 @@
           </a:solidFill>
           <a:ln w="12700">
             <a:solidFill>
-              <a:srgbClr val="D4AF6A"/>
+              <a:srgbClr val="F2EFE9"/>
             </a:solidFill>
           </a:ln>
         </p:spPr>
@@ -5144,14 +5073,14 @@
       </p:sp>
       <p:sp>
         <p:nvSpPr>
-          <p:cNvPr id="8" name="TextBox 7"/>
+          <p:cNvPr id="7" name="TextBox 6"/>
           <p:cNvSpPr txBox="1"/>
           <p:nvPr/>
         </p:nvSpPr>
         <p:spPr>
           <a:xfrm>
-            <a:off x="6473952" y="1993392"/>
-            <a:ext cx="4700016" cy="3877056"/>
+            <a:off x="960120" y="4297680"/>
+            <a:ext cx="4663440" cy="1645920"/>
           </a:xfrm>
           <a:prstGeom prst="rect">
             <a:avLst/>
@@ -5165,7 +5094,233 @@
           <a:lstStyle/>
           <a:p>
             <a:pPr>
-              <a:defRPr sz="1900" b="1">
+              <a:defRPr sz="1800" b="1">
+                <a:solidFill>
+                  <a:srgbClr val="F2EFE9"/>
+                </a:solidFill>
+                <a:latin typeface="Segoe UI"/>
+              </a:defRPr>
+            </a:pPr>
+            <a:r>
+              <a:t>Gaze-Clutch (Look-to-Control)</a:t>
+            </a:r>
+          </a:p>
+          <a:p>
+            <a:pPr>
+              <a:spcBef>
+                <a:spcPts val="600"/>
+              </a:spcBef>
+              <a:defRPr sz="1300">
+                <a:solidFill>
+                  <a:srgbClr val="F2EFE9"/>
+                </a:solidFill>
+                <a:latin typeface="Segoe UI"/>
+              </a:defRPr>
+            </a:pPr>
+            <a:r>
+              <a:t>• Real-time 3D head yaw and pupillary distance tracking.</a:t>
+            </a:r>
+          </a:p>
+          <a:p>
+            <a:pPr>
+              <a:spcBef>
+                <a:spcPts val="600"/>
+              </a:spcBef>
+              <a:defRPr sz="1300">
+                <a:solidFill>
+                  <a:srgbClr val="F2EFE9"/>
+                </a:solidFill>
+                <a:latin typeface="Segoe UI"/>
+              </a:defRPr>
+            </a:pPr>
+            <a:r>
+              <a:t>• Glancing away at another screen automatically clutches gestures to standby.</a:t>
+            </a:r>
+          </a:p>
+        </p:txBody>
+      </p:sp>
+      <p:sp>
+        <p:nvSpPr>
+          <p:cNvPr id="8" name="Rounded Rectangle 7"/>
+          <p:cNvSpPr/>
+          <p:nvPr/>
+        </p:nvSpPr>
+        <p:spPr>
+          <a:xfrm>
+            <a:off x="6217920" y="1737360"/>
+            <a:ext cx="5212080" cy="2103120"/>
+          </a:xfrm>
+          <a:prstGeom prst="roundRect">
+            <a:avLst/>
+          </a:prstGeom>
+          <a:solidFill>
+            <a:srgbClr val="181820"/>
+          </a:solidFill>
+          <a:ln w="12700">
+            <a:solidFill>
+              <a:srgbClr val="4A6FA5"/>
+            </a:solidFill>
+          </a:ln>
+        </p:spPr>
+        <p:style>
+          <a:lnRef idx="1">
+            <a:schemeClr val="accent1"/>
+          </a:lnRef>
+          <a:fillRef idx="3">
+            <a:schemeClr val="accent1"/>
+          </a:fillRef>
+          <a:effectRef idx="2">
+            <a:schemeClr val="accent1"/>
+          </a:effectRef>
+          <a:fontRef idx="minor">
+            <a:schemeClr val="lt1"/>
+          </a:fontRef>
+        </p:style>
+        <p:txBody>
+          <a:bodyPr rtlCol="0" anchor="ctr"/>
+          <a:lstStyle/>
+          <a:p>
+            <a:pPr algn="ctr"/>
+          </a:p>
+        </p:txBody>
+      </p:sp>
+      <p:sp>
+        <p:nvSpPr>
+          <p:cNvPr id="9" name="TextBox 8"/>
+          <p:cNvSpPr txBox="1"/>
+          <p:nvPr/>
+        </p:nvSpPr>
+        <p:spPr>
+          <a:xfrm>
+            <a:off x="6446520" y="1965960"/>
+            <a:ext cx="4754880" cy="1645920"/>
+          </a:xfrm>
+          <a:prstGeom prst="rect">
+            <a:avLst/>
+          </a:prstGeom>
+          <a:noFill/>
+        </p:spPr>
+        <p:txBody>
+          <a:bodyPr wrap="square">
+            <a:spAutoFit/>
+          </a:bodyPr>
+          <a:lstStyle/>
+          <a:p>
+            <a:pPr>
+              <a:defRPr sz="1800" b="1">
+                <a:solidFill>
+                  <a:srgbClr val="4A6FA5"/>
+                </a:solidFill>
+                <a:latin typeface="Segoe UI"/>
+              </a:defRPr>
+            </a:pPr>
+            <a:r>
+              <a:t>ShoulderGuard Intruder Shield</a:t>
+            </a:r>
+          </a:p>
+          <a:p>
+            <a:pPr>
+              <a:spcBef>
+                <a:spcPts val="600"/>
+              </a:spcBef>
+              <a:defRPr sz="1300">
+                <a:solidFill>
+                  <a:srgbClr val="F2EFE9"/>
+                </a:solidFill>
+                <a:latin typeface="Segoe UI"/>
+              </a:defRPr>
+            </a:pPr>
+            <a:r>
+              <a:t>• Continuous BlazeFace scan monitors for shoulder surfers in public spaces.</a:t>
+            </a:r>
+          </a:p>
+          <a:p>
+            <a:pPr>
+              <a:spcBef>
+                <a:spcPts val="600"/>
+              </a:spcBef>
+              <a:defRPr sz="1300">
+                <a:solidFill>
+                  <a:srgbClr val="F2EFE9"/>
+                </a:solidFill>
+                <a:latin typeface="Segoe UI"/>
+              </a:defRPr>
+            </a:pPr>
+            <a:r>
+              <a:t>• If a second face appears behind you, automatically fires Win+D to protect sensitive work.</a:t>
+            </a:r>
+          </a:p>
+        </p:txBody>
+      </p:sp>
+      <p:sp>
+        <p:nvSpPr>
+          <p:cNvPr id="10" name="Rounded Rectangle 9"/>
+          <p:cNvSpPr/>
+          <p:nvPr/>
+        </p:nvSpPr>
+        <p:spPr>
+          <a:xfrm>
+            <a:off x="6217920" y="4069080"/>
+            <a:ext cx="5212080" cy="2103120"/>
+          </a:xfrm>
+          <a:prstGeom prst="roundRect">
+            <a:avLst/>
+          </a:prstGeom>
+          <a:solidFill>
+            <a:srgbClr val="181820"/>
+          </a:solidFill>
+          <a:ln w="12700">
+            <a:solidFill>
+              <a:srgbClr val="D4AF6A"/>
+            </a:solidFill>
+          </a:ln>
+        </p:spPr>
+        <p:style>
+          <a:lnRef idx="1">
+            <a:schemeClr val="accent1"/>
+          </a:lnRef>
+          <a:fillRef idx="3">
+            <a:schemeClr val="accent1"/>
+          </a:fillRef>
+          <a:effectRef idx="2">
+            <a:schemeClr val="accent1"/>
+          </a:effectRef>
+          <a:fontRef idx="minor">
+            <a:schemeClr val="lt1"/>
+          </a:fontRef>
+        </p:style>
+        <p:txBody>
+          <a:bodyPr rtlCol="0" anchor="ctr"/>
+          <a:lstStyle/>
+          <a:p>
+            <a:pPr algn="ctr"/>
+          </a:p>
+        </p:txBody>
+      </p:sp>
+      <p:sp>
+        <p:nvSpPr>
+          <p:cNvPr id="11" name="TextBox 10"/>
+          <p:cNvSpPr txBox="1"/>
+          <p:nvPr/>
+        </p:nvSpPr>
+        <p:spPr>
+          <a:xfrm>
+            <a:off x="6446520" y="4297680"/>
+            <a:ext cx="4754880" cy="1645920"/>
+          </a:xfrm>
+          <a:prstGeom prst="rect">
+            <a:avLst/>
+          </a:prstGeom>
+          <a:noFill/>
+        </p:spPr>
+        <p:txBody>
+          <a:bodyPr wrap="square">
+            <a:spAutoFit/>
+          </a:bodyPr>
+          <a:lstStyle/>
+          <a:p>
+            <a:pPr>
+              <a:defRPr sz="1800" b="1">
                 <a:solidFill>
                   <a:srgbClr val="D4AF6A"/>
                 </a:solidFill>
@@ -5173,15 +5328,386 @@
               </a:defRPr>
             </a:pPr>
             <a:r>
+              <a:t>Body Ownership &amp; Anti-Jitter Physics</a:t>
+            </a:r>
+          </a:p>
+          <a:p>
+            <a:pPr>
+              <a:spcBef>
+                <a:spcPts val="600"/>
+              </a:spcBef>
+              <a:defRPr sz="1300">
+                <a:solidFill>
+                  <a:srgbClr val="F2EFE9"/>
+                </a:solidFill>
+                <a:latin typeface="Segoe UI"/>
+              </a:defRPr>
+            </a:pPr>
+            <a:r>
+              <a:t>• Calculates Euclidean distance between wrist and face; rejects passerby hands.</a:t>
+            </a:r>
+          </a:p>
+          <a:p>
+            <a:pPr>
+              <a:spcBef>
+                <a:spcPts val="600"/>
+              </a:spcBef>
+              <a:defRPr sz="1300">
+                <a:solidFill>
+                  <a:srgbClr val="F2EFE9"/>
+                </a:solidFill>
+                <a:latin typeface="Segoe UI"/>
+              </a:defRPr>
+            </a:pPr>
+            <a:r>
+              <a:t>• Bone length stability and acceleration checks freeze hallucinated hand joints.</a:t>
+            </a:r>
+          </a:p>
+        </p:txBody>
+      </p:sp>
+    </p:spTree>
+  </p:cSld>
+  <p:clrMapOvr>
+    <a:masterClrMapping/>
+  </p:clrMapOvr>
+</p:sld>
+</file>
+
+<file path=ppt/slides/slide6.xml><?xml version="1.0" encoding="utf-8"?>
+<p:sld xmlns:a="http://schemas.openxmlformats.org/drawingml/2006/main" xmlns:p="http://schemas.openxmlformats.org/presentationml/2006/main" xmlns:r="http://schemas.openxmlformats.org/officeDocument/2006/relationships">
+  <p:cSld>
+    <p:spTree>
+      <p:nvGrpSpPr>
+        <p:cNvPr id="1" name=""/>
+        <p:cNvGrpSpPr/>
+        <p:nvPr/>
+      </p:nvGrpSpPr>
+      <p:grpSpPr/>
+      <p:sp>
+        <p:nvSpPr>
+          <p:cNvPr id="2" name="Rectangle 1"/>
+          <p:cNvSpPr/>
+          <p:nvPr/>
+        </p:nvSpPr>
+        <p:spPr>
+          <a:xfrm>
+            <a:off x="0" y="0"/>
+            <a:ext cx="12191695" cy="6858000"/>
+          </a:xfrm>
+          <a:prstGeom prst="rect">
+            <a:avLst/>
+          </a:prstGeom>
+          <a:solidFill>
+            <a:srgbClr val="0F0F14"/>
+          </a:solidFill>
+          <a:ln>
+            <a:noFill/>
+          </a:ln>
+        </p:spPr>
+        <p:style>
+          <a:lnRef idx="1">
+            <a:schemeClr val="accent1"/>
+          </a:lnRef>
+          <a:fillRef idx="3">
+            <a:schemeClr val="accent1"/>
+          </a:fillRef>
+          <a:effectRef idx="2">
+            <a:schemeClr val="accent1"/>
+          </a:effectRef>
+          <a:fontRef idx="minor">
+            <a:schemeClr val="lt1"/>
+          </a:fontRef>
+        </p:style>
+        <p:txBody>
+          <a:bodyPr rtlCol="0" anchor="ctr"/>
+          <a:lstStyle/>
+          <a:p>
+            <a:pPr algn="ctr"/>
+          </a:p>
+        </p:txBody>
+      </p:sp>
+      <p:sp>
+        <p:nvSpPr>
+          <p:cNvPr id="3" name="TextBox 2"/>
+          <p:cNvSpPr txBox="1"/>
+          <p:nvPr/>
+        </p:nvSpPr>
+        <p:spPr>
+          <a:xfrm>
+            <a:off x="731520" y="502920"/>
+            <a:ext cx="10728655" cy="1005840"/>
+          </a:xfrm>
+          <a:prstGeom prst="rect">
+            <a:avLst/>
+          </a:prstGeom>
+          <a:noFill/>
+        </p:spPr>
+        <p:txBody>
+          <a:bodyPr wrap="square">
+            <a:spAutoFit/>
+          </a:bodyPr>
+          <a:lstStyle/>
+          <a:p>
+            <a:pPr>
+              <a:defRPr sz="1100" b="1">
+                <a:solidFill>
+                  <a:srgbClr val="D4AF6A"/>
+                </a:solidFill>
+                <a:latin typeface="Consolas"/>
+              </a:defRPr>
+            </a:pPr>
+            <a:r>
+              <a:t>05 • ARCHITECTURE &amp; SUMMARY</a:t>
+            </a:r>
+          </a:p>
+          <a:p>
+            <a:pPr>
+              <a:spcBef>
+                <a:spcPts val="400"/>
+              </a:spcBef>
+              <a:defRPr sz="2600" b="1">
+                <a:solidFill>
+                  <a:srgbClr val="F2EFE9"/>
+                </a:solidFill>
+                <a:latin typeface="Georgia"/>
+              </a:defRPr>
+            </a:pPr>
+            <a:r>
+              <a:t>Technical Architecture &amp; Hackathon Wrap-Up</a:t>
+            </a:r>
+          </a:p>
+        </p:txBody>
+      </p:sp>
+      <p:sp>
+        <p:nvSpPr>
+          <p:cNvPr id="4" name="Rounded Rectangle 3"/>
+          <p:cNvSpPr/>
+          <p:nvPr/>
+        </p:nvSpPr>
+        <p:spPr>
+          <a:xfrm>
+            <a:off x="731520" y="1737360"/>
+            <a:ext cx="5120640" cy="4389120"/>
+          </a:xfrm>
+          <a:prstGeom prst="roundRect">
+            <a:avLst/>
+          </a:prstGeom>
+          <a:solidFill>
+            <a:srgbClr val="181820"/>
+          </a:solidFill>
+          <a:ln w="12700">
+            <a:solidFill>
+              <a:srgbClr val="4A6FA5"/>
+            </a:solidFill>
+          </a:ln>
+        </p:spPr>
+        <p:style>
+          <a:lnRef idx="1">
+            <a:schemeClr val="accent1"/>
+          </a:lnRef>
+          <a:fillRef idx="3">
+            <a:schemeClr val="accent1"/>
+          </a:fillRef>
+          <a:effectRef idx="2">
+            <a:schemeClr val="accent1"/>
+          </a:effectRef>
+          <a:fontRef idx="minor">
+            <a:schemeClr val="lt1"/>
+          </a:fontRef>
+        </p:style>
+        <p:txBody>
+          <a:bodyPr rtlCol="0" anchor="ctr"/>
+          <a:lstStyle/>
+          <a:p>
+            <a:pPr algn="ctr"/>
+          </a:p>
+        </p:txBody>
+      </p:sp>
+      <p:sp>
+        <p:nvSpPr>
+          <p:cNvPr id="5" name="TextBox 4"/>
+          <p:cNvSpPr txBox="1"/>
+          <p:nvPr/>
+        </p:nvSpPr>
+        <p:spPr>
+          <a:xfrm>
+            <a:off x="960120" y="1965960"/>
+            <a:ext cx="4663440" cy="3931920"/>
+          </a:xfrm>
+          <a:prstGeom prst="rect">
+            <a:avLst/>
+          </a:prstGeom>
+          <a:noFill/>
+        </p:spPr>
+        <p:txBody>
+          <a:bodyPr wrap="square">
+            <a:spAutoFit/>
+          </a:bodyPr>
+          <a:lstStyle/>
+          <a:p>
+            <a:pPr>
+              <a:defRPr sz="1800" b="1">
+                <a:solidFill>
+                  <a:srgbClr val="4A6FA5"/>
+                </a:solidFill>
+                <a:latin typeface="Segoe UI"/>
+              </a:defRPr>
+            </a:pPr>
+            <a:r>
+              <a:t>High-Performance System Architecture</a:t>
+            </a:r>
+          </a:p>
+          <a:p>
+            <a:pPr>
+              <a:spcBef>
+                <a:spcPts val="600"/>
+              </a:spcBef>
+              <a:defRPr sz="1300">
+                <a:solidFill>
+                  <a:srgbClr val="F2EFE9"/>
+                </a:solidFill>
+                <a:latin typeface="Segoe UI"/>
+              </a:defRPr>
+            </a:pPr>
+            <a:r>
+              <a:t>• Shared Memory IPC: Zero-copy multiprocessing.shared_memory streams 30 FPS telemetry and previews to GUI.</a:t>
+            </a:r>
+          </a:p>
+          <a:p>
+            <a:pPr>
+              <a:spcBef>
+                <a:spcPts val="600"/>
+              </a:spcBef>
+              <a:defRPr sz="1300">
+                <a:solidFill>
+                  <a:srgbClr val="F2EFE9"/>
+                </a:solidFill>
+                <a:latin typeface="Segoe UI"/>
+              </a:defRPr>
+            </a:pPr>
+            <a:r>
+              <a:t>• Hardware Audio Hook: Direct Windows Core Audio (Pycaw) input endpoint volume control.</a:t>
+            </a:r>
+          </a:p>
+          <a:p>
+            <a:pPr>
+              <a:spcBef>
+                <a:spcPts val="600"/>
+              </a:spcBef>
+              <a:defRPr sz="1300">
+                <a:solidFill>
+                  <a:srgbClr val="F2EFE9"/>
+                </a:solidFill>
+                <a:latin typeface="Segoe UI"/>
+              </a:defRPr>
+            </a:pPr>
+            <a:r>
+              <a:t>• Windows Camera Frame Server: OpenCV MSMF backend hooks svchost.exe -k Camera for native multi-app streaming.</a:t>
+            </a:r>
+          </a:p>
+          <a:p>
+            <a:pPr>
+              <a:spcBef>
+                <a:spcPts val="600"/>
+              </a:spcBef>
+              <a:defRPr sz="1300">
+                <a:solidFill>
+                  <a:srgbClr val="F2EFE9"/>
+                </a:solidFill>
+                <a:latin typeface="Segoe UI"/>
+              </a:defRPr>
+            </a:pPr>
+            <a:r>
+              <a:t>• Ambient HUD: CustomTkinter executive dashboard + topmost micro-pill Floating Capsule.</a:t>
+            </a:r>
+          </a:p>
+        </p:txBody>
+      </p:sp>
+      <p:sp>
+        <p:nvSpPr>
+          <p:cNvPr id="6" name="Rounded Rectangle 5"/>
+          <p:cNvSpPr/>
+          <p:nvPr/>
+        </p:nvSpPr>
+        <p:spPr>
+          <a:xfrm>
+            <a:off x="6217920" y="1737360"/>
+            <a:ext cx="5212080" cy="4389120"/>
+          </a:xfrm>
+          <a:prstGeom prst="roundRect">
+            <a:avLst/>
+          </a:prstGeom>
+          <a:solidFill>
+            <a:srgbClr val="181820"/>
+          </a:solidFill>
+          <a:ln w="12700">
+            <a:solidFill>
+              <a:srgbClr val="D4AF6A"/>
+            </a:solidFill>
+          </a:ln>
+        </p:spPr>
+        <p:style>
+          <a:lnRef idx="1">
+            <a:schemeClr val="accent1"/>
+          </a:lnRef>
+          <a:fillRef idx="3">
+            <a:schemeClr val="accent1"/>
+          </a:fillRef>
+          <a:effectRef idx="2">
+            <a:schemeClr val="accent1"/>
+          </a:effectRef>
+          <a:fontRef idx="minor">
+            <a:schemeClr val="lt1"/>
+          </a:fontRef>
+        </p:style>
+        <p:txBody>
+          <a:bodyPr rtlCol="0" anchor="ctr"/>
+          <a:lstStyle/>
+          <a:p>
+            <a:pPr algn="ctr"/>
+          </a:p>
+        </p:txBody>
+      </p:sp>
+      <p:sp>
+        <p:nvSpPr>
+          <p:cNvPr id="7" name="TextBox 6"/>
+          <p:cNvSpPr txBox="1"/>
+          <p:nvPr/>
+        </p:nvSpPr>
+        <p:spPr>
+          <a:xfrm>
+            <a:off x="6446520" y="1965960"/>
+            <a:ext cx="4754880" cy="3931920"/>
+          </a:xfrm>
+          <a:prstGeom prst="rect">
+            <a:avLst/>
+          </a:prstGeom>
+          <a:noFill/>
+        </p:spPr>
+        <p:txBody>
+          <a:bodyPr wrap="square">
+            <a:spAutoFit/>
+          </a:bodyPr>
+          <a:lstStyle/>
+          <a:p>
+            <a:pPr>
+              <a:defRPr sz="1800" b="1">
+                <a:solidFill>
+                  <a:srgbClr val="D4AF6A"/>
+                </a:solidFill>
+                <a:latin typeface="Segoe UI"/>
+              </a:defRPr>
+            </a:pPr>
+            <a:r>
               <a:t>Summary &amp; Why ZeroTouch Wins</a:t>
             </a:r>
           </a:p>
           <a:p>
             <a:pPr>
               <a:spcBef>
-                <a:spcPts val="800"/>
+                <a:spcPts val="600"/>
               </a:spcBef>
-              <a:defRPr sz="1400">
+              <a:defRPr sz="1300">
                 <a:solidFill>
                   <a:srgbClr val="F2EFE9"/>
                 </a:solidFill>
@@ -5195,9 +5721,9 @@
           <a:p>
             <a:pPr>
               <a:spcBef>
-                <a:spcPts val="800"/>
+                <a:spcPts val="600"/>
               </a:spcBef>
-              <a:defRPr sz="1400">
+              <a:defRPr sz="1300">
                 <a:solidFill>
                   <a:srgbClr val="F2EFE9"/>
                 </a:solidFill>
@@ -5211,9 +5737,9 @@
           <a:p>
             <a:pPr>
               <a:spcBef>
-                <a:spcPts val="800"/>
+                <a:spcPts val="600"/>
               </a:spcBef>
-              <a:defRPr sz="1400">
+              <a:defRPr sz="1300">
                 <a:solidFill>
                   <a:srgbClr val="F2EFE9"/>
                 </a:solidFill>
@@ -5227,9 +5753,9 @@
           <a:p>
             <a:pPr>
               <a:spcBef>
-                <a:spcPts val="800"/>
+                <a:spcPts val="600"/>
               </a:spcBef>
-              <a:defRPr sz="1400">
+              <a:defRPr sz="1300">
                 <a:solidFill>
                   <a:srgbClr val="F2EFE9"/>
                 </a:solidFill>

</xml_diff>

<commit_message>
docs: streamline pitch deck to 5 slides combining problem and context modes with punchy speaker anchors
</commit_message>
<xml_diff>
--- a/ZeroTouch_PitchDeck.pptx
+++ b/ZeroTouch_PitchDeck.pptx
@@ -10,7 +10,6 @@
     <p:sldId id="258" r:id="rId9"/>
     <p:sldId id="259" r:id="rId10"/>
     <p:sldId id="260" r:id="rId11"/>
-    <p:sldId id="261" r:id="rId12"/>
   </p:sldIdLst>
   <p:sldSz cx="12191695" cy="6858000" type="screen4x3"/>
   <p:notesSz cx="6858000" cy="9144000"/>
@@ -3152,7 +3151,7 @@
         </p:blipFill>
         <p:spPr>
           <a:xfrm>
-            <a:off x="5358384" y="1188720"/>
+            <a:off x="5358384" y="1051560"/>
             <a:ext cx="1463040" cy="1463040"/>
           </a:xfrm>
           <a:prstGeom prst="rect">
@@ -3168,8 +3167,8 @@
         </p:nvSpPr>
         <p:spPr>
           <a:xfrm>
-            <a:off x="914400" y="2926080"/>
-            <a:ext cx="10360152" cy="3200400"/>
+            <a:off x="914400" y="2697480"/>
+            <a:ext cx="10360152" cy="3474720"/>
           </a:xfrm>
           <a:prstGeom prst="rect">
             <a:avLst/>
@@ -3197,7 +3196,7 @@
           <a:p>
             <a:pPr algn="ctr">
               <a:spcBef>
-                <a:spcPts val="1000"/>
+                <a:spcPts val="800"/>
               </a:spcBef>
               <a:defRPr sz="1500" b="1">
                 <a:solidFill>
@@ -3215,31 +3214,31 @@
               <a:spcBef>
                 <a:spcPts val="600"/>
               </a:spcBef>
-              <a:defRPr sz="1400">
-                <a:solidFill>
-                  <a:srgbClr val="8A8D93"/>
+              <a:defRPr sz="1300">
+                <a:solidFill>
+                  <a:srgbClr val="91949B"/>
                 </a:solidFill>
                 <a:latin typeface="Segoe UI"/>
               </a:defRPr>
             </a:pPr>
             <a:r>
-              <a:t>Executive Computer Vision • 100% Local Inferencing • Zero False Positives</a:t>
+              <a:t>Zero Cloud Footprint  •  Multi-Modal False Trigger Defense  •  Active App Context</a:t>
             </a:r>
           </a:p>
           <a:p>
             <a:pPr algn="ctr">
               <a:spcBef>
-                <a:spcPts val="2800"/>
+                <a:spcPts val="3000"/>
               </a:spcBef>
-              <a:defRPr sz="1300">
+              <a:defRPr sz="1200" b="1">
                 <a:solidFill>
                   <a:srgbClr val="A0824B"/>
                 </a:solidFill>
-                <a:latin typeface="Segoe UI"/>
+                <a:latin typeface="Consolas"/>
               </a:defRPr>
             </a:pPr>
             <a:r>
-              <a:t>UAT Hackathon 2026: See / Analyze / Build</a:t>
+              <a:t>UAT Hackathon 2026  |  See  •  Analyze  •  Build</a:t>
             </a:r>
           </a:p>
         </p:txBody>
@@ -3313,7 +3312,7 @@
         </p:nvSpPr>
         <p:spPr>
           <a:xfrm>
-            <a:off x="731520" y="502920"/>
+            <a:off x="731520" y="475488"/>
             <a:ext cx="10728655" cy="1005840"/>
           </a:xfrm>
           <a:prstGeom prst="rect">
@@ -3336,15 +3335,15 @@
               </a:defRPr>
             </a:pPr>
             <a:r>
-              <a:t>01 • PROBLEM &amp; THESIS</a:t>
+              <a:t>01 • THESIS &amp; WORKFLOW</a:t>
             </a:r>
           </a:p>
           <a:p>
             <a:pPr>
               <a:spcBef>
-                <a:spcPts val="400"/>
+                <a:spcPts val="300"/>
               </a:spcBef>
-              <a:defRPr sz="2600" b="1">
+              <a:defRPr sz="2500" b="1">
                 <a:solidFill>
                   <a:srgbClr val="F2EFE9"/>
                 </a:solidFill>
@@ -3352,7 +3351,7 @@
               </a:defRPr>
             </a:pPr>
             <a:r>
-              <a:t>The Spatial Dilemma: Why Computer Vision Peripherals Fail</a:t>
+              <a:t>The Spatial Dilemma &amp; Context-Aware Solution</a:t>
             </a:r>
           </a:p>
         </p:txBody>
@@ -3365,8 +3364,8 @@
         </p:nvSpPr>
         <p:spPr>
           <a:xfrm>
-            <a:off x="731520" y="1737360"/>
-            <a:ext cx="5120640" cy="4389120"/>
+            <a:off x="731520" y="1691640"/>
+            <a:ext cx="3383280" cy="4480560"/>
           </a:xfrm>
           <a:prstGeom prst="roundRect">
             <a:avLst/>
@@ -3374,7 +3373,7 @@
           <a:solidFill>
             <a:srgbClr val="181820"/>
           </a:solidFill>
-          <a:ln w="12700">
+          <a:ln w="15240">
             <a:solidFill>
               <a:srgbClr val="D4AF6A"/>
             </a:solidFill>
@@ -3410,8 +3409,8 @@
         </p:nvSpPr>
         <p:spPr>
           <a:xfrm>
-            <a:off x="960120" y="1965960"/>
-            <a:ext cx="4663440" cy="3931920"/>
+            <a:off x="950976" y="1892808"/>
+            <a:ext cx="2944368" cy="4078224"/>
           </a:xfrm>
           <a:prstGeom prst="rect">
             <a:avLst/>
@@ -3425,7 +3424,7 @@
           <a:lstStyle/>
           <a:p>
             <a:pPr>
-              <a:defRPr sz="1800" b="1">
+              <a:defRPr sz="1700" b="1">
                 <a:solidFill>
                   <a:srgbClr val="D4AF6A"/>
                 </a:solidFill>
@@ -3433,7 +3432,26 @@
               </a:defRPr>
             </a:pPr>
             <a:r>
-              <a:t>The Problem: Too Noisy to Leave On</a:t>
+              <a:t>The Spatial Dilemma</a:t>
+            </a:r>
+          </a:p>
+          <a:p>
+            <a:pPr>
+              <a:spcBef>
+                <a:spcPts val="200"/>
+              </a:spcBef>
+              <a:spcAft>
+                <a:spcPts val="600"/>
+              </a:spcAft>
+              <a:defRPr sz="1000" b="1">
+                <a:solidFill>
+                  <a:srgbClr val="91949B"/>
+                </a:solidFill>
+                <a:latin typeface="Consolas"/>
+              </a:defRPr>
+            </a:pPr>
+            <a:r>
+              <a:t>WHY CV PERIPHERALS FAIL</a:t>
             </a:r>
           </a:p>
           <a:p>
@@ -3441,15 +3459,33 @@
               <a:spcBef>
                 <a:spcPts val="600"/>
               </a:spcBef>
-              <a:defRPr sz="1300">
+            </a:pPr>
+            <a:r>
+              <a:rPr b="1" sz="1300">
+                <a:solidFill>
+                  <a:srgbClr val="D4AF6A"/>
+                </a:solidFill>
+                <a:latin typeface="Segoe UI"/>
+              </a:rPr>
+              <a:t>• </a:t>
+            </a:r>
+            <a:r>
+              <a:rPr b="1" sz="1300">
                 <a:solidFill>
                   <a:srgbClr val="F2EFE9"/>
                 </a:solidFill>
                 <a:latin typeface="Segoe UI"/>
-              </a:defRPr>
-            </a:pPr>
-            <a:r>
-              <a:t>• Accidental Triggers: Scratching face, typing, or grabbing a cup fires unintended clicks and commands.</a:t>
+              </a:rPr>
+              <a:t>Accidental Triggers: </a:t>
+            </a:r>
+            <a:r>
+              <a:rPr sz="1300">
+                <a:solidFill>
+                  <a:srgbClr val="91949B"/>
+                </a:solidFill>
+                <a:latin typeface="Segoe UI"/>
+              </a:rPr>
+              <a:t>Scratching face or typing fires unwanted clicks</a:t>
             </a:r>
           </a:p>
           <a:p>
@@ -3457,15 +3493,33 @@
               <a:spcBef>
                 <a:spcPts val="600"/>
               </a:spcBef>
-              <a:defRPr sz="1300">
+            </a:pPr>
+            <a:r>
+              <a:rPr b="1" sz="1300">
+                <a:solidFill>
+                  <a:srgbClr val="D4AF6A"/>
+                </a:solidFill>
+                <a:latin typeface="Segoe UI"/>
+              </a:rPr>
+              <a:t>• </a:t>
+            </a:r>
+            <a:r>
+              <a:rPr b="1" sz="1300">
                 <a:solidFill>
                   <a:srgbClr val="F2EFE9"/>
                 </a:solidFill>
                 <a:latin typeface="Segoe UI"/>
-              </a:defRPr>
-            </a:pPr>
-            <a:r>
-              <a:t>• Privacy Paranoia: Users fear cameras streaming frames across networks or logging to disk.</a:t>
+              </a:rPr>
+              <a:t>Privacy Paranoia: </a:t>
+            </a:r>
+            <a:r>
+              <a:rPr sz="1300">
+                <a:solidFill>
+                  <a:srgbClr val="91949B"/>
+                </a:solidFill>
+                <a:latin typeface="Segoe UI"/>
+              </a:rPr>
+              <a:t>Users fear webcams streaming frames to the cloud</a:t>
             </a:r>
           </a:p>
           <a:p>
@@ -3473,15 +3527,33 @@
               <a:spcBef>
                 <a:spcPts val="600"/>
               </a:spcBef>
-              <a:defRPr sz="1300">
+            </a:pPr>
+            <a:r>
+              <a:rPr b="1" sz="1300">
+                <a:solidFill>
+                  <a:srgbClr val="D4AF6A"/>
+                </a:solidFill>
+                <a:latin typeface="Segoe UI"/>
+              </a:rPr>
+              <a:t>• </a:t>
+            </a:r>
+            <a:r>
+              <a:rPr b="1" sz="1300">
                 <a:solidFill>
                   <a:srgbClr val="F2EFE9"/>
                 </a:solidFill>
                 <a:latin typeface="Segoe UI"/>
-              </a:defRPr>
-            </a:pPr>
-            <a:r>
-              <a:t>• Distance &amp; Posture Limits: Stepping back to present slides breaks hand tracking or trips false look-aways.</a:t>
+              </a:rPr>
+              <a:t>Hardware Lockouts: </a:t>
+            </a:r>
+            <a:r>
+              <a:rPr sz="1300">
+                <a:solidFill>
+                  <a:srgbClr val="91949B"/>
+                </a:solidFill>
+                <a:latin typeface="Segoe UI"/>
+              </a:rPr>
+              <a:t>Standard CV apps hijack webcam from Zoom/Teams</a:t>
             </a:r>
           </a:p>
           <a:p>
@@ -3489,15 +3561,33 @@
               <a:spcBef>
                 <a:spcPts val="600"/>
               </a:spcBef>
-              <a:defRPr sz="1300">
+            </a:pPr>
+            <a:r>
+              <a:rPr b="1" sz="1300">
+                <a:solidFill>
+                  <a:srgbClr val="D4AF6A"/>
+                </a:solidFill>
+                <a:latin typeface="Segoe UI"/>
+              </a:rPr>
+              <a:t>• </a:t>
+            </a:r>
+            <a:r>
+              <a:rPr b="1" sz="1300">
                 <a:solidFill>
                   <a:srgbClr val="F2EFE9"/>
                 </a:solidFill>
                 <a:latin typeface="Segoe UI"/>
-              </a:defRPr>
-            </a:pPr>
-            <a:r>
-              <a:t>• Hardware Lockouts: Most CV software monopolizes the webcam, preventing Zoom, Teams, or Meet from opening.</a:t>
+              </a:rPr>
+              <a:t>Posture Constraints: </a:t>
+            </a:r>
+            <a:r>
+              <a:rPr sz="1300">
+                <a:solidFill>
+                  <a:srgbClr val="91949B"/>
+                </a:solidFill>
+                <a:latin typeface="Segoe UI"/>
+              </a:rPr>
+              <a:t>Stepping back from desk breaks tracking completely</a:t>
             </a:r>
           </a:p>
         </p:txBody>
@@ -3510,8 +3600,8 @@
         </p:nvSpPr>
         <p:spPr>
           <a:xfrm>
-            <a:off x="6217920" y="1737360"/>
-            <a:ext cx="5212080" cy="4389120"/>
+            <a:off x="4389120" y="1691640"/>
+            <a:ext cx="3383280" cy="4480560"/>
           </a:xfrm>
           <a:prstGeom prst="roundRect">
             <a:avLst/>
@@ -3519,7 +3609,7 @@
           <a:solidFill>
             <a:srgbClr val="181820"/>
           </a:solidFill>
-          <a:ln w="12700">
+          <a:ln w="15240">
             <a:solidFill>
               <a:srgbClr val="F2EFE9"/>
             </a:solidFill>
@@ -3555,8 +3645,8 @@
         </p:nvSpPr>
         <p:spPr>
           <a:xfrm>
-            <a:off x="6446520" y="1965960"/>
-            <a:ext cx="4754880" cy="3931920"/>
+            <a:off x="4608576" y="1892808"/>
+            <a:ext cx="2944368" cy="4078224"/>
           </a:xfrm>
           <a:prstGeom prst="rect">
             <a:avLst/>
@@ -3570,7 +3660,7 @@
           <a:lstStyle/>
           <a:p>
             <a:pPr>
-              <a:defRPr sz="1800" b="1">
+              <a:defRPr sz="1700" b="1">
                 <a:solidFill>
                   <a:srgbClr val="F2EFE9"/>
                 </a:solidFill>
@@ -3578,7 +3668,26 @@
               </a:defRPr>
             </a:pPr>
             <a:r>
-              <a:t>The Solution: The Invisible Peripheral</a:t>
+              <a:t>Context-Aware Engine</a:t>
+            </a:r>
+          </a:p>
+          <a:p>
+            <a:pPr>
+              <a:spcBef>
+                <a:spcPts val="200"/>
+              </a:spcBef>
+              <a:spcAft>
+                <a:spcPts val="600"/>
+              </a:spcAft>
+              <a:defRPr sz="1000" b="1">
+                <a:solidFill>
+                  <a:srgbClr val="91949B"/>
+                </a:solidFill>
+                <a:latin typeface="Consolas"/>
+              </a:defRPr>
+            </a:pPr>
+            <a:r>
+              <a:t>ADAPTS TO ACTIVE APP</a:t>
             </a:r>
           </a:p>
           <a:p>
@@ -3586,15 +3695,33 @@
               <a:spcBef>
                 <a:spcPts val="600"/>
               </a:spcBef>
-              <a:defRPr sz="1300">
+            </a:pPr>
+            <a:r>
+              <a:rPr b="1" sz="1300">
                 <a:solidFill>
                   <a:srgbClr val="F2EFE9"/>
                 </a:solidFill>
                 <a:latin typeface="Segoe UI"/>
-              </a:defRPr>
-            </a:pPr>
-            <a:r>
-              <a:t>• 100% Volatile RAM: Zero video frames saved or transmitted; all inference runs strictly in local memory.</a:t>
+              </a:rPr>
+              <a:t>• </a:t>
+            </a:r>
+            <a:r>
+              <a:rPr b="1" sz="1300">
+                <a:solidFill>
+                  <a:srgbClr val="F2EFE9"/>
+                </a:solidFill>
+                <a:latin typeface="Segoe UI"/>
+              </a:rPr>
+              <a:t>Presentation Mode: </a:t>
+            </a:r>
+            <a:r>
+              <a:rPr sz="1300">
+                <a:solidFill>
+                  <a:srgbClr val="91949B"/>
+                </a:solidFill>
+                <a:latin typeface="Segoe UI"/>
+              </a:rPr>
+              <a:t>PowerPoint &amp; Slides: Wave swipe to advance; palm to blank screen ('B')</a:t>
             </a:r>
           </a:p>
           <a:p>
@@ -3602,15 +3729,33 @@
               <a:spcBef>
                 <a:spcPts val="600"/>
               </a:spcBef>
-              <a:defRPr sz="1300">
+            </a:pPr>
+            <a:r>
+              <a:rPr b="1" sz="1300">
                 <a:solidFill>
                   <a:srgbClr val="F2EFE9"/>
                 </a:solidFill>
                 <a:latin typeface="Segoe UI"/>
-              </a:defRPr>
-            </a:pPr>
-            <a:r>
-              <a:t>• Multimodal Intent Filtering: Physical typing lockout, gaze tracking, and reach boundaries eliminate misfires.</a:t>
+              </a:rPr>
+              <a:t>• </a:t>
+            </a:r>
+            <a:r>
+              <a:rPr b="1" sz="1300">
+                <a:solidFill>
+                  <a:srgbClr val="F2EFE9"/>
+                </a:solidFill>
+                <a:latin typeface="Segoe UI"/>
+              </a:rPr>
+              <a:t>Meeting Mode: </a:t>
+            </a:r>
+            <a:r>
+              <a:rPr sz="1300">
+                <a:solidFill>
+                  <a:srgbClr val="91949B"/>
+                </a:solidFill>
+                <a:latin typeface="Segoe UI"/>
+              </a:rPr>
+              <a:t>Meet &amp; Teams: Ghost-Mute (Shh), camera toggle (Ctrl+E / Ctrl+Shift+O)</a:t>
             </a:r>
           </a:p>
           <a:p>
@@ -3618,15 +3763,33 @@
               <a:spcBef>
                 <a:spcPts val="600"/>
               </a:spcBef>
-              <a:defRPr sz="1300">
+            </a:pPr>
+            <a:r>
+              <a:rPr b="1" sz="1300">
                 <a:solidFill>
                   <a:srgbClr val="F2EFE9"/>
                 </a:solidFill>
                 <a:latin typeface="Segoe UI"/>
-              </a:defRPr>
-            </a:pPr>
-            <a:r>
-              <a:t>• Stage Mode: Automatic distance adaptation keeps controls responsive at 6–10 feet.</a:t>
+              </a:rPr>
+              <a:t>• </a:t>
+            </a:r>
+            <a:r>
+              <a:rPr b="1" sz="1300">
+                <a:solidFill>
+                  <a:srgbClr val="F2EFE9"/>
+                </a:solidFill>
+                <a:latin typeface="Segoe UI"/>
+              </a:rPr>
+              <a:t>Media Mode: </a:t>
+            </a:r>
+            <a:r>
+              <a:rPr sz="1300">
+                <a:solidFill>
+                  <a:srgbClr val="91949B"/>
+                </a:solidFill>
+                <a:latin typeface="Segoe UI"/>
+              </a:rPr>
+              <a:t>Spotify &amp; YouTube: Natural palm play/pause and continuous volume pinch</a:t>
             </a:r>
           </a:p>
           <a:p>
@@ -3634,15 +3797,269 @@
               <a:spcBef>
                 <a:spcPts val="600"/>
               </a:spcBef>
-              <a:defRPr sz="1300">
+            </a:pPr>
+            <a:r>
+              <a:rPr b="1" sz="1300">
                 <a:solidFill>
                   <a:srgbClr val="F2EFE9"/>
                 </a:solidFill>
                 <a:latin typeface="Segoe UI"/>
+              </a:rPr>
+              <a:t>• </a:t>
+            </a:r>
+            <a:r>
+              <a:rPr b="1" sz="1300">
+                <a:solidFill>
+                  <a:srgbClr val="F2EFE9"/>
+                </a:solidFill>
+                <a:latin typeface="Segoe UI"/>
+              </a:rPr>
+              <a:t>Auto Mode Switching: </a:t>
+            </a:r>
+            <a:r>
+              <a:rPr sz="1300">
+                <a:solidFill>
+                  <a:srgbClr val="91949B"/>
+                </a:solidFill>
+                <a:latin typeface="Segoe UI"/>
+              </a:rPr>
+              <a:t>Detects focused window every 400ms seamlessly</a:t>
+            </a:r>
+          </a:p>
+        </p:txBody>
+      </p:sp>
+      <p:sp>
+        <p:nvSpPr>
+          <p:cNvPr id="8" name="Rounded Rectangle 7"/>
+          <p:cNvSpPr/>
+          <p:nvPr/>
+        </p:nvSpPr>
+        <p:spPr>
+          <a:xfrm>
+            <a:off x="8046720" y="1691640"/>
+            <a:ext cx="3383280" cy="4480560"/>
+          </a:xfrm>
+          <a:prstGeom prst="roundRect">
+            <a:avLst/>
+          </a:prstGeom>
+          <a:solidFill>
+            <a:srgbClr val="181820"/>
+          </a:solidFill>
+          <a:ln w="15240">
+            <a:solidFill>
+              <a:srgbClr val="557DB9"/>
+            </a:solidFill>
+          </a:ln>
+        </p:spPr>
+        <p:style>
+          <a:lnRef idx="1">
+            <a:schemeClr val="accent1"/>
+          </a:lnRef>
+          <a:fillRef idx="3">
+            <a:schemeClr val="accent1"/>
+          </a:fillRef>
+          <a:effectRef idx="2">
+            <a:schemeClr val="accent1"/>
+          </a:effectRef>
+          <a:fontRef idx="minor">
+            <a:schemeClr val="lt1"/>
+          </a:fontRef>
+        </p:style>
+        <p:txBody>
+          <a:bodyPr rtlCol="0" anchor="ctr"/>
+          <a:lstStyle/>
+          <a:p>
+            <a:pPr algn="ctr"/>
+          </a:p>
+        </p:txBody>
+      </p:sp>
+      <p:sp>
+        <p:nvSpPr>
+          <p:cNvPr id="9" name="TextBox 8"/>
+          <p:cNvSpPr txBox="1"/>
+          <p:nvPr/>
+        </p:nvSpPr>
+        <p:spPr>
+          <a:xfrm>
+            <a:off x="8266176" y="1892808"/>
+            <a:ext cx="2944368" cy="4078224"/>
+          </a:xfrm>
+          <a:prstGeom prst="rect">
+            <a:avLst/>
+          </a:prstGeom>
+          <a:noFill/>
+        </p:spPr>
+        <p:txBody>
+          <a:bodyPr wrap="square">
+            <a:spAutoFit/>
+          </a:bodyPr>
+          <a:lstStyle/>
+          <a:p>
+            <a:pPr>
+              <a:defRPr sz="1700" b="1">
+                <a:solidFill>
+                  <a:srgbClr val="557DB9"/>
+                </a:solidFill>
+                <a:latin typeface="Segoe UI"/>
               </a:defRPr>
             </a:pPr>
             <a:r>
-              <a:t>• Native OS Camera Sharing: Windows Camera Frame Server sharing allows simultaneous Google Meet and CV usage.</a:t>
+              <a:t>ZeroTouch Breakthrough</a:t>
+            </a:r>
+          </a:p>
+          <a:p>
+            <a:pPr>
+              <a:spcBef>
+                <a:spcPts val="200"/>
+              </a:spcBef>
+              <a:spcAft>
+                <a:spcPts val="600"/>
+              </a:spcAft>
+              <a:defRPr sz="1000" b="1">
+                <a:solidFill>
+                  <a:srgbClr val="91949B"/>
+                </a:solidFill>
+                <a:latin typeface="Consolas"/>
+              </a:defRPr>
+            </a:pPr>
+            <a:r>
+              <a:t>THE INVISIBLE PERIPHERAL</a:t>
+            </a:r>
+          </a:p>
+          <a:p>
+            <a:pPr>
+              <a:spcBef>
+                <a:spcPts val="600"/>
+              </a:spcBef>
+            </a:pPr>
+            <a:r>
+              <a:rPr b="1" sz="1300">
+                <a:solidFill>
+                  <a:srgbClr val="557DB9"/>
+                </a:solidFill>
+                <a:latin typeface="Segoe UI"/>
+              </a:rPr>
+              <a:t>• </a:t>
+            </a:r>
+            <a:r>
+              <a:rPr b="1" sz="1300">
+                <a:solidFill>
+                  <a:srgbClr val="F2EFE9"/>
+                </a:solidFill>
+                <a:latin typeface="Segoe UI"/>
+              </a:rPr>
+              <a:t>100% Volatile RAM: </a:t>
+            </a:r>
+            <a:r>
+              <a:rPr sz="1300">
+                <a:solidFill>
+                  <a:srgbClr val="91949B"/>
+                </a:solidFill>
+                <a:latin typeface="Segoe UI"/>
+              </a:rPr>
+              <a:t>Zero video frames ever stored or transmitted</a:t>
+            </a:r>
+          </a:p>
+          <a:p>
+            <a:pPr>
+              <a:spcBef>
+                <a:spcPts val="600"/>
+              </a:spcBef>
+            </a:pPr>
+            <a:r>
+              <a:rPr b="1" sz="1300">
+                <a:solidFill>
+                  <a:srgbClr val="557DB9"/>
+                </a:solidFill>
+                <a:latin typeface="Segoe UI"/>
+              </a:rPr>
+              <a:t>• </a:t>
+            </a:r>
+            <a:r>
+              <a:rPr b="1" sz="1300">
+                <a:solidFill>
+                  <a:srgbClr val="F2EFE9"/>
+                </a:solidFill>
+                <a:latin typeface="Segoe UI"/>
+              </a:rPr>
+              <a:t>OS Camera Sharing: </a:t>
+            </a:r>
+            <a:r>
+              <a:rPr sz="1300">
+                <a:solidFill>
+                  <a:srgbClr val="91949B"/>
+                </a:solidFill>
+                <a:latin typeface="Segoe UI"/>
+              </a:rPr>
+              <a:t>Native Windows Frame Server coexists with Meet/Teams</a:t>
+            </a:r>
+          </a:p>
+          <a:p>
+            <a:pPr>
+              <a:spcBef>
+                <a:spcPts val="600"/>
+              </a:spcBef>
+            </a:pPr>
+            <a:r>
+              <a:rPr b="1" sz="1300">
+                <a:solidFill>
+                  <a:srgbClr val="557DB9"/>
+                </a:solidFill>
+                <a:latin typeface="Segoe UI"/>
+              </a:rPr>
+              <a:t>• </a:t>
+            </a:r>
+            <a:r>
+              <a:rPr b="1" sz="1300">
+                <a:solidFill>
+                  <a:srgbClr val="F2EFE9"/>
+                </a:solidFill>
+                <a:latin typeface="Segoe UI"/>
+              </a:rPr>
+              <a:t>Stage Distance Engine: </a:t>
+            </a:r>
+            <a:r>
+              <a:rPr sz="1300">
+                <a:solidFill>
+                  <a:srgbClr val="91949B"/>
+                </a:solidFill>
+                <a:latin typeface="Segoe UI"/>
+              </a:rPr>
+              <a:t>Dynamic distance scaling works from 6–10 feet</a:t>
+            </a:r>
+          </a:p>
+          <a:p>
+            <a:pPr>
+              <a:spcBef>
+                <a:spcPts val="600"/>
+              </a:spcBef>
+            </a:pPr>
+            <a:r>
+              <a:rPr b="1" sz="1300">
+                <a:solidFill>
+                  <a:srgbClr val="557DB9"/>
+                </a:solidFill>
+                <a:latin typeface="Segoe UI"/>
+              </a:rPr>
+              <a:t>• </a:t>
+            </a:r>
+            <a:r>
+              <a:rPr b="1" sz="1300">
+                <a:solidFill>
+                  <a:srgbClr val="F2EFE9"/>
+                </a:solidFill>
+                <a:latin typeface="Segoe UI"/>
+              </a:rPr>
+              <a:t>Zero Window Stealing: </a:t>
+            </a:r>
+            <a:r>
+              <a:rPr sz="1300">
+                <a:solidFill>
+                  <a:srgbClr val="91949B"/>
+                </a:solidFill>
+                <a:latin typeface="Segoe UI"/>
+              </a:rPr>
+              <a:t>Controls background media without losing active window focus</a:t>
             </a:r>
           </a:p>
         </p:txBody>
@@ -3716,7 +4133,7 @@
         </p:nvSpPr>
         <p:spPr>
           <a:xfrm>
-            <a:off x="731520" y="502920"/>
+            <a:off x="731520" y="475488"/>
             <a:ext cx="10728655" cy="1005840"/>
           </a:xfrm>
           <a:prstGeom prst="rect">
@@ -3739,15 +4156,15 @@
               </a:defRPr>
             </a:pPr>
             <a:r>
-              <a:t>02 • MARKET &amp; AUDIENCE</a:t>
+              <a:t>02 • TARGET MARKET &amp; PERSONAS</a:t>
             </a:r>
           </a:p>
           <a:p>
             <a:pPr>
               <a:spcBef>
-                <a:spcPts val="400"/>
+                <a:spcPts val="300"/>
               </a:spcBef>
-              <a:defRPr sz="2600" b="1">
+              <a:defRPr sz="2500" b="1">
                 <a:solidFill>
                   <a:srgbClr val="F2EFE9"/>
                 </a:solidFill>
@@ -3755,7 +4172,7 @@
               </a:defRPr>
             </a:pPr>
             <a:r>
-              <a:t>Target Demographic &amp; Real-World User Personas</a:t>
+              <a:t>Who Needs ZeroTouch: Real-World Demographics</a:t>
             </a:r>
           </a:p>
         </p:txBody>
@@ -3768,8 +4185,8 @@
         </p:nvSpPr>
         <p:spPr>
           <a:xfrm>
-            <a:off x="731520" y="1737360"/>
-            <a:ext cx="3383280" cy="4389120"/>
+            <a:off x="731520" y="1691640"/>
+            <a:ext cx="3383280" cy="4480560"/>
           </a:xfrm>
           <a:prstGeom prst="roundRect">
             <a:avLst/>
@@ -3777,7 +4194,7 @@
           <a:solidFill>
             <a:srgbClr val="181820"/>
           </a:solidFill>
-          <a:ln w="12700">
+          <a:ln w="15240">
             <a:solidFill>
               <a:srgbClr val="D4AF6A"/>
             </a:solidFill>
@@ -3813,8 +4230,8 @@
         </p:nvSpPr>
         <p:spPr>
           <a:xfrm>
-            <a:off x="960120" y="1965960"/>
-            <a:ext cx="2926080" cy="3931920"/>
+            <a:off x="950976" y="1892808"/>
+            <a:ext cx="2944368" cy="4078224"/>
           </a:xfrm>
           <a:prstGeom prst="rect">
             <a:avLst/>
@@ -3828,7 +4245,7 @@
           <a:lstStyle/>
           <a:p>
             <a:pPr>
-              <a:defRPr sz="1800" b="1">
+              <a:defRPr sz="1700" b="1">
                 <a:solidFill>
                   <a:srgbClr val="D4AF6A"/>
                 </a:solidFill>
@@ -3836,7 +4253,7 @@
               </a:defRPr>
             </a:pPr>
             <a:r>
-              <a:t>Corporate &amp; Remote Pros</a:t>
+              <a:t>Hybrid Knowledge Workers</a:t>
             </a:r>
           </a:p>
           <a:p>
@@ -3845,17 +4262,17 @@
                 <a:spcPts val="200"/>
               </a:spcBef>
               <a:spcAft>
-                <a:spcPts val="400"/>
+                <a:spcPts val="600"/>
               </a:spcAft>
-              <a:defRPr sz="1200" b="1">
-                <a:solidFill>
-                  <a:srgbClr val="8A8D93"/>
-                </a:solidFill>
-                <a:latin typeface="Segoe UI"/>
+              <a:defRPr sz="1000" b="1">
+                <a:solidFill>
+                  <a:srgbClr val="91949B"/>
+                </a:solidFill>
+                <a:latin typeface="Consolas"/>
               </a:defRPr>
             </a:pPr>
             <a:r>
-              <a:t>Knowledge Workers &amp; Remote Teams</a:t>
+              <a:t>REMOTE &amp; ENTERPRISE TEAMS</a:t>
             </a:r>
           </a:p>
           <a:p>
@@ -3863,15 +4280,33 @@
               <a:spcBef>
                 <a:spcPts val="600"/>
               </a:spcBef>
-              <a:defRPr sz="1300">
+            </a:pPr>
+            <a:r>
+              <a:rPr b="1" sz="1300">
+                <a:solidFill>
+                  <a:srgbClr val="D4AF6A"/>
+                </a:solidFill>
+                <a:latin typeface="Segoe UI"/>
+              </a:rPr>
+              <a:t>• </a:t>
+            </a:r>
+            <a:r>
+              <a:rPr b="1" sz="1300">
                 <a:solidFill>
                   <a:srgbClr val="F2EFE9"/>
                 </a:solidFill>
                 <a:latin typeface="Segoe UI"/>
-              </a:defRPr>
-            </a:pPr>
-            <a:r>
-              <a:t>• Profile: Spends 4–6 hrs/day in virtual meetings (Google Meet, Microsoft Teams, Zoom).</a:t>
+              </a:rPr>
+              <a:t>Daily Profile: </a:t>
+            </a:r>
+            <a:r>
+              <a:rPr sz="1300">
+                <a:solidFill>
+                  <a:srgbClr val="91949B"/>
+                </a:solidFill>
+                <a:latin typeface="Segoe UI"/>
+              </a:rPr>
+              <a:t>4–6 hours daily in Google Meet, Teams, and Zoom calls</a:t>
             </a:r>
           </a:p>
           <a:p>
@@ -3879,15 +4314,33 @@
               <a:spcBef>
                 <a:spcPts val="600"/>
               </a:spcBef>
-              <a:defRPr sz="1300">
+            </a:pPr>
+            <a:r>
+              <a:rPr b="1" sz="1300">
+                <a:solidFill>
+                  <a:srgbClr val="D4AF6A"/>
+                </a:solidFill>
+                <a:latin typeface="Segoe UI"/>
+              </a:rPr>
+              <a:t>• </a:t>
+            </a:r>
+            <a:r>
+              <a:rPr b="1" sz="1300">
                 <a:solidFill>
                   <a:srgbClr val="F2EFE9"/>
                 </a:solidFill>
                 <a:latin typeface="Segoe UI"/>
-              </a:defRPr>
-            </a:pPr>
-            <a:r>
-              <a:t>• Pain Point: Scrambling across 5 open windows to find the mute button while coughing or interrupted.</a:t>
+              </a:rPr>
+              <a:t>Core Frustration: </a:t>
+            </a:r>
+            <a:r>
+              <a:rPr sz="1300">
+                <a:solidFill>
+                  <a:srgbClr val="91949B"/>
+                </a:solidFill>
+                <a:latin typeface="Segoe UI"/>
+              </a:rPr>
+              <a:t>Scrambling across 10 open windows to find the mute button</a:t>
             </a:r>
           </a:p>
           <a:p>
@@ -3895,15 +4348,33 @@
               <a:spcBef>
                 <a:spcPts val="600"/>
               </a:spcBef>
-              <a:defRPr sz="1300">
+            </a:pPr>
+            <a:r>
+              <a:rPr b="1" sz="1300">
+                <a:solidFill>
+                  <a:srgbClr val="D4AF6A"/>
+                </a:solidFill>
+                <a:latin typeface="Segoe UI"/>
+              </a:rPr>
+              <a:t>• </a:t>
+            </a:r>
+            <a:r>
+              <a:rPr b="1" sz="1300">
                 <a:solidFill>
                   <a:srgbClr val="F2EFE9"/>
                 </a:solidFill>
                 <a:latin typeface="Segoe UI"/>
-              </a:defRPr>
-            </a:pPr>
-            <a:r>
-              <a:t>• ZeroTouch Value: Ghost-Mute (Shh to lips) toggles hardware mic instantly with zero window focus needed.</a:t>
+              </a:rPr>
+              <a:t>ZeroTouch Superpower: </a:t>
+            </a:r>
+            <a:r>
+              <a:rPr sz="1300">
+                <a:solidFill>
+                  <a:srgbClr val="91949B"/>
+                </a:solidFill>
+                <a:latin typeface="Segoe UI"/>
+              </a:rPr>
+              <a:t>Instant 'Shh' hardware mute without touching window or mouse</a:t>
             </a:r>
           </a:p>
           <a:p>
@@ -3911,15 +4382,33 @@
               <a:spcBef>
                 <a:spcPts val="600"/>
               </a:spcBef>
-              <a:defRPr sz="1300">
+            </a:pPr>
+            <a:r>
+              <a:rPr b="1" sz="1300">
+                <a:solidFill>
+                  <a:srgbClr val="D4AF6A"/>
+                </a:solidFill>
+                <a:latin typeface="Segoe UI"/>
+              </a:rPr>
+              <a:t>• </a:t>
+            </a:r>
+            <a:r>
+              <a:rPr b="1" sz="1300">
                 <a:solidFill>
                   <a:srgbClr val="F2EFE9"/>
                 </a:solidFill>
                 <a:latin typeface="Segoe UI"/>
-              </a:defRPr>
-            </a:pPr>
-            <a:r>
-              <a:t>• Enterprise Fit: 100% local RAM execution complies with corporate IT security &amp; data privacy mandates.</a:t>
+              </a:rPr>
+              <a:t>Enterprise Compliance: </a:t>
+            </a:r>
+            <a:r>
+              <a:rPr sz="1300">
+                <a:solidFill>
+                  <a:srgbClr val="91949B"/>
+                </a:solidFill>
+                <a:latin typeface="Segoe UI"/>
+              </a:rPr>
+              <a:t>Runs 100% locally; satisfies strict corporate data policies</a:t>
             </a:r>
           </a:p>
         </p:txBody>
@@ -3932,8 +4421,8 @@
         </p:nvSpPr>
         <p:spPr>
           <a:xfrm>
-            <a:off x="4389120" y="1737360"/>
-            <a:ext cx="3383280" cy="4389120"/>
+            <a:off x="4389120" y="1691640"/>
+            <a:ext cx="3383280" cy="4480560"/>
           </a:xfrm>
           <a:prstGeom prst="roundRect">
             <a:avLst/>
@@ -3941,7 +4430,7 @@
           <a:solidFill>
             <a:srgbClr val="181820"/>
           </a:solidFill>
-          <a:ln w="12700">
+          <a:ln w="15240">
             <a:solidFill>
               <a:srgbClr val="F2EFE9"/>
             </a:solidFill>
@@ -3977,8 +4466,8 @@
         </p:nvSpPr>
         <p:spPr>
           <a:xfrm>
-            <a:off x="4617720" y="1965960"/>
-            <a:ext cx="2926080" cy="3931920"/>
+            <a:off x="4608576" y="1892808"/>
+            <a:ext cx="2944368" cy="4078224"/>
           </a:xfrm>
           <a:prstGeom prst="rect">
             <a:avLst/>
@@ -3992,7 +4481,7 @@
           <a:lstStyle/>
           <a:p>
             <a:pPr>
-              <a:defRPr sz="1800" b="1">
+              <a:defRPr sz="1700" b="1">
                 <a:solidFill>
                   <a:srgbClr val="F2EFE9"/>
                 </a:solidFill>
@@ -4000,7 +4489,7 @@
               </a:defRPr>
             </a:pPr>
             <a:r>
-              <a:t>Presenters &amp; Educators</a:t>
+              <a:t>Speakers &amp; Educators</a:t>
             </a:r>
           </a:p>
           <a:p>
@@ -4009,17 +4498,17 @@
                 <a:spcPts val="200"/>
               </a:spcBef>
               <a:spcAft>
-                <a:spcPts val="400"/>
+                <a:spcPts val="600"/>
               </a:spcAft>
-              <a:defRPr sz="1200" b="1">
-                <a:solidFill>
-                  <a:srgbClr val="8A8D93"/>
-                </a:solidFill>
-                <a:latin typeface="Segoe UI"/>
+              <a:defRPr sz="1000" b="1">
+                <a:solidFill>
+                  <a:srgbClr val="91949B"/>
+                </a:solidFill>
+                <a:latin typeface="Consolas"/>
               </a:defRPr>
             </a:pPr>
             <a:r>
-              <a:t>Speakers, Lecturers &amp; Pitch Teams</a:t>
+              <a:t>KEYNOTES, LECTURERS, PITCHES</a:t>
             </a:r>
           </a:p>
           <a:p>
@@ -4027,15 +4516,33 @@
               <a:spcBef>
                 <a:spcPts val="600"/>
               </a:spcBef>
-              <a:defRPr sz="1300">
+            </a:pPr>
+            <a:r>
+              <a:rPr b="1" sz="1300">
                 <a:solidFill>
                   <a:srgbClr val="F2EFE9"/>
                 </a:solidFill>
                 <a:latin typeface="Segoe UI"/>
-              </a:defRPr>
-            </a:pPr>
-            <a:r>
-              <a:t>• Profile: Keynote speakers, university lecturers, sales executives, and conference presenters.</a:t>
+              </a:rPr>
+              <a:t>• </a:t>
+            </a:r>
+            <a:r>
+              <a:rPr b="1" sz="1300">
+                <a:solidFill>
+                  <a:srgbClr val="F2EFE9"/>
+                </a:solidFill>
+                <a:latin typeface="Segoe UI"/>
+              </a:rPr>
+              <a:t>Daily Profile: </a:t>
+            </a:r>
+            <a:r>
+              <a:rPr sz="1300">
+                <a:solidFill>
+                  <a:srgbClr val="91949B"/>
+                </a:solidFill>
+                <a:latin typeface="Segoe UI"/>
+              </a:rPr>
+              <a:t>Presenting to clients, lecture halls, and live pitch judges</a:t>
             </a:r>
           </a:p>
           <a:p>
@@ -4043,15 +4550,33 @@
               <a:spcBef>
                 <a:spcPts val="600"/>
               </a:spcBef>
-              <a:defRPr sz="1300">
+            </a:pPr>
+            <a:r>
+              <a:rPr b="1" sz="1300">
                 <a:solidFill>
                   <a:srgbClr val="F2EFE9"/>
                 </a:solidFill>
                 <a:latin typeface="Segoe UI"/>
-              </a:defRPr>
-            </a:pPr>
-            <a:r>
-              <a:t>• Pain Point: Tethered to podium laptop, dealing with broken/dead clicker dongles, or awkward pacing.</a:t>
+              </a:rPr>
+              <a:t>• </a:t>
+            </a:r>
+            <a:r>
+              <a:rPr b="1" sz="1300">
+                <a:solidFill>
+                  <a:srgbClr val="F2EFE9"/>
+                </a:solidFill>
+                <a:latin typeface="Segoe UI"/>
+              </a:rPr>
+              <a:t>Core Frustration: </a:t>
+            </a:r>
+            <a:r>
+              <a:rPr sz="1300">
+                <a:solidFill>
+                  <a:srgbClr val="91949B"/>
+                </a:solidFill>
+                <a:latin typeface="Segoe UI"/>
+              </a:rPr>
+              <a:t>Tethered to podium laptop or relying on dead clicker batteries</a:t>
             </a:r>
           </a:p>
           <a:p>
@@ -4059,15 +4584,33 @@
               <a:spcBef>
                 <a:spcPts val="600"/>
               </a:spcBef>
-              <a:defRPr sz="1300">
+            </a:pPr>
+            <a:r>
+              <a:rPr b="1" sz="1300">
                 <a:solidFill>
                   <a:srgbClr val="F2EFE9"/>
                 </a:solidFill>
                 <a:latin typeface="Segoe UI"/>
-              </a:defRPr>
-            </a:pPr>
-            <a:r>
-              <a:t>• ZeroTouch Value: Stage Mode lets presenters navigate slides from 6–10 feet away with natural gestures.</a:t>
+              </a:rPr>
+              <a:t>• </a:t>
+            </a:r>
+            <a:r>
+              <a:rPr b="1" sz="1300">
+                <a:solidFill>
+                  <a:srgbClr val="F2EFE9"/>
+                </a:solidFill>
+                <a:latin typeface="Segoe UI"/>
+              </a:rPr>
+              <a:t>ZeroTouch Superpower: </a:t>
+            </a:r>
+            <a:r>
+              <a:rPr sz="1300">
+                <a:solidFill>
+                  <a:srgbClr val="91949B"/>
+                </a:solidFill>
+                <a:latin typeface="Segoe UI"/>
+              </a:rPr>
+              <a:t>Walk the stage freely; advance slides from 10 feet away</a:t>
             </a:r>
           </a:p>
           <a:p>
@@ -4075,15 +4618,33 @@
               <a:spcBef>
                 <a:spcPts val="600"/>
               </a:spcBef>
-              <a:defRPr sz="1300">
+            </a:pPr>
+            <a:r>
+              <a:rPr b="1" sz="1300">
                 <a:solidFill>
                   <a:srgbClr val="F2EFE9"/>
                 </a:solidFill>
                 <a:latin typeface="Segoe UI"/>
-              </a:defRPr>
-            </a:pPr>
-            <a:r>
-              <a:t>• Audience Engagement: Blank/resume slides instantly ('B') to command room attention without touching hardware.</a:t>
+              </a:rPr>
+              <a:t>• </a:t>
+            </a:r>
+            <a:r>
+              <a:rPr b="1" sz="1300">
+                <a:solidFill>
+                  <a:srgbClr val="F2EFE9"/>
+                </a:solidFill>
+                <a:latin typeface="Segoe UI"/>
+              </a:rPr>
+              <a:t>Audience Command: </a:t>
+            </a:r>
+            <a:r>
+              <a:rPr sz="1300">
+                <a:solidFill>
+                  <a:srgbClr val="91949B"/>
+                </a:solidFill>
+                <a:latin typeface="Segoe UI"/>
+              </a:rPr>
+              <a:t>Hold open palm to blank screen ('B') and hold room attention</a:t>
             </a:r>
           </a:p>
         </p:txBody>
@@ -4096,8 +4657,8 @@
         </p:nvSpPr>
         <p:spPr>
           <a:xfrm>
-            <a:off x="8046720" y="1737360"/>
-            <a:ext cx="3383280" cy="4389120"/>
+            <a:off x="8046720" y="1691640"/>
+            <a:ext cx="3383280" cy="4480560"/>
           </a:xfrm>
           <a:prstGeom prst="roundRect">
             <a:avLst/>
@@ -4105,9 +4666,9 @@
           <a:solidFill>
             <a:srgbClr val="181820"/>
           </a:solidFill>
-          <a:ln w="12700">
+          <a:ln w="15240">
             <a:solidFill>
-              <a:srgbClr val="4A6FA5"/>
+              <a:srgbClr val="557DB9"/>
             </a:solidFill>
           </a:ln>
         </p:spPr>
@@ -4141,8 +4702,8 @@
         </p:nvSpPr>
         <p:spPr>
           <a:xfrm>
-            <a:off x="8275320" y="1965960"/>
-            <a:ext cx="2926080" cy="3931920"/>
+            <a:off x="8266176" y="1892808"/>
+            <a:ext cx="2944368" cy="4078224"/>
           </a:xfrm>
           <a:prstGeom prst="rect">
             <a:avLst/>
@@ -4156,15 +4717,15 @@
           <a:lstStyle/>
           <a:p>
             <a:pPr>
-              <a:defRPr sz="1800" b="1">
-                <a:solidFill>
-                  <a:srgbClr val="4A6FA5"/>
+              <a:defRPr sz="1700" b="1">
+                <a:solidFill>
+                  <a:srgbClr val="557DB9"/>
                 </a:solidFill>
                 <a:latin typeface="Segoe UI"/>
               </a:defRPr>
             </a:pPr>
             <a:r>
-              <a:t>Power Users &amp; Ergonomics</a:t>
+              <a:t>Workstation Power Users</a:t>
             </a:r>
           </a:p>
           <a:p>
@@ -4173,17 +4734,17 @@
                 <a:spcPts val="200"/>
               </a:spcBef>
               <a:spcAft>
-                <a:spcPts val="400"/>
+                <a:spcPts val="600"/>
               </a:spcAft>
-              <a:defRPr sz="1200" b="1">
-                <a:solidFill>
-                  <a:srgbClr val="8A8D93"/>
-                </a:solidFill>
-                <a:latin typeface="Segoe UI"/>
+              <a:defRPr sz="1000" b="1">
+                <a:solidFill>
+                  <a:srgbClr val="91949B"/>
+                </a:solidFill>
+                <a:latin typeface="Consolas"/>
               </a:defRPr>
             </a:pPr>
             <a:r>
-              <a:t>Workstation Operators &amp; Accessibility</a:t>
+              <a:t>MULTI-MONITOR &amp; ERGONOMICS</a:t>
             </a:r>
           </a:p>
           <a:p>
@@ -4191,15 +4752,33 @@
               <a:spcBef>
                 <a:spcPts val="600"/>
               </a:spcBef>
-              <a:defRPr sz="1300">
+            </a:pPr>
+            <a:r>
+              <a:rPr b="1" sz="1300">
+                <a:solidFill>
+                  <a:srgbClr val="557DB9"/>
+                </a:solidFill>
+                <a:latin typeface="Segoe UI"/>
+              </a:rPr>
+              <a:t>• </a:t>
+            </a:r>
+            <a:r>
+              <a:rPr b="1" sz="1300">
                 <a:solidFill>
                   <a:srgbClr val="F2EFE9"/>
                 </a:solidFill>
                 <a:latin typeface="Segoe UI"/>
-              </a:defRPr>
-            </a:pPr>
-            <a:r>
-              <a:t>• Profile: Multi-monitor developers, creative pros, and users managing RSI/carpal tunnel fatigue.</a:t>
+              </a:rPr>
+              <a:t>Daily Profile: </a:t>
+            </a:r>
+            <a:r>
+              <a:rPr sz="1300">
+                <a:solidFill>
+                  <a:srgbClr val="91949B"/>
+                </a:solidFill>
+                <a:latin typeface="Segoe UI"/>
+              </a:rPr>
+              <a:t>Software developers, video editors, and heavy multi-taskers</a:t>
             </a:r>
           </a:p>
           <a:p>
@@ -4207,15 +4786,33 @@
               <a:spcBef>
                 <a:spcPts val="600"/>
               </a:spcBef>
-              <a:defRPr sz="1300">
+            </a:pPr>
+            <a:r>
+              <a:rPr b="1" sz="1300">
+                <a:solidFill>
+                  <a:srgbClr val="557DB9"/>
+                </a:solidFill>
+                <a:latin typeface="Segoe UI"/>
+              </a:rPr>
+              <a:t>• </a:t>
+            </a:r>
+            <a:r>
+              <a:rPr b="1" sz="1300">
                 <a:solidFill>
                   <a:srgbClr val="F2EFE9"/>
                 </a:solidFill>
                 <a:latin typeface="Segoe UI"/>
-              </a:defRPr>
-            </a:pPr>
-            <a:r>
-              <a:t>• Pain Point: Constant Alt-Tab context switching to adjust media volume or tracks interrupts deep flow.</a:t>
+              </a:rPr>
+              <a:t>Core Frustration: </a:t>
+            </a:r>
+            <a:r>
+              <a:rPr sz="1300">
+                <a:solidFill>
+                  <a:srgbClr val="91949B"/>
+                </a:solidFill>
+                <a:latin typeface="Segoe UI"/>
+              </a:rPr>
+              <a:t>Breaking flow and Alt-Tabbing just to adjust volume or tracks</a:t>
             </a:r>
           </a:p>
           <a:p>
@@ -4223,15 +4820,33 @@
               <a:spcBef>
                 <a:spcPts val="600"/>
               </a:spcBef>
-              <a:defRPr sz="1300">
+            </a:pPr>
+            <a:r>
+              <a:rPr b="1" sz="1300">
+                <a:solidFill>
+                  <a:srgbClr val="557DB9"/>
+                </a:solidFill>
+                <a:latin typeface="Segoe UI"/>
+              </a:rPr>
+              <a:t>• </a:t>
+            </a:r>
+            <a:r>
+              <a:rPr b="1" sz="1300">
                 <a:solidFill>
                   <a:srgbClr val="F2EFE9"/>
                 </a:solidFill>
                 <a:latin typeface="Segoe UI"/>
-              </a:defRPr>
-            </a:pPr>
-            <a:r>
-              <a:t>• ZeroTouch Value: Frictionless spatial volume and media playback without stealing active keyboard focus.</a:t>
+              </a:rPr>
+              <a:t>ZeroTouch Superpower: </a:t>
+            </a:r>
+            <a:r>
+              <a:rPr sz="1300">
+                <a:solidFill>
+                  <a:srgbClr val="91949B"/>
+                </a:solidFill>
+                <a:latin typeface="Segoe UI"/>
+              </a:rPr>
+              <a:t>Spatial volume and track controls without stealing keyboard focus</a:t>
             </a:r>
           </a:p>
           <a:p>
@@ -4239,15 +4854,33 @@
               <a:spcBef>
                 <a:spcPts val="600"/>
               </a:spcBef>
-              <a:defRPr sz="1300">
+            </a:pPr>
+            <a:r>
+              <a:rPr b="1" sz="1300">
+                <a:solidFill>
+                  <a:srgbClr val="557DB9"/>
+                </a:solidFill>
+                <a:latin typeface="Segoe UI"/>
+              </a:rPr>
+              <a:t>• </a:t>
+            </a:r>
+            <a:r>
+              <a:rPr b="1" sz="1300">
                 <a:solidFill>
                   <a:srgbClr val="F2EFE9"/>
                 </a:solidFill>
                 <a:latin typeface="Segoe UI"/>
-              </a:defRPr>
-            </a:pPr>
-            <a:r>
-              <a:t>• Accessibility: Effortless micro-gestures reduce repetitive wrist and finger strain from mouse clutching.</a:t>
+              </a:rPr>
+              <a:t>Ergonomic Relief: </a:t>
+            </a:r>
+            <a:r>
+              <a:rPr sz="1300">
+                <a:solidFill>
+                  <a:srgbClr val="91949B"/>
+                </a:solidFill>
+                <a:latin typeface="Segoe UI"/>
+              </a:rPr>
+              <a:t>Hands-free micro-gestures reduce repetitive mouse-clutching strain (RSI)</a:t>
             </a:r>
           </a:p>
         </p:txBody>
@@ -4321,7 +4954,7 @@
         </p:nvSpPr>
         <p:spPr>
           <a:xfrm>
-            <a:off x="731520" y="502920"/>
+            <a:off x="731520" y="475488"/>
             <a:ext cx="10728655" cy="1005840"/>
           </a:xfrm>
           <a:prstGeom prst="rect">
@@ -4344,15 +4977,15 @@
               </a:defRPr>
             </a:pPr>
             <a:r>
-              <a:t>03 • SPATIAL WORKFLOW</a:t>
+              <a:t>03 • COMPUTER VISION DEFENSE</a:t>
             </a:r>
           </a:p>
           <a:p>
             <a:pPr>
               <a:spcBef>
-                <a:spcPts val="400"/>
+                <a:spcPts val="300"/>
               </a:spcBef>
-              <a:defRPr sz="2600" b="1">
+              <a:defRPr sz="2500" b="1">
                 <a:solidFill>
                   <a:srgbClr val="F2EFE9"/>
                 </a:solidFill>
@@ -4360,7 +4993,7 @@
               </a:defRPr>
             </a:pPr>
             <a:r>
-              <a:t>Context-Aware Architecture: One Engine, Three Modes</a:t>
+              <a:t>Noise Defense: Eliminating False Triggers</a:t>
             </a:r>
           </a:p>
         </p:txBody>
@@ -4373,8 +5006,8 @@
         </p:nvSpPr>
         <p:spPr>
           <a:xfrm>
-            <a:off x="731520" y="1737360"/>
-            <a:ext cx="3383280" cy="4389120"/>
+            <a:off x="731520" y="1691640"/>
+            <a:ext cx="5120640" cy="2148840"/>
           </a:xfrm>
           <a:prstGeom prst="roundRect">
             <a:avLst/>
@@ -4382,7 +5015,7 @@
           <a:solidFill>
             <a:srgbClr val="181820"/>
           </a:solidFill>
-          <a:ln w="12700">
+          <a:ln w="15240">
             <a:solidFill>
               <a:srgbClr val="D4AF6A"/>
             </a:solidFill>
@@ -4418,8 +5051,8 @@
         </p:nvSpPr>
         <p:spPr>
           <a:xfrm>
-            <a:off x="960120" y="1965960"/>
-            <a:ext cx="2926080" cy="3931920"/>
+            <a:off x="950976" y="1892808"/>
+            <a:ext cx="4681728" cy="1746504"/>
           </a:xfrm>
           <a:prstGeom prst="rect">
             <a:avLst/>
@@ -4433,7 +5066,7 @@
           <a:lstStyle/>
           <a:p>
             <a:pPr>
-              <a:defRPr sz="1800" b="1">
+              <a:defRPr sz="1600" b="1">
                 <a:solidFill>
                   <a:srgbClr val="D4AF6A"/>
                 </a:solidFill>
@@ -4441,7 +5074,26 @@
               </a:defRPr>
             </a:pPr>
             <a:r>
-              <a:t>Presentation Mode</a:t>
+              <a:t>Smart Activity Lockout</a:t>
+            </a:r>
+          </a:p>
+          <a:p>
+            <a:pPr>
+              <a:spcBef>
+                <a:spcPts val="200"/>
+              </a:spcBef>
+              <a:spcAft>
+                <a:spcPts val="600"/>
+              </a:spcAft>
+              <a:defRPr sz="1000" b="1">
+                <a:solidFill>
+                  <a:srgbClr val="91949B"/>
+                </a:solidFill>
+                <a:latin typeface="Consolas"/>
+              </a:defRPr>
+            </a:pPr>
+            <a:r>
+              <a:t>TYPE &amp; CLICK DETECTION</a:t>
             </a:r>
           </a:p>
           <a:p>
@@ -4449,15 +5101,33 @@
               <a:spcBef>
                 <a:spcPts val="600"/>
               </a:spcBef>
-              <a:defRPr sz="1300">
+            </a:pPr>
+            <a:r>
+              <a:rPr b="1" sz="1200">
+                <a:solidFill>
+                  <a:srgbClr val="D4AF6A"/>
+                </a:solidFill>
+                <a:latin typeface="Segoe UI"/>
+              </a:rPr>
+              <a:t>• </a:t>
+            </a:r>
+            <a:r>
+              <a:rPr b="1" sz="1200">
                 <a:solidFill>
                   <a:srgbClr val="F2EFE9"/>
                 </a:solidFill>
                 <a:latin typeface="Segoe UI"/>
-              </a:defRPr>
-            </a:pPr>
-            <a:r>
-              <a:t>• Targets: PowerPoint, Google Slides, Keynote, PDF Reader.</a:t>
+              </a:rPr>
+              <a:t>Hardware Intercept: </a:t>
+            </a:r>
+            <a:r>
+              <a:rPr sz="1200">
+                <a:solidFill>
+                  <a:srgbClr val="91949B"/>
+                </a:solidFill>
+                <a:latin typeface="Segoe UI"/>
+              </a:rPr>
+              <a:t>Global pynput hooks detect active typing &amp; mouse clicks</a:t>
             </a:r>
           </a:p>
           <a:p>
@@ -4465,47 +5135,33 @@
               <a:spcBef>
                 <a:spcPts val="600"/>
               </a:spcBef>
-              <a:defRPr sz="1300">
+            </a:pPr>
+            <a:r>
+              <a:rPr b="1" sz="1200">
+                <a:solidFill>
+                  <a:srgbClr val="D4AF6A"/>
+                </a:solidFill>
+                <a:latin typeface="Segoe UI"/>
+              </a:rPr>
+              <a:t>• </a:t>
+            </a:r>
+            <a:r>
+              <a:rPr b="1" sz="1200">
                 <a:solidFill>
                   <a:srgbClr val="F2EFE9"/>
                 </a:solidFill>
                 <a:latin typeface="Segoe UI"/>
-              </a:defRPr>
-            </a:pPr>
-            <a:r>
-              <a:t>• Back-of-Hand Swipe: Advance (Right) or return (Left) slides seamlessly across the room.</a:t>
-            </a:r>
-          </a:p>
-          <a:p>
-            <a:pPr>
-              <a:spcBef>
-                <a:spcPts val="600"/>
-              </a:spcBef>
-              <a:defRPr sz="1300">
-                <a:solidFill>
-                  <a:srgbClr val="F2EFE9"/>
-                </a:solidFill>
-                <a:latin typeface="Segoe UI"/>
-              </a:defRPr>
-            </a:pPr>
-            <a:r>
-              <a:t>• Open Palm Hold (0.5s): Blank/resume screen ('B').</a:t>
-            </a:r>
-          </a:p>
-          <a:p>
-            <a:pPr>
-              <a:spcBef>
-                <a:spcPts val="600"/>
-              </a:spcBef>
-              <a:defRPr sz="1300">
-                <a:solidFill>
-                  <a:srgbClr val="F2EFE9"/>
-                </a:solidFill>
-                <a:latin typeface="Segoe UI"/>
-              </a:defRPr>
-            </a:pPr>
-            <a:r>
-              <a:t>• Stage Optimization: Disengages desk gaze lockouts so presenters can look at audience or slides freely.</a:t>
+              </a:rPr>
+              <a:t>Smart Sleep: </a:t>
+            </a:r>
+            <a:r>
+              <a:rPr sz="1200">
+                <a:solidFill>
+                  <a:srgbClr val="91949B"/>
+                </a:solidFill>
+                <a:latin typeface="Segoe UI"/>
+              </a:rPr>
+              <a:t>Gestures instantly sleep while typing; zero accidental misfires</a:t>
             </a:r>
           </a:p>
         </p:txBody>
@@ -4518,8 +5174,8 @@
         </p:nvSpPr>
         <p:spPr>
           <a:xfrm>
-            <a:off x="4389120" y="1737360"/>
-            <a:ext cx="3383280" cy="4389120"/>
+            <a:off x="731520" y="4023360"/>
+            <a:ext cx="5120640" cy="2148840"/>
           </a:xfrm>
           <a:prstGeom prst="roundRect">
             <a:avLst/>
@@ -4527,7 +5183,7 @@
           <a:solidFill>
             <a:srgbClr val="181820"/>
           </a:solidFill>
-          <a:ln w="12700">
+          <a:ln w="15240">
             <a:solidFill>
               <a:srgbClr val="F2EFE9"/>
             </a:solidFill>
@@ -4563,8 +5219,8 @@
         </p:nvSpPr>
         <p:spPr>
           <a:xfrm>
-            <a:off x="4617720" y="1965960"/>
-            <a:ext cx="2926080" cy="3931920"/>
+            <a:off x="950976" y="4224528"/>
+            <a:ext cx="4681728" cy="1746504"/>
           </a:xfrm>
           <a:prstGeom prst="rect">
             <a:avLst/>
@@ -4578,7 +5234,7 @@
           <a:lstStyle/>
           <a:p>
             <a:pPr>
-              <a:defRPr sz="1800" b="1">
+              <a:defRPr sz="1600" b="1">
                 <a:solidFill>
                   <a:srgbClr val="F2EFE9"/>
                 </a:solidFill>
@@ -4586,7 +5242,26 @@
               </a:defRPr>
             </a:pPr>
             <a:r>
-              <a:t>Video Meeting Mode</a:t>
+              <a:t>Gaze-Clutch™ Technology</a:t>
+            </a:r>
+          </a:p>
+          <a:p>
+            <a:pPr>
+              <a:spcBef>
+                <a:spcPts val="200"/>
+              </a:spcBef>
+              <a:spcAft>
+                <a:spcPts val="600"/>
+              </a:spcAft>
+              <a:defRPr sz="1000" b="1">
+                <a:solidFill>
+                  <a:srgbClr val="91949B"/>
+                </a:solidFill>
+                <a:latin typeface="Consolas"/>
+              </a:defRPr>
+            </a:pPr>
+            <a:r>
+              <a:t>LOOK-TO-CONTROL</a:t>
             </a:r>
           </a:p>
           <a:p>
@@ -4594,15 +5269,33 @@
               <a:spcBef>
                 <a:spcPts val="600"/>
               </a:spcBef>
-              <a:defRPr sz="1300">
+            </a:pPr>
+            <a:r>
+              <a:rPr b="1" sz="1200">
                 <a:solidFill>
                   <a:srgbClr val="F2EFE9"/>
                 </a:solidFill>
                 <a:latin typeface="Segoe UI"/>
-              </a:defRPr>
-            </a:pPr>
-            <a:r>
-              <a:t>• Targets: Google Meet, Zoom, MS Teams, Webex.</a:t>
+              </a:rPr>
+              <a:t>• </a:t>
+            </a:r>
+            <a:r>
+              <a:rPr b="1" sz="1200">
+                <a:solidFill>
+                  <a:srgbClr val="F2EFE9"/>
+                </a:solidFill>
+                <a:latin typeface="Segoe UI"/>
+              </a:rPr>
+              <a:t>Head Yaw Telemetry: </a:t>
+            </a:r>
+            <a:r>
+              <a:rPr sz="1200">
+                <a:solidFill>
+                  <a:srgbClr val="91949B"/>
+                </a:solidFill>
+                <a:latin typeface="Segoe UI"/>
+              </a:rPr>
+              <a:t>Monitors 3D facial orientation and pupillary distance</a:t>
             </a:r>
           </a:p>
           <a:p>
@@ -4610,47 +5303,33 @@
               <a:spcBef>
                 <a:spcPts val="600"/>
               </a:spcBef>
-              <a:defRPr sz="1300">
+            </a:pPr>
+            <a:r>
+              <a:rPr b="1" sz="1200">
                 <a:solidFill>
                   <a:srgbClr val="F2EFE9"/>
                 </a:solidFill>
                 <a:latin typeface="Segoe UI"/>
-              </a:defRPr>
-            </a:pPr>
-            <a:r>
-              <a:t>• Ghost-Mute (Shh): Index finger to mouth directly toggles hardware mic via Windows Core Audio + in-app sync.</a:t>
-            </a:r>
-          </a:p>
-          <a:p>
-            <a:pPr>
-              <a:spcBef>
-                <a:spcPts val="600"/>
-              </a:spcBef>
-              <a:defRPr sz="1300">
+              </a:rPr>
+              <a:t>• </a:t>
+            </a:r>
+            <a:r>
+              <a:rPr b="1" sz="1200">
                 <a:solidFill>
                   <a:srgbClr val="F2EFE9"/>
                 </a:solidFill>
                 <a:latin typeface="Segoe UI"/>
-              </a:defRPr>
-            </a:pPr>
-            <a:r>
-              <a:t>• Open Palm Hold: Instant camera toggle (Ctrl+E in Meet, Ctrl+Shift+O in Teams, Alt+V in Zoom).</a:t>
-            </a:r>
-          </a:p>
-          <a:p>
-            <a:pPr>
-              <a:spcBef>
-                <a:spcPts val="600"/>
-              </a:spcBef>
-              <a:defRPr sz="1300">
-                <a:solidFill>
-                  <a:srgbClr val="F2EFE9"/>
-                </a:solidFill>
-                <a:latin typeface="Segoe UI"/>
-              </a:defRPr>
-            </a:pPr>
-            <a:r>
-              <a:t>• Back-of-Hand Swipe: Toggle People panel or Raise/Lower Hand without clicking.</a:t>
+              </a:rPr>
+              <a:t>Intent Verification: </a:t>
+            </a:r>
+            <a:r>
+              <a:rPr sz="1200">
+                <a:solidFill>
+                  <a:srgbClr val="91949B"/>
+                </a:solidFill>
+                <a:latin typeface="Segoe UI"/>
+              </a:rPr>
+              <a:t>Looking at other monitors automatically clutches gestures to standby</a:t>
             </a:r>
           </a:p>
         </p:txBody>
@@ -4663,8 +5342,8 @@
         </p:nvSpPr>
         <p:spPr>
           <a:xfrm>
-            <a:off x="8046720" y="1737360"/>
-            <a:ext cx="3383280" cy="4389120"/>
+            <a:off x="6217920" y="1691640"/>
+            <a:ext cx="5212080" cy="2148840"/>
           </a:xfrm>
           <a:prstGeom prst="roundRect">
             <a:avLst/>
@@ -4672,9 +5351,9 @@
           <a:solidFill>
             <a:srgbClr val="181820"/>
           </a:solidFill>
-          <a:ln w="12700">
+          <a:ln w="15240">
             <a:solidFill>
-              <a:srgbClr val="4A6FA5"/>
+              <a:srgbClr val="557DB9"/>
             </a:solidFill>
           </a:ln>
         </p:spPr>
@@ -4708,8 +5387,8 @@
         </p:nvSpPr>
         <p:spPr>
           <a:xfrm>
-            <a:off x="8275320" y="1965960"/>
-            <a:ext cx="2926080" cy="3931920"/>
+            <a:off x="6437376" y="1892808"/>
+            <a:ext cx="4773168" cy="1746504"/>
           </a:xfrm>
           <a:prstGeom prst="rect">
             <a:avLst/>
@@ -4723,15 +5402,34 @@
           <a:lstStyle/>
           <a:p>
             <a:pPr>
-              <a:defRPr sz="1800" b="1">
-                <a:solidFill>
-                  <a:srgbClr val="4A6FA5"/>
+              <a:defRPr sz="1600" b="1">
+                <a:solidFill>
+                  <a:srgbClr val="557DB9"/>
                 </a:solidFill>
                 <a:latin typeface="Segoe UI"/>
               </a:defRPr>
             </a:pPr>
             <a:r>
-              <a:t>Media &amp; Default Mode</a:t>
+              <a:t>ShoulderGuard™ Intruder Shield</a:t>
+            </a:r>
+          </a:p>
+          <a:p>
+            <a:pPr>
+              <a:spcBef>
+                <a:spcPts val="200"/>
+              </a:spcBef>
+              <a:spcAft>
+                <a:spcPts val="600"/>
+              </a:spcAft>
+              <a:defRPr sz="1000" b="1">
+                <a:solidFill>
+                  <a:srgbClr val="91949B"/>
+                </a:solidFill>
+                <a:latin typeface="Consolas"/>
+              </a:defRPr>
+            </a:pPr>
+            <a:r>
+              <a:t>PRIVACY PROTECTION</a:t>
             </a:r>
           </a:p>
           <a:p>
@@ -4739,15 +5437,33 @@
               <a:spcBef>
                 <a:spcPts val="600"/>
               </a:spcBef>
-              <a:defRPr sz="1300">
+            </a:pPr>
+            <a:r>
+              <a:rPr b="1" sz="1200">
+                <a:solidFill>
+                  <a:srgbClr val="557DB9"/>
+                </a:solidFill>
+                <a:latin typeface="Segoe UI"/>
+              </a:rPr>
+              <a:t>• </a:t>
+            </a:r>
+            <a:r>
+              <a:rPr b="1" sz="1200">
                 <a:solidFill>
                   <a:srgbClr val="F2EFE9"/>
                 </a:solidFill>
                 <a:latin typeface="Segoe UI"/>
-              </a:defRPr>
-            </a:pPr>
-            <a:r>
-              <a:t>• Targets: Spotify, YouTube, Netflix, Desktop.</a:t>
+              </a:rPr>
+              <a:t>Background Face Scan: </a:t>
+            </a:r>
+            <a:r>
+              <a:rPr sz="1200">
+                <a:solidFill>
+                  <a:srgbClr val="91949B"/>
+                </a:solidFill>
+                <a:latin typeface="Segoe UI"/>
+              </a:rPr>
+              <a:t>BlazeFace scans continuous periphery for shoulder surfers</a:t>
             </a:r>
           </a:p>
           <a:p>
@@ -4755,15 +5471,133 @@
               <a:spcBef>
                 <a:spcPts val="600"/>
               </a:spcBef>
-              <a:defRPr sz="1300">
+            </a:pPr>
+            <a:r>
+              <a:rPr b="1" sz="1200">
+                <a:solidFill>
+                  <a:srgbClr val="557DB9"/>
+                </a:solidFill>
+                <a:latin typeface="Segoe UI"/>
+              </a:rPr>
+              <a:t>• </a:t>
+            </a:r>
+            <a:r>
+              <a:rPr b="1" sz="1200">
                 <a:solidFill>
                   <a:srgbClr val="F2EFE9"/>
                 </a:solidFill>
                 <a:latin typeface="Segoe UI"/>
+              </a:rPr>
+              <a:t>Instant Boss Key: </a:t>
+            </a:r>
+            <a:r>
+              <a:rPr sz="1200">
+                <a:solidFill>
+                  <a:srgbClr val="91949B"/>
+                </a:solidFill>
+                <a:latin typeface="Segoe UI"/>
+              </a:rPr>
+              <a:t>Second face detected automatically minimizes to desktop (Win+D)</a:t>
+            </a:r>
+          </a:p>
+        </p:txBody>
+      </p:sp>
+      <p:sp>
+        <p:nvSpPr>
+          <p:cNvPr id="10" name="Rounded Rectangle 9"/>
+          <p:cNvSpPr/>
+          <p:nvPr/>
+        </p:nvSpPr>
+        <p:spPr>
+          <a:xfrm>
+            <a:off x="6217920" y="4023360"/>
+            <a:ext cx="5212080" cy="2148840"/>
+          </a:xfrm>
+          <a:prstGeom prst="roundRect">
+            <a:avLst/>
+          </a:prstGeom>
+          <a:solidFill>
+            <a:srgbClr val="181820"/>
+          </a:solidFill>
+          <a:ln w="15240">
+            <a:solidFill>
+              <a:srgbClr val="D4AF6A"/>
+            </a:solidFill>
+          </a:ln>
+        </p:spPr>
+        <p:style>
+          <a:lnRef idx="1">
+            <a:schemeClr val="accent1"/>
+          </a:lnRef>
+          <a:fillRef idx="3">
+            <a:schemeClr val="accent1"/>
+          </a:fillRef>
+          <a:effectRef idx="2">
+            <a:schemeClr val="accent1"/>
+          </a:effectRef>
+          <a:fontRef idx="minor">
+            <a:schemeClr val="lt1"/>
+          </a:fontRef>
+        </p:style>
+        <p:txBody>
+          <a:bodyPr rtlCol="0" anchor="ctr"/>
+          <a:lstStyle/>
+          <a:p>
+            <a:pPr algn="ctr"/>
+          </a:p>
+        </p:txBody>
+      </p:sp>
+      <p:sp>
+        <p:nvSpPr>
+          <p:cNvPr id="11" name="TextBox 10"/>
+          <p:cNvSpPr txBox="1"/>
+          <p:nvPr/>
+        </p:nvSpPr>
+        <p:spPr>
+          <a:xfrm>
+            <a:off x="6437376" y="4224528"/>
+            <a:ext cx="4773168" cy="1746504"/>
+          </a:xfrm>
+          <a:prstGeom prst="rect">
+            <a:avLst/>
+          </a:prstGeom>
+          <a:noFill/>
+        </p:spPr>
+        <p:txBody>
+          <a:bodyPr wrap="square">
+            <a:spAutoFit/>
+          </a:bodyPr>
+          <a:lstStyle/>
+          <a:p>
+            <a:pPr>
+              <a:defRPr sz="1600" b="1">
+                <a:solidFill>
+                  <a:srgbClr val="D4AF6A"/>
+                </a:solidFill>
+                <a:latin typeface="Segoe UI"/>
               </a:defRPr>
             </a:pPr>
             <a:r>
-              <a:t>• Open Palm Hold: Smooth play/pause toggle.</a:t>
+              <a:t>Body Ownership &amp; Physics Engine</a:t>
+            </a:r>
+          </a:p>
+          <a:p>
+            <a:pPr>
+              <a:spcBef>
+                <a:spcPts val="200"/>
+              </a:spcBef>
+              <a:spcAft>
+                <a:spcPts val="600"/>
+              </a:spcAft>
+              <a:defRPr sz="1000" b="1">
+                <a:solidFill>
+                  <a:srgbClr val="91949B"/>
+                </a:solidFill>
+                <a:latin typeface="Consolas"/>
+              </a:defRPr>
+            </a:pPr>
+            <a:r>
+              <a:t>ANTI-JITTER &amp; REACH BOUNDS</a:t>
             </a:r>
           </a:p>
           <a:p>
@@ -4771,15 +5605,33 @@
               <a:spcBef>
                 <a:spcPts val="600"/>
               </a:spcBef>
-              <a:defRPr sz="1300">
+            </a:pPr>
+            <a:r>
+              <a:rPr b="1" sz="1200">
+                <a:solidFill>
+                  <a:srgbClr val="D4AF6A"/>
+                </a:solidFill>
+                <a:latin typeface="Segoe UI"/>
+              </a:rPr>
+              <a:t>• </a:t>
+            </a:r>
+            <a:r>
+              <a:rPr b="1" sz="1200">
                 <a:solidFill>
                   <a:srgbClr val="F2EFE9"/>
                 </a:solidFill>
                 <a:latin typeface="Segoe UI"/>
-              </a:defRPr>
-            </a:pPr>
-            <a:r>
-              <a:t>• Dynamic Vertical Pinch: Continuous master volume control with live capsule HUD updates.</a:t>
+              </a:rPr>
+              <a:t>Passerby Rejection: </a:t>
+            </a:r>
+            <a:r>
+              <a:rPr sz="1200">
+                <a:solidFill>
+                  <a:srgbClr val="91949B"/>
+                </a:solidFill>
+                <a:latin typeface="Segoe UI"/>
+              </a:rPr>
+              <a:t>Locks control to primary user; rejects background passerby hands</a:t>
             </a:r>
           </a:p>
           <a:p>
@@ -4787,15 +5639,33 @@
               <a:spcBef>
                 <a:spcPts val="600"/>
               </a:spcBef>
-              <a:defRPr sz="1300">
+            </a:pPr>
+            <a:r>
+              <a:rPr b="1" sz="1200">
+                <a:solidFill>
+                  <a:srgbClr val="D4AF6A"/>
+                </a:solidFill>
+                <a:latin typeface="Segoe UI"/>
+              </a:rPr>
+              <a:t>• </a:t>
+            </a:r>
+            <a:r>
+              <a:rPr b="1" sz="1200">
                 <a:solidFill>
                   <a:srgbClr val="F2EFE9"/>
                 </a:solidFill>
                 <a:latin typeface="Segoe UI"/>
-              </a:defRPr>
-            </a:pPr>
-            <a:r>
-              <a:t>• Back-of-Hand Swipe: Skip or previous track.</a:t>
+              </a:rPr>
+              <a:t>Bone Length Physics: </a:t>
+            </a:r>
+            <a:r>
+              <a:rPr sz="1200">
+                <a:solidFill>
+                  <a:srgbClr val="91949B"/>
+                </a:solidFill>
+                <a:latin typeface="Segoe UI"/>
+              </a:rPr>
+              <a:t>Freezes hallucinated joints when gripping phones or objects</a:t>
             </a:r>
           </a:p>
         </p:txBody>
@@ -4869,7 +5739,7 @@
         </p:nvSpPr>
         <p:spPr>
           <a:xfrm>
-            <a:off x="731520" y="502920"/>
+            <a:off x="731520" y="475488"/>
             <a:ext cx="10728655" cy="1005840"/>
           </a:xfrm>
           <a:prstGeom prst="rect">
@@ -4892,15 +5762,15 @@
               </a:defRPr>
             </a:pPr>
             <a:r>
-              <a:t>04 • COMPUTER VISION DEFENSE</a:t>
+              <a:t>04 • ARCHITECTURE &amp; SUMMARY</a:t>
             </a:r>
           </a:p>
           <a:p>
             <a:pPr>
               <a:spcBef>
-                <a:spcPts val="400"/>
+                <a:spcPts val="300"/>
               </a:spcBef>
-              <a:defRPr sz="2600" b="1">
+              <a:defRPr sz="2500" b="1">
                 <a:solidFill>
                   <a:srgbClr val="F2EFE9"/>
                 </a:solidFill>
@@ -4908,7 +5778,7 @@
               </a:defRPr>
             </a:pPr>
             <a:r>
-              <a:t>Noise Defense: How We Eliminated False Triggers</a:t>
+              <a:t>Engineering Architecture &amp; Why ZeroTouch Wins</a:t>
             </a:r>
           </a:p>
         </p:txBody>
@@ -4921,8 +5791,8 @@
         </p:nvSpPr>
         <p:spPr>
           <a:xfrm>
-            <a:off x="731520" y="1737360"/>
-            <a:ext cx="5120640" cy="2103120"/>
+            <a:off x="731520" y="1691640"/>
+            <a:ext cx="5120640" cy="4480560"/>
           </a:xfrm>
           <a:prstGeom prst="roundRect">
             <a:avLst/>
@@ -4930,7 +5800,243 @@
           <a:solidFill>
             <a:srgbClr val="181820"/>
           </a:solidFill>
-          <a:ln w="12700">
+          <a:ln w="15240">
+            <a:solidFill>
+              <a:srgbClr val="557DB9"/>
+            </a:solidFill>
+          </a:ln>
+        </p:spPr>
+        <p:style>
+          <a:lnRef idx="1">
+            <a:schemeClr val="accent1"/>
+          </a:lnRef>
+          <a:fillRef idx="3">
+            <a:schemeClr val="accent1"/>
+          </a:fillRef>
+          <a:effectRef idx="2">
+            <a:schemeClr val="accent1"/>
+          </a:effectRef>
+          <a:fontRef idx="minor">
+            <a:schemeClr val="lt1"/>
+          </a:fontRef>
+        </p:style>
+        <p:txBody>
+          <a:bodyPr rtlCol="0" anchor="ctr"/>
+          <a:lstStyle/>
+          <a:p>
+            <a:pPr algn="ctr"/>
+          </a:p>
+        </p:txBody>
+      </p:sp>
+      <p:sp>
+        <p:nvSpPr>
+          <p:cNvPr id="5" name="TextBox 4"/>
+          <p:cNvSpPr txBox="1"/>
+          <p:nvPr/>
+        </p:nvSpPr>
+        <p:spPr>
+          <a:xfrm>
+            <a:off x="950976" y="1892808"/>
+            <a:ext cx="4681728" cy="4078224"/>
+          </a:xfrm>
+          <a:prstGeom prst="rect">
+            <a:avLst/>
+          </a:prstGeom>
+          <a:noFill/>
+        </p:spPr>
+        <p:txBody>
+          <a:bodyPr wrap="square">
+            <a:spAutoFit/>
+          </a:bodyPr>
+          <a:lstStyle/>
+          <a:p>
+            <a:pPr>
+              <a:defRPr sz="1700" b="1">
+                <a:solidFill>
+                  <a:srgbClr val="557DB9"/>
+                </a:solidFill>
+                <a:latin typeface="Segoe UI"/>
+              </a:defRPr>
+            </a:pPr>
+            <a:r>
+              <a:t>High-Performance Architecture</a:t>
+            </a:r>
+          </a:p>
+          <a:p>
+            <a:pPr>
+              <a:spcBef>
+                <a:spcPts val="200"/>
+              </a:spcBef>
+              <a:spcAft>
+                <a:spcPts val="600"/>
+              </a:spcAft>
+              <a:defRPr sz="1000" b="1">
+                <a:solidFill>
+                  <a:srgbClr val="91949B"/>
+                </a:solidFill>
+                <a:latin typeface="Consolas"/>
+              </a:defRPr>
+            </a:pPr>
+            <a:r>
+              <a:t>WINDOWS OS INTEGRATION</a:t>
+            </a:r>
+          </a:p>
+          <a:p>
+            <a:pPr>
+              <a:spcBef>
+                <a:spcPts val="600"/>
+              </a:spcBef>
+            </a:pPr>
+            <a:r>
+              <a:rPr b="1" sz="1300">
+                <a:solidFill>
+                  <a:srgbClr val="557DB9"/>
+                </a:solidFill>
+                <a:latin typeface="Segoe UI"/>
+              </a:rPr>
+              <a:t>• </a:t>
+            </a:r>
+            <a:r>
+              <a:rPr b="1" sz="1300">
+                <a:solidFill>
+                  <a:srgbClr val="F2EFE9"/>
+                </a:solidFill>
+                <a:latin typeface="Segoe UI"/>
+              </a:rPr>
+              <a:t>Zero-Copy Shared Memory: </a:t>
+            </a:r>
+            <a:r>
+              <a:rPr sz="1300">
+                <a:solidFill>
+                  <a:srgbClr val="91949B"/>
+                </a:solidFill>
+                <a:latin typeface="Segoe UI"/>
+              </a:rPr>
+              <a:t>multiprocessing.shared_memory streams 30 FPS HUD previews</a:t>
+            </a:r>
+          </a:p>
+          <a:p>
+            <a:pPr>
+              <a:spcBef>
+                <a:spcPts val="600"/>
+              </a:spcBef>
+            </a:pPr>
+            <a:r>
+              <a:rPr b="1" sz="1300">
+                <a:solidFill>
+                  <a:srgbClr val="557DB9"/>
+                </a:solidFill>
+                <a:latin typeface="Segoe UI"/>
+              </a:rPr>
+              <a:t>• </a:t>
+            </a:r>
+            <a:r>
+              <a:rPr b="1" sz="1300">
+                <a:solidFill>
+                  <a:srgbClr val="F2EFE9"/>
+                </a:solidFill>
+                <a:latin typeface="Segoe UI"/>
+              </a:rPr>
+              <a:t>Hardware Audio Core: </a:t>
+            </a:r>
+            <a:r>
+              <a:rPr sz="1300">
+                <a:solidFill>
+                  <a:srgbClr val="91949B"/>
+                </a:solidFill>
+                <a:latin typeface="Segoe UI"/>
+              </a:rPr>
+              <a:t>Direct Windows Core Audio (PyCAW) input endpoint volume mute</a:t>
+            </a:r>
+          </a:p>
+          <a:p>
+            <a:pPr>
+              <a:spcBef>
+                <a:spcPts val="600"/>
+              </a:spcBef>
+            </a:pPr>
+            <a:r>
+              <a:rPr b="1" sz="1300">
+                <a:solidFill>
+                  <a:srgbClr val="557DB9"/>
+                </a:solidFill>
+                <a:latin typeface="Segoe UI"/>
+              </a:rPr>
+              <a:t>• </a:t>
+            </a:r>
+            <a:r>
+              <a:rPr b="1" sz="1300">
+                <a:solidFill>
+                  <a:srgbClr val="F2EFE9"/>
+                </a:solidFill>
+                <a:latin typeface="Segoe UI"/>
+              </a:rPr>
+              <a:t>Native Camera Sharing: </a:t>
+            </a:r>
+            <a:r>
+              <a:rPr sz="1300">
+                <a:solidFill>
+                  <a:srgbClr val="91949B"/>
+                </a:solidFill>
+                <a:latin typeface="Segoe UI"/>
+              </a:rPr>
+              <a:t>OpenCV MSMF backend hooks svchost Camera for multi-app streaming</a:t>
+            </a:r>
+          </a:p>
+          <a:p>
+            <a:pPr>
+              <a:spcBef>
+                <a:spcPts val="600"/>
+              </a:spcBef>
+            </a:pPr>
+            <a:r>
+              <a:rPr b="1" sz="1300">
+                <a:solidFill>
+                  <a:srgbClr val="557DB9"/>
+                </a:solidFill>
+                <a:latin typeface="Segoe UI"/>
+              </a:rPr>
+              <a:t>• </a:t>
+            </a:r>
+            <a:r>
+              <a:rPr b="1" sz="1300">
+                <a:solidFill>
+                  <a:srgbClr val="F2EFE9"/>
+                </a:solidFill>
+                <a:latin typeface="Segoe UI"/>
+              </a:rPr>
+              <a:t>Executive Ambient HUD: </a:t>
+            </a:r>
+            <a:r>
+              <a:rPr sz="1300">
+                <a:solidFill>
+                  <a:srgbClr val="91949B"/>
+                </a:solidFill>
+                <a:latin typeface="Segoe UI"/>
+              </a:rPr>
+              <a:t>CustomTkinter dashboard + always-on-top champagne micro-pill</a:t>
+            </a:r>
+          </a:p>
+        </p:txBody>
+      </p:sp>
+      <p:sp>
+        <p:nvSpPr>
+          <p:cNvPr id="6" name="Rounded Rectangle 5"/>
+          <p:cNvSpPr/>
+          <p:nvPr/>
+        </p:nvSpPr>
+        <p:spPr>
+          <a:xfrm>
+            <a:off x="6217920" y="1691640"/>
+            <a:ext cx="5212080" cy="4480560"/>
+          </a:xfrm>
+          <a:prstGeom prst="roundRect">
+            <a:avLst/>
+          </a:prstGeom>
+          <a:solidFill>
+            <a:srgbClr val="181820"/>
+          </a:solidFill>
+          <a:ln w="15240">
             <a:solidFill>
               <a:srgbClr val="D4AF6A"/>
             </a:solidFill>
@@ -4960,14 +6066,14 @@
       </p:sp>
       <p:sp>
         <p:nvSpPr>
-          <p:cNvPr id="5" name="TextBox 4"/>
+          <p:cNvPr id="7" name="TextBox 6"/>
           <p:cNvSpPr txBox="1"/>
           <p:nvPr/>
         </p:nvSpPr>
         <p:spPr>
           <a:xfrm>
-            <a:off x="960120" y="1965960"/>
-            <a:ext cx="4663440" cy="1645920"/>
+            <a:off x="6437376" y="1892808"/>
+            <a:ext cx="4773168" cy="4078224"/>
           </a:xfrm>
           <a:prstGeom prst="rect">
             <a:avLst/>
@@ -4981,7 +6087,7 @@
           <a:lstStyle/>
           <a:p>
             <a:pPr>
-              <a:defRPr sz="1800" b="1">
+              <a:defRPr sz="1700" b="1">
                 <a:solidFill>
                   <a:srgbClr val="D4AF6A"/>
                 </a:solidFill>
@@ -4989,7 +6095,26 @@
               </a:defRPr>
             </a:pPr>
             <a:r>
-              <a:t>Smart Activity Lockout (Type &amp; Click)</a:t>
+              <a:t>Why ZeroTouch Wins</a:t>
+            </a:r>
+          </a:p>
+          <a:p>
+            <a:pPr>
+              <a:spcBef>
+                <a:spcPts val="200"/>
+              </a:spcBef>
+              <a:spcAft>
+                <a:spcPts val="600"/>
+              </a:spcAft>
+              <a:defRPr sz="1000" b="1">
+                <a:solidFill>
+                  <a:srgbClr val="91949B"/>
+                </a:solidFill>
+                <a:latin typeface="Consolas"/>
+              </a:defRPr>
+            </a:pPr>
+            <a:r>
+              <a:t>EXECUTIVE PRODUCTION POLISH</a:t>
             </a:r>
           </a:p>
           <a:p>
@@ -4997,15 +6122,33 @@
               <a:spcBef>
                 <a:spcPts val="600"/>
               </a:spcBef>
-              <a:defRPr sz="1300">
+            </a:pPr>
+            <a:r>
+              <a:rPr b="1" sz="1300">
+                <a:solidFill>
+                  <a:srgbClr val="D4AF6A"/>
+                </a:solidFill>
+                <a:latin typeface="Segoe UI"/>
+              </a:rPr>
+              <a:t>• </a:t>
+            </a:r>
+            <a:r>
+              <a:rPr b="1" sz="1300">
                 <a:solidFill>
                   <a:srgbClr val="F2EFE9"/>
                 </a:solidFill>
                 <a:latin typeface="Segoe UI"/>
-              </a:defRPr>
-            </a:pPr>
-            <a:r>
-              <a:t>• Background hardware hooks (Pynput) detect keyboard typing and mouse clicks.</a:t>
+              </a:rPr>
+              <a:t>Production Finish: </a:t>
+            </a:r>
+            <a:r>
+              <a:rPr sz="1300">
+                <a:solidFill>
+                  <a:srgbClr val="91949B"/>
+                </a:solidFill>
+                <a:latin typeface="Segoe UI"/>
+              </a:rPr>
+              <a:t>1-click silent background launcher, custom taskbar brand &amp; tray icon</a:t>
             </a:r>
           </a:p>
           <a:p>
@@ -5013,96 +6156,33 @@
               <a:spcBef>
                 <a:spcPts val="600"/>
               </a:spcBef>
-              <a:defRPr sz="1300">
+            </a:pPr>
+            <a:r>
+              <a:rPr b="1" sz="1300">
+                <a:solidFill>
+                  <a:srgbClr val="D4AF6A"/>
+                </a:solidFill>
+                <a:latin typeface="Segoe UI"/>
+              </a:rPr>
+              <a:t>• </a:t>
+            </a:r>
+            <a:r>
+              <a:rPr b="1" sz="1300">
                 <a:solidFill>
                   <a:srgbClr val="F2EFE9"/>
                 </a:solidFill>
                 <a:latin typeface="Segoe UI"/>
-              </a:defRPr>
-            </a:pPr>
-            <a:r>
-              <a:t>• While typing or resting hands above keyboard, gestures sleep to prevent false firing.</a:t>
-            </a:r>
-          </a:p>
-        </p:txBody>
-      </p:sp>
-      <p:sp>
-        <p:nvSpPr>
-          <p:cNvPr id="6" name="Rounded Rectangle 5"/>
-          <p:cNvSpPr/>
-          <p:nvPr/>
-        </p:nvSpPr>
-        <p:spPr>
-          <a:xfrm>
-            <a:off x="731520" y="4069080"/>
-            <a:ext cx="5120640" cy="2103120"/>
-          </a:xfrm>
-          <a:prstGeom prst="roundRect">
-            <a:avLst/>
-          </a:prstGeom>
-          <a:solidFill>
-            <a:srgbClr val="181820"/>
-          </a:solidFill>
-          <a:ln w="12700">
-            <a:solidFill>
-              <a:srgbClr val="F2EFE9"/>
-            </a:solidFill>
-          </a:ln>
-        </p:spPr>
-        <p:style>
-          <a:lnRef idx="1">
-            <a:schemeClr val="accent1"/>
-          </a:lnRef>
-          <a:fillRef idx="3">
-            <a:schemeClr val="accent1"/>
-          </a:fillRef>
-          <a:effectRef idx="2">
-            <a:schemeClr val="accent1"/>
-          </a:effectRef>
-          <a:fontRef idx="minor">
-            <a:schemeClr val="lt1"/>
-          </a:fontRef>
-        </p:style>
-        <p:txBody>
-          <a:bodyPr rtlCol="0" anchor="ctr"/>
-          <a:lstStyle/>
-          <a:p>
-            <a:pPr algn="ctr"/>
-          </a:p>
-        </p:txBody>
-      </p:sp>
-      <p:sp>
-        <p:nvSpPr>
-          <p:cNvPr id="7" name="TextBox 6"/>
-          <p:cNvSpPr txBox="1"/>
-          <p:nvPr/>
-        </p:nvSpPr>
-        <p:spPr>
-          <a:xfrm>
-            <a:off x="960120" y="4297680"/>
-            <a:ext cx="4663440" cy="1645920"/>
-          </a:xfrm>
-          <a:prstGeom prst="rect">
-            <a:avLst/>
-          </a:prstGeom>
-          <a:noFill/>
-        </p:spPr>
-        <p:txBody>
-          <a:bodyPr wrap="square">
-            <a:spAutoFit/>
-          </a:bodyPr>
-          <a:lstStyle/>
-          <a:p>
-            <a:pPr>
-              <a:defRPr sz="1800" b="1">
-                <a:solidFill>
-                  <a:srgbClr val="F2EFE9"/>
-                </a:solidFill>
-                <a:latin typeface="Segoe UI"/>
-              </a:defRPr>
-            </a:pPr>
-            <a:r>
-              <a:t>Gaze-Clutch (Look-to-Control)</a:t>
+              </a:rPr>
+              <a:t>No Hardware Needed: </a:t>
+            </a:r>
+            <a:r>
+              <a:rPr sz="1300">
+                <a:solidFill>
+                  <a:srgbClr val="91949B"/>
+                </a:solidFill>
+                <a:latin typeface="Segoe UI"/>
+              </a:rPr>
+              <a:t>Works on any built-in laptop webcam or $15 USB camera</a:t>
             </a:r>
           </a:p>
           <a:p>
@@ -5110,15 +6190,33 @@
               <a:spcBef>
                 <a:spcPts val="600"/>
               </a:spcBef>
-              <a:defRPr sz="1300">
+            </a:pPr>
+            <a:r>
+              <a:rPr b="1" sz="1300">
+                <a:solidFill>
+                  <a:srgbClr val="D4AF6A"/>
+                </a:solidFill>
+                <a:latin typeface="Segoe UI"/>
+              </a:rPr>
+              <a:t>• </a:t>
+            </a:r>
+            <a:r>
+              <a:rPr b="1" sz="1300">
                 <a:solidFill>
                   <a:srgbClr val="F2EFE9"/>
                 </a:solidFill>
                 <a:latin typeface="Segoe UI"/>
-              </a:defRPr>
-            </a:pPr>
-            <a:r>
-              <a:t>• Real-time 3D head yaw and pupillary distance tracking.</a:t>
+              </a:rPr>
+              <a:t>Solves Everyday Pain: </a:t>
+            </a:r>
+            <a:r>
+              <a:rPr sz="1300">
+                <a:solidFill>
+                  <a:srgbClr val="91949B"/>
+                </a:solidFill>
+                <a:latin typeface="Segoe UI"/>
+              </a:rPr>
+              <a:t>Not a tech demo; designed for daily desk and presentation workflows</a:t>
             </a:r>
           </a:p>
           <a:p>
@@ -5126,644 +6224,33 @@
               <a:spcBef>
                 <a:spcPts val="600"/>
               </a:spcBef>
-              <a:defRPr sz="1300">
+            </a:pPr>
+            <a:r>
+              <a:rPr b="1" sz="1300">
+                <a:solidFill>
+                  <a:srgbClr val="D4AF6A"/>
+                </a:solidFill>
+                <a:latin typeface="Segoe UI"/>
+              </a:rPr>
+              <a:t>• </a:t>
+            </a:r>
+            <a:r>
+              <a:rPr b="1" sz="1300">
                 <a:solidFill>
                   <a:srgbClr val="F2EFE9"/>
                 </a:solidFill>
                 <a:latin typeface="Segoe UI"/>
-              </a:defRPr>
-            </a:pPr>
-            <a:r>
-              <a:t>• Glancing away at another screen automatically clutches gestures to standby.</a:t>
-            </a:r>
-          </a:p>
-        </p:txBody>
-      </p:sp>
-      <p:sp>
-        <p:nvSpPr>
-          <p:cNvPr id="8" name="Rounded Rectangle 7"/>
-          <p:cNvSpPr/>
-          <p:nvPr/>
-        </p:nvSpPr>
-        <p:spPr>
-          <a:xfrm>
-            <a:off x="6217920" y="1737360"/>
-            <a:ext cx="5212080" cy="2103120"/>
-          </a:xfrm>
-          <a:prstGeom prst="roundRect">
-            <a:avLst/>
-          </a:prstGeom>
-          <a:solidFill>
-            <a:srgbClr val="181820"/>
-          </a:solidFill>
-          <a:ln w="12700">
-            <a:solidFill>
-              <a:srgbClr val="4A6FA5"/>
-            </a:solidFill>
-          </a:ln>
-        </p:spPr>
-        <p:style>
-          <a:lnRef idx="1">
-            <a:schemeClr val="accent1"/>
-          </a:lnRef>
-          <a:fillRef idx="3">
-            <a:schemeClr val="accent1"/>
-          </a:fillRef>
-          <a:effectRef idx="2">
-            <a:schemeClr val="accent1"/>
-          </a:effectRef>
-          <a:fontRef idx="minor">
-            <a:schemeClr val="lt1"/>
-          </a:fontRef>
-        </p:style>
-        <p:txBody>
-          <a:bodyPr rtlCol="0" anchor="ctr"/>
-          <a:lstStyle/>
-          <a:p>
-            <a:pPr algn="ctr"/>
-          </a:p>
-        </p:txBody>
-      </p:sp>
-      <p:sp>
-        <p:nvSpPr>
-          <p:cNvPr id="9" name="TextBox 8"/>
-          <p:cNvSpPr txBox="1"/>
-          <p:nvPr/>
-        </p:nvSpPr>
-        <p:spPr>
-          <a:xfrm>
-            <a:off x="6446520" y="1965960"/>
-            <a:ext cx="4754880" cy="1645920"/>
-          </a:xfrm>
-          <a:prstGeom prst="rect">
-            <a:avLst/>
-          </a:prstGeom>
-          <a:noFill/>
-        </p:spPr>
-        <p:txBody>
-          <a:bodyPr wrap="square">
-            <a:spAutoFit/>
-          </a:bodyPr>
-          <a:lstStyle/>
-          <a:p>
-            <a:pPr>
-              <a:defRPr sz="1800" b="1">
-                <a:solidFill>
-                  <a:srgbClr val="4A6FA5"/>
-                </a:solidFill>
-                <a:latin typeface="Segoe UI"/>
-              </a:defRPr>
-            </a:pPr>
-            <a:r>
-              <a:t>ShoulderGuard Intruder Shield</a:t>
-            </a:r>
-          </a:p>
-          <a:p>
-            <a:pPr>
-              <a:spcBef>
-                <a:spcPts val="600"/>
-              </a:spcBef>
-              <a:defRPr sz="1300">
-                <a:solidFill>
-                  <a:srgbClr val="F2EFE9"/>
-                </a:solidFill>
-                <a:latin typeface="Segoe UI"/>
-              </a:defRPr>
-            </a:pPr>
-            <a:r>
-              <a:t>• Continuous BlazeFace scan monitors for shoulder surfers in public spaces.</a:t>
-            </a:r>
-          </a:p>
-          <a:p>
-            <a:pPr>
-              <a:spcBef>
-                <a:spcPts val="600"/>
-              </a:spcBef>
-              <a:defRPr sz="1300">
-                <a:solidFill>
-                  <a:srgbClr val="F2EFE9"/>
-                </a:solidFill>
-                <a:latin typeface="Segoe UI"/>
-              </a:defRPr>
-            </a:pPr>
-            <a:r>
-              <a:t>• If a second face appears behind you, automatically fires Win+D to protect sensitive work.</a:t>
-            </a:r>
-          </a:p>
-        </p:txBody>
-      </p:sp>
-      <p:sp>
-        <p:nvSpPr>
-          <p:cNvPr id="10" name="Rounded Rectangle 9"/>
-          <p:cNvSpPr/>
-          <p:nvPr/>
-        </p:nvSpPr>
-        <p:spPr>
-          <a:xfrm>
-            <a:off x="6217920" y="4069080"/>
-            <a:ext cx="5212080" cy="2103120"/>
-          </a:xfrm>
-          <a:prstGeom prst="roundRect">
-            <a:avLst/>
-          </a:prstGeom>
-          <a:solidFill>
-            <a:srgbClr val="181820"/>
-          </a:solidFill>
-          <a:ln w="12700">
-            <a:solidFill>
-              <a:srgbClr val="D4AF6A"/>
-            </a:solidFill>
-          </a:ln>
-        </p:spPr>
-        <p:style>
-          <a:lnRef idx="1">
-            <a:schemeClr val="accent1"/>
-          </a:lnRef>
-          <a:fillRef idx="3">
-            <a:schemeClr val="accent1"/>
-          </a:fillRef>
-          <a:effectRef idx="2">
-            <a:schemeClr val="accent1"/>
-          </a:effectRef>
-          <a:fontRef idx="minor">
-            <a:schemeClr val="lt1"/>
-          </a:fontRef>
-        </p:style>
-        <p:txBody>
-          <a:bodyPr rtlCol="0" anchor="ctr"/>
-          <a:lstStyle/>
-          <a:p>
-            <a:pPr algn="ctr"/>
-          </a:p>
-        </p:txBody>
-      </p:sp>
-      <p:sp>
-        <p:nvSpPr>
-          <p:cNvPr id="11" name="TextBox 10"/>
-          <p:cNvSpPr txBox="1"/>
-          <p:nvPr/>
-        </p:nvSpPr>
-        <p:spPr>
-          <a:xfrm>
-            <a:off x="6446520" y="4297680"/>
-            <a:ext cx="4754880" cy="1645920"/>
-          </a:xfrm>
-          <a:prstGeom prst="rect">
-            <a:avLst/>
-          </a:prstGeom>
-          <a:noFill/>
-        </p:spPr>
-        <p:txBody>
-          <a:bodyPr wrap="square">
-            <a:spAutoFit/>
-          </a:bodyPr>
-          <a:lstStyle/>
-          <a:p>
-            <a:pPr>
-              <a:defRPr sz="1800" b="1">
-                <a:solidFill>
-                  <a:srgbClr val="D4AF6A"/>
-                </a:solidFill>
-                <a:latin typeface="Segoe UI"/>
-              </a:defRPr>
-            </a:pPr>
-            <a:r>
-              <a:t>Body Ownership &amp; Anti-Jitter Physics</a:t>
-            </a:r>
-          </a:p>
-          <a:p>
-            <a:pPr>
-              <a:spcBef>
-                <a:spcPts val="600"/>
-              </a:spcBef>
-              <a:defRPr sz="1300">
-                <a:solidFill>
-                  <a:srgbClr val="F2EFE9"/>
-                </a:solidFill>
-                <a:latin typeface="Segoe UI"/>
-              </a:defRPr>
-            </a:pPr>
-            <a:r>
-              <a:t>• Calculates Euclidean distance between wrist and face; rejects passerby hands.</a:t>
-            </a:r>
-          </a:p>
-          <a:p>
-            <a:pPr>
-              <a:spcBef>
-                <a:spcPts val="600"/>
-              </a:spcBef>
-              <a:defRPr sz="1300">
-                <a:solidFill>
-                  <a:srgbClr val="F2EFE9"/>
-                </a:solidFill>
-                <a:latin typeface="Segoe UI"/>
-              </a:defRPr>
-            </a:pPr>
-            <a:r>
-              <a:t>• Bone length stability and acceleration checks freeze hallucinated hand joints.</a:t>
-            </a:r>
-          </a:p>
-        </p:txBody>
-      </p:sp>
-    </p:spTree>
-  </p:cSld>
-  <p:clrMapOvr>
-    <a:masterClrMapping/>
-  </p:clrMapOvr>
-</p:sld>
-</file>
-
-<file path=ppt/slides/slide6.xml><?xml version="1.0" encoding="utf-8"?>
-<p:sld xmlns:a="http://schemas.openxmlformats.org/drawingml/2006/main" xmlns:p="http://schemas.openxmlformats.org/presentationml/2006/main" xmlns:r="http://schemas.openxmlformats.org/officeDocument/2006/relationships">
-  <p:cSld>
-    <p:spTree>
-      <p:nvGrpSpPr>
-        <p:cNvPr id="1" name=""/>
-        <p:cNvGrpSpPr/>
-        <p:nvPr/>
-      </p:nvGrpSpPr>
-      <p:grpSpPr/>
-      <p:sp>
-        <p:nvSpPr>
-          <p:cNvPr id="2" name="Rectangle 1"/>
-          <p:cNvSpPr/>
-          <p:nvPr/>
-        </p:nvSpPr>
-        <p:spPr>
-          <a:xfrm>
-            <a:off x="0" y="0"/>
-            <a:ext cx="12191695" cy="6858000"/>
-          </a:xfrm>
-          <a:prstGeom prst="rect">
-            <a:avLst/>
-          </a:prstGeom>
-          <a:solidFill>
-            <a:srgbClr val="0F0F14"/>
-          </a:solidFill>
-          <a:ln>
-            <a:noFill/>
-          </a:ln>
-        </p:spPr>
-        <p:style>
-          <a:lnRef idx="1">
-            <a:schemeClr val="accent1"/>
-          </a:lnRef>
-          <a:fillRef idx="3">
-            <a:schemeClr val="accent1"/>
-          </a:fillRef>
-          <a:effectRef idx="2">
-            <a:schemeClr val="accent1"/>
-          </a:effectRef>
-          <a:fontRef idx="minor">
-            <a:schemeClr val="lt1"/>
-          </a:fontRef>
-        </p:style>
-        <p:txBody>
-          <a:bodyPr rtlCol="0" anchor="ctr"/>
-          <a:lstStyle/>
-          <a:p>
-            <a:pPr algn="ctr"/>
-          </a:p>
-        </p:txBody>
-      </p:sp>
-      <p:sp>
-        <p:nvSpPr>
-          <p:cNvPr id="3" name="TextBox 2"/>
-          <p:cNvSpPr txBox="1"/>
-          <p:nvPr/>
-        </p:nvSpPr>
-        <p:spPr>
-          <a:xfrm>
-            <a:off x="731520" y="502920"/>
-            <a:ext cx="10728655" cy="1005840"/>
-          </a:xfrm>
-          <a:prstGeom prst="rect">
-            <a:avLst/>
-          </a:prstGeom>
-          <a:noFill/>
-        </p:spPr>
-        <p:txBody>
-          <a:bodyPr wrap="square">
-            <a:spAutoFit/>
-          </a:bodyPr>
-          <a:lstStyle/>
-          <a:p>
-            <a:pPr>
-              <a:defRPr sz="1100" b="1">
-                <a:solidFill>
-                  <a:srgbClr val="D4AF6A"/>
-                </a:solidFill>
-                <a:latin typeface="Consolas"/>
-              </a:defRPr>
-            </a:pPr>
-            <a:r>
-              <a:t>05 • ARCHITECTURE &amp; SUMMARY</a:t>
-            </a:r>
-          </a:p>
-          <a:p>
-            <a:pPr>
-              <a:spcBef>
-                <a:spcPts val="400"/>
-              </a:spcBef>
-              <a:defRPr sz="2600" b="1">
-                <a:solidFill>
-                  <a:srgbClr val="F2EFE9"/>
-                </a:solidFill>
-                <a:latin typeface="Georgia"/>
-              </a:defRPr>
-            </a:pPr>
-            <a:r>
-              <a:t>Technical Architecture &amp; Hackathon Wrap-Up</a:t>
-            </a:r>
-          </a:p>
-        </p:txBody>
-      </p:sp>
-      <p:sp>
-        <p:nvSpPr>
-          <p:cNvPr id="4" name="Rounded Rectangle 3"/>
-          <p:cNvSpPr/>
-          <p:nvPr/>
-        </p:nvSpPr>
-        <p:spPr>
-          <a:xfrm>
-            <a:off x="731520" y="1737360"/>
-            <a:ext cx="5120640" cy="4389120"/>
-          </a:xfrm>
-          <a:prstGeom prst="roundRect">
-            <a:avLst/>
-          </a:prstGeom>
-          <a:solidFill>
-            <a:srgbClr val="181820"/>
-          </a:solidFill>
-          <a:ln w="12700">
-            <a:solidFill>
-              <a:srgbClr val="4A6FA5"/>
-            </a:solidFill>
-          </a:ln>
-        </p:spPr>
-        <p:style>
-          <a:lnRef idx="1">
-            <a:schemeClr val="accent1"/>
-          </a:lnRef>
-          <a:fillRef idx="3">
-            <a:schemeClr val="accent1"/>
-          </a:fillRef>
-          <a:effectRef idx="2">
-            <a:schemeClr val="accent1"/>
-          </a:effectRef>
-          <a:fontRef idx="minor">
-            <a:schemeClr val="lt1"/>
-          </a:fontRef>
-        </p:style>
-        <p:txBody>
-          <a:bodyPr rtlCol="0" anchor="ctr"/>
-          <a:lstStyle/>
-          <a:p>
-            <a:pPr algn="ctr"/>
-          </a:p>
-        </p:txBody>
-      </p:sp>
-      <p:sp>
-        <p:nvSpPr>
-          <p:cNvPr id="5" name="TextBox 4"/>
-          <p:cNvSpPr txBox="1"/>
-          <p:nvPr/>
-        </p:nvSpPr>
-        <p:spPr>
-          <a:xfrm>
-            <a:off x="960120" y="1965960"/>
-            <a:ext cx="4663440" cy="3931920"/>
-          </a:xfrm>
-          <a:prstGeom prst="rect">
-            <a:avLst/>
-          </a:prstGeom>
-          <a:noFill/>
-        </p:spPr>
-        <p:txBody>
-          <a:bodyPr wrap="square">
-            <a:spAutoFit/>
-          </a:bodyPr>
-          <a:lstStyle/>
-          <a:p>
-            <a:pPr>
-              <a:defRPr sz="1800" b="1">
-                <a:solidFill>
-                  <a:srgbClr val="4A6FA5"/>
-                </a:solidFill>
-                <a:latin typeface="Segoe UI"/>
-              </a:defRPr>
-            </a:pPr>
-            <a:r>
-              <a:t>High-Performance System Architecture</a:t>
-            </a:r>
-          </a:p>
-          <a:p>
-            <a:pPr>
-              <a:spcBef>
-                <a:spcPts val="600"/>
-              </a:spcBef>
-              <a:defRPr sz="1300">
-                <a:solidFill>
-                  <a:srgbClr val="F2EFE9"/>
-                </a:solidFill>
-                <a:latin typeface="Segoe UI"/>
-              </a:defRPr>
-            </a:pPr>
-            <a:r>
-              <a:t>• Shared Memory IPC: Zero-copy multiprocessing.shared_memory streams 30 FPS telemetry and previews to GUI.</a:t>
-            </a:r>
-          </a:p>
-          <a:p>
-            <a:pPr>
-              <a:spcBef>
-                <a:spcPts val="600"/>
-              </a:spcBef>
-              <a:defRPr sz="1300">
-                <a:solidFill>
-                  <a:srgbClr val="F2EFE9"/>
-                </a:solidFill>
-                <a:latin typeface="Segoe UI"/>
-              </a:defRPr>
-            </a:pPr>
-            <a:r>
-              <a:t>• Hardware Audio Hook: Direct Windows Core Audio (Pycaw) input endpoint volume control.</a:t>
-            </a:r>
-          </a:p>
-          <a:p>
-            <a:pPr>
-              <a:spcBef>
-                <a:spcPts val="600"/>
-              </a:spcBef>
-              <a:defRPr sz="1300">
-                <a:solidFill>
-                  <a:srgbClr val="F2EFE9"/>
-                </a:solidFill>
-                <a:latin typeface="Segoe UI"/>
-              </a:defRPr>
-            </a:pPr>
-            <a:r>
-              <a:t>• Windows Camera Frame Server: OpenCV MSMF backend hooks svchost.exe -k Camera for native multi-app streaming.</a:t>
-            </a:r>
-          </a:p>
-          <a:p>
-            <a:pPr>
-              <a:spcBef>
-                <a:spcPts val="600"/>
-              </a:spcBef>
-              <a:defRPr sz="1300">
-                <a:solidFill>
-                  <a:srgbClr val="F2EFE9"/>
-                </a:solidFill>
-                <a:latin typeface="Segoe UI"/>
-              </a:defRPr>
-            </a:pPr>
-            <a:r>
-              <a:t>• Ambient HUD: CustomTkinter executive dashboard + topmost micro-pill Floating Capsule.</a:t>
-            </a:r>
-          </a:p>
-        </p:txBody>
-      </p:sp>
-      <p:sp>
-        <p:nvSpPr>
-          <p:cNvPr id="6" name="Rounded Rectangle 5"/>
-          <p:cNvSpPr/>
-          <p:nvPr/>
-        </p:nvSpPr>
-        <p:spPr>
-          <a:xfrm>
-            <a:off x="6217920" y="1737360"/>
-            <a:ext cx="5212080" cy="4389120"/>
-          </a:xfrm>
-          <a:prstGeom prst="roundRect">
-            <a:avLst/>
-          </a:prstGeom>
-          <a:solidFill>
-            <a:srgbClr val="181820"/>
-          </a:solidFill>
-          <a:ln w="12700">
-            <a:solidFill>
-              <a:srgbClr val="D4AF6A"/>
-            </a:solidFill>
-          </a:ln>
-        </p:spPr>
-        <p:style>
-          <a:lnRef idx="1">
-            <a:schemeClr val="accent1"/>
-          </a:lnRef>
-          <a:fillRef idx="3">
-            <a:schemeClr val="accent1"/>
-          </a:fillRef>
-          <a:effectRef idx="2">
-            <a:schemeClr val="accent1"/>
-          </a:effectRef>
-          <a:fontRef idx="minor">
-            <a:schemeClr val="lt1"/>
-          </a:fontRef>
-        </p:style>
-        <p:txBody>
-          <a:bodyPr rtlCol="0" anchor="ctr"/>
-          <a:lstStyle/>
-          <a:p>
-            <a:pPr algn="ctr"/>
-          </a:p>
-        </p:txBody>
-      </p:sp>
-      <p:sp>
-        <p:nvSpPr>
-          <p:cNvPr id="7" name="TextBox 6"/>
-          <p:cNvSpPr txBox="1"/>
-          <p:nvPr/>
-        </p:nvSpPr>
-        <p:spPr>
-          <a:xfrm>
-            <a:off x="6446520" y="1965960"/>
-            <a:ext cx="4754880" cy="3931920"/>
-          </a:xfrm>
-          <a:prstGeom prst="rect">
-            <a:avLst/>
-          </a:prstGeom>
-          <a:noFill/>
-        </p:spPr>
-        <p:txBody>
-          <a:bodyPr wrap="square">
-            <a:spAutoFit/>
-          </a:bodyPr>
-          <a:lstStyle/>
-          <a:p>
-            <a:pPr>
-              <a:defRPr sz="1800" b="1">
-                <a:solidFill>
-                  <a:srgbClr val="D4AF6A"/>
-                </a:solidFill>
-                <a:latin typeface="Segoe UI"/>
-              </a:defRPr>
-            </a:pPr>
-            <a:r>
-              <a:t>Summary &amp; Why ZeroTouch Wins</a:t>
-            </a:r>
-          </a:p>
-          <a:p>
-            <a:pPr>
-              <a:spcBef>
-                <a:spcPts val="600"/>
-              </a:spcBef>
-              <a:defRPr sz="1300">
-                <a:solidFill>
-                  <a:srgbClr val="F2EFE9"/>
-                </a:solidFill>
-                <a:latin typeface="Segoe UI"/>
-              </a:defRPr>
-            </a:pPr>
-            <a:r>
-              <a:t>• Executive Polish: Enterprise-ready companion built for everyday work, not a tech demo.</a:t>
-            </a:r>
-          </a:p>
-          <a:p>
-            <a:pPr>
-              <a:spcBef>
-                <a:spcPts val="600"/>
-              </a:spcBef>
-              <a:defRPr sz="1300">
-                <a:solidFill>
-                  <a:srgbClr val="F2EFE9"/>
-                </a:solidFill>
-                <a:latin typeface="Segoe UI"/>
-              </a:defRPr>
-            </a:pPr>
-            <a:r>
-              <a:t>• Zero Cloud Risk: True local privacy that enterprise users can actually deploy.</a:t>
-            </a:r>
-          </a:p>
-          <a:p>
-            <a:pPr>
-              <a:spcBef>
-                <a:spcPts val="600"/>
-              </a:spcBef>
-              <a:defRPr sz="1300">
-                <a:solidFill>
-                  <a:srgbClr val="F2EFE9"/>
-                </a:solidFill>
-                <a:latin typeface="Segoe UI"/>
-              </a:defRPr>
-            </a:pPr>
-            <a:r>
-              <a:t>• Production Ready: Complete with 1-click batch launcher, custom Windows taskbar branding, and system tray integration.</a:t>
-            </a:r>
-          </a:p>
-          <a:p>
-            <a:pPr>
-              <a:spcBef>
-                <a:spcPts val="600"/>
-              </a:spcBef>
-              <a:defRPr sz="1300">
-                <a:solidFill>
-                  <a:srgbClr val="F2EFE9"/>
-                </a:solidFill>
-                <a:latin typeface="Segoe UI"/>
-              </a:defRPr>
-            </a:pPr>
-            <a:r>
-              <a:t>• Open Source: https://github.com/Philphil-org/UAT-Hackathon</a:t>
+              </a:rPr>
+              <a:t>Open Source &amp; Live: </a:t>
+            </a:r>
+            <a:r>
+              <a:rPr sz="1300">
+                <a:solidFill>
+                  <a:srgbClr val="91949B"/>
+                </a:solidFill>
+                <a:latin typeface="Segoe UI"/>
+              </a:rPr>
+              <a:t>Tested, verified, and ready on GitHub: Philphil-org/UAT-Hackathon</a:t>
             </a:r>
           </a:p>
         </p:txBody>

</xml_diff>

<commit_message>
docs: restructure pitch deck into clean What-Why-Who-Details 5-slide executive narrative
</commit_message>
<xml_diff>
--- a/ZeroTouch_PitchDeck.pptx
+++ b/ZeroTouch_PitchDeck.pptx
@@ -3151,7 +3151,7 @@
         </p:blipFill>
         <p:spPr>
           <a:xfrm>
-            <a:off x="5358384" y="1051560"/>
+            <a:off x="5358384" y="1097280"/>
             <a:ext cx="1463040" cy="1463040"/>
           </a:xfrm>
           <a:prstGeom prst="rect">
@@ -3167,7 +3167,7 @@
         </p:nvSpPr>
         <p:spPr>
           <a:xfrm>
-            <a:off x="914400" y="2697480"/>
+            <a:off x="914400" y="2788920"/>
             <a:ext cx="10360152" cy="3474720"/>
           </a:xfrm>
           <a:prstGeom prst="rect">
@@ -3216,13 +3216,13 @@
               </a:spcBef>
               <a:defRPr sz="1300">
                 <a:solidFill>
-                  <a:srgbClr val="91949B"/>
+                  <a:srgbClr val="94979E"/>
                 </a:solidFill>
                 <a:latin typeface="Segoe UI"/>
               </a:defRPr>
             </a:pPr>
             <a:r>
-              <a:t>Zero Cloud Footprint  •  Multi-Modal False Trigger Defense  •  Active App Context</a:t>
+              <a:t>100% Local Inferencing  •  Active App Context  •  Zero False Triggers</a:t>
             </a:r>
           </a:p>
           <a:p>
@@ -3312,8 +3312,8 @@
         </p:nvSpPr>
         <p:spPr>
           <a:xfrm>
-            <a:off x="731520" y="475488"/>
-            <a:ext cx="10728655" cy="1005840"/>
+            <a:off x="731520" y="438912"/>
+            <a:ext cx="10728655" cy="1097280"/>
           </a:xfrm>
           <a:prstGeom prst="rect">
             <a:avLst/>
@@ -3335,7 +3335,7 @@
               </a:defRPr>
             </a:pPr>
             <a:r>
-              <a:t>01 • THESIS &amp; WORKFLOW</a:t>
+              <a:t>01 • WHAT WE MADE</a:t>
             </a:r>
           </a:p>
           <a:p>
@@ -3351,7 +3351,23 @@
               </a:defRPr>
             </a:pPr>
             <a:r>
-              <a:t>The Spatial Dilemma &amp; Context-Aware Solution</a:t>
+              <a:t>What We Made: The Invisible Spatial Peripheral</a:t>
+            </a:r>
+          </a:p>
+          <a:p>
+            <a:pPr>
+              <a:spcBef>
+                <a:spcPts val="200"/>
+              </a:spcBef>
+              <a:defRPr sz="1200">
+                <a:solidFill>
+                  <a:srgbClr val="94979E"/>
+                </a:solidFill>
+                <a:latin typeface="Segoe UI"/>
+              </a:defRPr>
+            </a:pPr>
+            <a:r>
+              <a:t>Seamless touchless control that automatically adapts to your active Windows application.</a:t>
             </a:r>
           </a:p>
         </p:txBody>
@@ -3364,8 +3380,8 @@
         </p:nvSpPr>
         <p:spPr>
           <a:xfrm>
-            <a:off x="731520" y="1691640"/>
-            <a:ext cx="3383280" cy="4480560"/>
+            <a:off x="731520" y="1783080"/>
+            <a:ext cx="3383280" cy="4389120"/>
           </a:xfrm>
           <a:prstGeom prst="roundRect">
             <a:avLst/>
@@ -3409,8 +3425,8 @@
         </p:nvSpPr>
         <p:spPr>
           <a:xfrm>
-            <a:off x="950976" y="1892808"/>
-            <a:ext cx="2944368" cy="4078224"/>
+            <a:off x="950976" y="1984248"/>
+            <a:ext cx="2944368" cy="3986784"/>
           </a:xfrm>
           <a:prstGeom prst="rect">
             <a:avLst/>
@@ -3424,7 +3440,7 @@
           <a:lstStyle/>
           <a:p>
             <a:pPr>
-              <a:defRPr sz="1700" b="1">
+              <a:defRPr sz="1800" b="1">
                 <a:solidFill>
                   <a:srgbClr val="D4AF6A"/>
                 </a:solidFill>
@@ -3432,7 +3448,7 @@
               </a:defRPr>
             </a:pPr>
             <a:r>
-              <a:t>The Spatial Dilemma</a:t>
+              <a:t>Presentation Companion</a:t>
             </a:r>
           </a:p>
           <a:p>
@@ -3445,19 +3461,19 @@
               </a:spcAft>
               <a:defRPr sz="1000" b="1">
                 <a:solidFill>
-                  <a:srgbClr val="91949B"/>
+                  <a:srgbClr val="94979E"/>
                 </a:solidFill>
                 <a:latin typeface="Consolas"/>
               </a:defRPr>
             </a:pPr>
             <a:r>
-              <a:t>WHY CV PERIPHERALS FAIL</a:t>
+              <a:t>POWERPOINT • GOOGLE SLIDES • PDF</a:t>
             </a:r>
           </a:p>
           <a:p>
             <a:pPr>
               <a:spcBef>
-                <a:spcPts val="600"/>
+                <a:spcPts val="700"/>
               </a:spcBef>
             </a:pPr>
             <a:r>
@@ -3476,22 +3492,22 @@
                 </a:solidFill>
                 <a:latin typeface="Segoe UI"/>
               </a:rPr>
-              <a:t>Accidental Triggers: </a:t>
+              <a:t>Back-of-Hand Swipe: </a:t>
             </a:r>
             <a:r>
               <a:rPr sz="1300">
                 <a:solidFill>
-                  <a:srgbClr val="91949B"/>
-                </a:solidFill>
-                <a:latin typeface="Segoe UI"/>
-              </a:rPr>
-              <a:t>Scratching face or typing fires unwanted clicks</a:t>
+                  <a:srgbClr val="94979E"/>
+                </a:solidFill>
+                <a:latin typeface="Segoe UI"/>
+              </a:rPr>
+              <a:t>Advance or return slides naturally from across the room</a:t>
             </a:r>
           </a:p>
           <a:p>
             <a:pPr>
               <a:spcBef>
-                <a:spcPts val="600"/>
+                <a:spcPts val="700"/>
               </a:spcBef>
             </a:pPr>
             <a:r>
@@ -3510,22 +3526,22 @@
                 </a:solidFill>
                 <a:latin typeface="Segoe UI"/>
               </a:rPr>
-              <a:t>Privacy Paranoia: </a:t>
+              <a:t>Open Palm Hold: </a:t>
             </a:r>
             <a:r>
               <a:rPr sz="1300">
                 <a:solidFill>
-                  <a:srgbClr val="91949B"/>
-                </a:solidFill>
-                <a:latin typeface="Segoe UI"/>
-              </a:rPr>
-              <a:t>Users fear webcams streaming frames to the cloud</a:t>
+                  <a:srgbClr val="94979E"/>
+                </a:solidFill>
+                <a:latin typeface="Segoe UI"/>
+              </a:rPr>
+              <a:t>Instantly blank or resume screen ('B') to hold attention</a:t>
             </a:r>
           </a:p>
           <a:p>
             <a:pPr>
               <a:spcBef>
-                <a:spcPts val="600"/>
+                <a:spcPts val="700"/>
               </a:spcBef>
             </a:pPr>
             <a:r>
@@ -3544,22 +3560,22 @@
                 </a:solidFill>
                 <a:latin typeface="Segoe UI"/>
               </a:rPr>
-              <a:t>Hardware Lockouts: </a:t>
+              <a:t>Stage Distance Engine: </a:t>
             </a:r>
             <a:r>
               <a:rPr sz="1300">
                 <a:solidFill>
-                  <a:srgbClr val="91949B"/>
-                </a:solidFill>
-                <a:latin typeface="Segoe UI"/>
-              </a:rPr>
-              <a:t>Standard CV apps hijack webcam from Zoom/Teams</a:t>
+                  <a:srgbClr val="94979E"/>
+                </a:solidFill>
+                <a:latin typeface="Segoe UI"/>
+              </a:rPr>
+              <a:t>Maintains responsive hand tracking up to 10 feet away</a:t>
             </a:r>
           </a:p>
           <a:p>
             <a:pPr>
               <a:spcBef>
-                <a:spcPts val="600"/>
+                <a:spcPts val="700"/>
               </a:spcBef>
             </a:pPr>
             <a:r>
@@ -3578,16 +3594,16 @@
                 </a:solidFill>
                 <a:latin typeface="Segoe UI"/>
               </a:rPr>
-              <a:t>Posture Constraints: </a:t>
+              <a:t>No Clickers Needed: </a:t>
             </a:r>
             <a:r>
               <a:rPr sz="1300">
                 <a:solidFill>
-                  <a:srgbClr val="91949B"/>
-                </a:solidFill>
-                <a:latin typeface="Segoe UI"/>
-              </a:rPr>
-              <a:t>Stepping back from desk breaks tracking completely</a:t>
+                  <a:srgbClr val="94979E"/>
+                </a:solidFill>
+                <a:latin typeface="Segoe UI"/>
+              </a:rPr>
+              <a:t>Zero plastic remotes, USB dongles, or dead batteries</a:t>
             </a:r>
           </a:p>
         </p:txBody>
@@ -3600,8 +3616,8 @@
         </p:nvSpPr>
         <p:spPr>
           <a:xfrm>
-            <a:off x="4389120" y="1691640"/>
-            <a:ext cx="3383280" cy="4480560"/>
+            <a:off x="4389120" y="1783080"/>
+            <a:ext cx="3383280" cy="4389120"/>
           </a:xfrm>
           <a:prstGeom prst="roundRect">
             <a:avLst/>
@@ -3645,8 +3661,8 @@
         </p:nvSpPr>
         <p:spPr>
           <a:xfrm>
-            <a:off x="4608576" y="1892808"/>
-            <a:ext cx="2944368" cy="4078224"/>
+            <a:off x="4608576" y="1984248"/>
+            <a:ext cx="2944368" cy="3986784"/>
           </a:xfrm>
           <a:prstGeom prst="rect">
             <a:avLst/>
@@ -3660,7 +3676,7 @@
           <a:lstStyle/>
           <a:p>
             <a:pPr>
-              <a:defRPr sz="1700" b="1">
+              <a:defRPr sz="1800" b="1">
                 <a:solidFill>
                   <a:srgbClr val="F2EFE9"/>
                 </a:solidFill>
@@ -3668,7 +3684,7 @@
               </a:defRPr>
             </a:pPr>
             <a:r>
-              <a:t>Context-Aware Engine</a:t>
+              <a:t>Video Meeting Companion</a:t>
             </a:r>
           </a:p>
           <a:p>
@@ -3681,19 +3697,19 @@
               </a:spcAft>
               <a:defRPr sz="1000" b="1">
                 <a:solidFill>
-                  <a:srgbClr val="91949B"/>
+                  <a:srgbClr val="94979E"/>
                 </a:solidFill>
                 <a:latin typeface="Consolas"/>
               </a:defRPr>
             </a:pPr>
             <a:r>
-              <a:t>ADAPTS TO ACTIVE APP</a:t>
+              <a:t>GOOGLE MEET • TEAMS • ZOOM</a:t>
             </a:r>
           </a:p>
           <a:p>
             <a:pPr>
               <a:spcBef>
-                <a:spcPts val="600"/>
+                <a:spcPts val="700"/>
               </a:spcBef>
             </a:pPr>
             <a:r>
@@ -3712,22 +3728,22 @@
                 </a:solidFill>
                 <a:latin typeface="Segoe UI"/>
               </a:rPr>
-              <a:t>Presentation Mode: </a:t>
+              <a:t>Ghost-Mute (Shh): </a:t>
             </a:r>
             <a:r>
               <a:rPr sz="1300">
                 <a:solidFill>
-                  <a:srgbClr val="91949B"/>
-                </a:solidFill>
-                <a:latin typeface="Segoe UI"/>
-              </a:rPr>
-              <a:t>PowerPoint &amp; Slides: Wave swipe to advance; palm to blank screen ('B')</a:t>
+                  <a:srgbClr val="94979E"/>
+                </a:solidFill>
+                <a:latin typeface="Segoe UI"/>
+              </a:rPr>
+              <a:t>Index finger to lips directly toggles hardware microphone</a:t>
             </a:r>
           </a:p>
           <a:p>
             <a:pPr>
               <a:spcBef>
-                <a:spcPts val="600"/>
+                <a:spcPts val="700"/>
               </a:spcBef>
             </a:pPr>
             <a:r>
@@ -3746,22 +3762,22 @@
                 </a:solidFill>
                 <a:latin typeface="Segoe UI"/>
               </a:rPr>
-              <a:t>Meeting Mode: </a:t>
+              <a:t>Open Palm Hold: </a:t>
             </a:r>
             <a:r>
               <a:rPr sz="1300">
                 <a:solidFill>
-                  <a:srgbClr val="91949B"/>
-                </a:solidFill>
-                <a:latin typeface="Segoe UI"/>
-              </a:rPr>
-              <a:t>Meet &amp; Teams: Ghost-Mute (Shh), camera toggle (Ctrl+E / Ctrl+Shift+O)</a:t>
+                  <a:srgbClr val="94979E"/>
+                </a:solidFill>
+                <a:latin typeface="Segoe UI"/>
+              </a:rPr>
+              <a:t>Instant camera on/off (Ctrl+E in Meet, Ctrl+Shift+O in Teams)</a:t>
             </a:r>
           </a:p>
           <a:p>
             <a:pPr>
               <a:spcBef>
-                <a:spcPts val="600"/>
+                <a:spcPts val="700"/>
               </a:spcBef>
             </a:pPr>
             <a:r>
@@ -3780,22 +3796,22 @@
                 </a:solidFill>
                 <a:latin typeface="Segoe UI"/>
               </a:rPr>
-              <a:t>Media Mode: </a:t>
+              <a:t>Back-of-Hand Swipe: </a:t>
             </a:r>
             <a:r>
               <a:rPr sz="1300">
                 <a:solidFill>
-                  <a:srgbClr val="91949B"/>
-                </a:solidFill>
-                <a:latin typeface="Segoe UI"/>
-              </a:rPr>
-              <a:t>Spotify &amp; YouTube: Natural palm play/pause and continuous volume pinch</a:t>
+                  <a:srgbClr val="94979E"/>
+                </a:solidFill>
+                <a:latin typeface="Segoe UI"/>
+              </a:rPr>
+              <a:t>Raise/lower hand or toggle participant list hands-free</a:t>
             </a:r>
           </a:p>
           <a:p>
             <a:pPr>
               <a:spcBef>
-                <a:spcPts val="600"/>
+                <a:spcPts val="700"/>
               </a:spcBef>
             </a:pPr>
             <a:r>
@@ -3814,16 +3830,16 @@
                 </a:solidFill>
                 <a:latin typeface="Segoe UI"/>
               </a:rPr>
-              <a:t>Auto Mode Switching: </a:t>
+              <a:t>Zero Window Scramble: </a:t>
             </a:r>
             <a:r>
               <a:rPr sz="1300">
                 <a:solidFill>
-                  <a:srgbClr val="91949B"/>
-                </a:solidFill>
-                <a:latin typeface="Segoe UI"/>
-              </a:rPr>
-              <a:t>Detects focused window every 400ms seamlessly</a:t>
+                  <a:srgbClr val="94979E"/>
+                </a:solidFill>
+                <a:latin typeface="Segoe UI"/>
+              </a:rPr>
+              <a:t>Works instantly without needing to find or focus the call tab</a:t>
             </a:r>
           </a:p>
         </p:txBody>
@@ -3836,8 +3852,8 @@
         </p:nvSpPr>
         <p:spPr>
           <a:xfrm>
-            <a:off x="8046720" y="1691640"/>
-            <a:ext cx="3383280" cy="4480560"/>
+            <a:off x="8046720" y="1783080"/>
+            <a:ext cx="3383280" cy="4389120"/>
           </a:xfrm>
           <a:prstGeom prst="roundRect">
             <a:avLst/>
@@ -3881,8 +3897,8 @@
         </p:nvSpPr>
         <p:spPr>
           <a:xfrm>
-            <a:off x="8266176" y="1892808"/>
-            <a:ext cx="2944368" cy="4078224"/>
+            <a:off x="8266176" y="1984248"/>
+            <a:ext cx="2944368" cy="3986784"/>
           </a:xfrm>
           <a:prstGeom prst="rect">
             <a:avLst/>
@@ -3896,7 +3912,7 @@
           <a:lstStyle/>
           <a:p>
             <a:pPr>
-              <a:defRPr sz="1700" b="1">
+              <a:defRPr sz="1800" b="1">
                 <a:solidFill>
                   <a:srgbClr val="557DB9"/>
                 </a:solidFill>
@@ -3904,7 +3920,7 @@
               </a:defRPr>
             </a:pPr>
             <a:r>
-              <a:t>ZeroTouch Breakthrough</a:t>
+              <a:t>Media &amp; Desktop Companion</a:t>
             </a:r>
           </a:p>
           <a:p>
@@ -3917,19 +3933,19 @@
               </a:spcAft>
               <a:defRPr sz="1000" b="1">
                 <a:solidFill>
-                  <a:srgbClr val="91949B"/>
+                  <a:srgbClr val="94979E"/>
                 </a:solidFill>
                 <a:latin typeface="Consolas"/>
               </a:defRPr>
             </a:pPr>
             <a:r>
-              <a:t>THE INVISIBLE PERIPHERAL</a:t>
+              <a:t>SPOTIFY • YOUTUBE • NETFLIX</a:t>
             </a:r>
           </a:p>
           <a:p>
             <a:pPr>
               <a:spcBef>
-                <a:spcPts val="600"/>
+                <a:spcPts val="700"/>
               </a:spcBef>
             </a:pPr>
             <a:r>
@@ -3948,22 +3964,22 @@
                 </a:solidFill>
                 <a:latin typeface="Segoe UI"/>
               </a:rPr>
-              <a:t>100% Volatile RAM: </a:t>
+              <a:t>Open Palm Hold: </a:t>
             </a:r>
             <a:r>
               <a:rPr sz="1300">
                 <a:solidFill>
-                  <a:srgbClr val="91949B"/>
-                </a:solidFill>
-                <a:latin typeface="Segoe UI"/>
-              </a:rPr>
-              <a:t>Zero video frames ever stored or transmitted</a:t>
+                  <a:srgbClr val="94979E"/>
+                </a:solidFill>
+                <a:latin typeface="Segoe UI"/>
+              </a:rPr>
+              <a:t>Effortless universal play / pause media toggle</a:t>
             </a:r>
           </a:p>
           <a:p>
             <a:pPr>
               <a:spcBef>
-                <a:spcPts val="600"/>
+                <a:spcPts val="700"/>
               </a:spcBef>
             </a:pPr>
             <a:r>
@@ -3982,22 +3998,22 @@
                 </a:solidFill>
                 <a:latin typeface="Segoe UI"/>
               </a:rPr>
-              <a:t>OS Camera Sharing: </a:t>
+              <a:t>Vertical Pinch Slider: </a:t>
             </a:r>
             <a:r>
               <a:rPr sz="1300">
                 <a:solidFill>
-                  <a:srgbClr val="91949B"/>
-                </a:solidFill>
-                <a:latin typeface="Segoe UI"/>
-              </a:rPr>
-              <a:t>Native Windows Frame Server coexists with Meet/Teams</a:t>
+                  <a:srgbClr val="94979E"/>
+                </a:solidFill>
+                <a:latin typeface="Segoe UI"/>
+              </a:rPr>
+              <a:t>Continuous master volume control with dynamic line HUD</a:t>
             </a:r>
           </a:p>
           <a:p>
             <a:pPr>
               <a:spcBef>
-                <a:spcPts val="600"/>
+                <a:spcPts val="700"/>
               </a:spcBef>
             </a:pPr>
             <a:r>
@@ -4016,22 +4032,22 @@
                 </a:solidFill>
                 <a:latin typeface="Segoe UI"/>
               </a:rPr>
-              <a:t>Stage Distance Engine: </a:t>
+              <a:t>Back-of-Hand Swipe: </a:t>
             </a:r>
             <a:r>
               <a:rPr sz="1300">
                 <a:solidFill>
-                  <a:srgbClr val="91949B"/>
-                </a:solidFill>
-                <a:latin typeface="Segoe UI"/>
-              </a:rPr>
-              <a:t>Dynamic distance scaling works from 6–10 feet</a:t>
+                  <a:srgbClr val="94979E"/>
+                </a:solidFill>
+                <a:latin typeface="Segoe UI"/>
+              </a:rPr>
+              <a:t>Skip to next track or jump back seamlessly</a:t>
             </a:r>
           </a:p>
           <a:p>
             <a:pPr>
               <a:spcBef>
-                <a:spcPts val="600"/>
+                <a:spcPts val="700"/>
               </a:spcBef>
             </a:pPr>
             <a:r>
@@ -4050,16 +4066,16 @@
                 </a:solidFill>
                 <a:latin typeface="Segoe UI"/>
               </a:rPr>
-              <a:t>Zero Window Stealing: </a:t>
+              <a:t>Ambient Capsule HUD: </a:t>
             </a:r>
             <a:r>
               <a:rPr sz="1300">
                 <a:solidFill>
-                  <a:srgbClr val="91949B"/>
-                </a:solidFill>
-                <a:latin typeface="Segoe UI"/>
-              </a:rPr>
-              <a:t>Controls background media without losing active window focus</a:t>
+                  <a:srgbClr val="94979E"/>
+                </a:solidFill>
+                <a:latin typeface="Segoe UI"/>
+              </a:rPr>
+              <a:t>Minimal gold pill gives instant visual &amp; audio feedback</a:t>
             </a:r>
           </a:p>
         </p:txBody>
@@ -4133,8 +4149,8 @@
         </p:nvSpPr>
         <p:spPr>
           <a:xfrm>
-            <a:off x="731520" y="475488"/>
-            <a:ext cx="10728655" cy="1005840"/>
+            <a:off x="731520" y="438912"/>
+            <a:ext cx="10728655" cy="1097280"/>
           </a:xfrm>
           <a:prstGeom prst="rect">
             <a:avLst/>
@@ -4156,7 +4172,7 @@
               </a:defRPr>
             </a:pPr>
             <a:r>
-              <a:t>02 • TARGET MARKET &amp; PERSONAS</a:t>
+              <a:t>02 • WHY WE MADE IT</a:t>
             </a:r>
           </a:p>
           <a:p>
@@ -4172,7 +4188,23 @@
               </a:defRPr>
             </a:pPr>
             <a:r>
-              <a:t>Who Needs ZeroTouch: Real-World Demographics</a:t>
+              <a:t>Why We Made It: Solving The Spatial Dilemma</a:t>
+            </a:r>
+          </a:p>
+          <a:p>
+            <a:pPr>
+              <a:spcBef>
+                <a:spcPts val="200"/>
+              </a:spcBef>
+              <a:defRPr sz="1200">
+                <a:solidFill>
+                  <a:srgbClr val="94979E"/>
+                </a:solidFill>
+                <a:latin typeface="Segoe UI"/>
+              </a:defRPr>
+            </a:pPr>
+            <a:r>
+              <a:t>Computer vision software has always failed in the real world for the same core reasons.</a:t>
             </a:r>
           </a:p>
         </p:txBody>
@@ -4185,8 +4217,8 @@
         </p:nvSpPr>
         <p:spPr>
           <a:xfrm>
-            <a:off x="731520" y="1691640"/>
-            <a:ext cx="3383280" cy="4480560"/>
+            <a:off x="731520" y="1783080"/>
+            <a:ext cx="5120640" cy="4389120"/>
           </a:xfrm>
           <a:prstGeom prst="roundRect">
             <a:avLst/>
@@ -4230,8 +4262,8 @@
         </p:nvSpPr>
         <p:spPr>
           <a:xfrm>
-            <a:off x="950976" y="1892808"/>
-            <a:ext cx="2944368" cy="4078224"/>
+            <a:off x="950976" y="1984248"/>
+            <a:ext cx="4681728" cy="3986784"/>
           </a:xfrm>
           <a:prstGeom prst="rect">
             <a:avLst/>
@@ -4245,7 +4277,7 @@
           <a:lstStyle/>
           <a:p>
             <a:pPr>
-              <a:defRPr sz="1700" b="1">
+              <a:defRPr sz="1900" b="1">
                 <a:solidFill>
                   <a:srgbClr val="D4AF6A"/>
                 </a:solidFill>
@@ -4253,7 +4285,7 @@
               </a:defRPr>
             </a:pPr>
             <a:r>
-              <a:t>Hybrid Knowledge Workers</a:t>
+              <a:t>The Flaws in Past Vision Tools</a:t>
             </a:r>
           </a:p>
           <a:p>
@@ -4266,23 +4298,23 @@
               </a:spcAft>
               <a:defRPr sz="1000" b="1">
                 <a:solidFill>
-                  <a:srgbClr val="91949B"/>
+                  <a:srgbClr val="94979E"/>
                 </a:solidFill>
                 <a:latin typeface="Consolas"/>
               </a:defRPr>
             </a:pPr>
             <a:r>
-              <a:t>REMOTE &amp; ENTERPRISE TEAMS</a:t>
+              <a:t>WHY USERS TURN THEM OFF</a:t>
             </a:r>
           </a:p>
           <a:p>
             <a:pPr>
               <a:spcBef>
-                <a:spcPts val="600"/>
+                <a:spcPts val="700"/>
               </a:spcBef>
             </a:pPr>
             <a:r>
-              <a:rPr b="1" sz="1300">
+              <a:rPr b="1" sz="1350">
                 <a:solidFill>
                   <a:srgbClr val="D4AF6A"/>
                 </a:solidFill>
@@ -4291,32 +4323,32 @@
               <a:t>• </a:t>
             </a:r>
             <a:r>
-              <a:rPr b="1" sz="1300">
+              <a:rPr b="1" sz="1350">
                 <a:solidFill>
                   <a:srgbClr val="F2EFE9"/>
                 </a:solidFill>
                 <a:latin typeface="Segoe UI"/>
               </a:rPr>
-              <a:t>Daily Profile: </a:t>
-            </a:r>
-            <a:r>
-              <a:rPr sz="1300">
-                <a:solidFill>
-                  <a:srgbClr val="91949B"/>
-                </a:solidFill>
-                <a:latin typeface="Segoe UI"/>
-              </a:rPr>
-              <a:t>4–6 hours daily in Google Meet, Teams, and Zoom calls</a:t>
+              <a:t>Accidental Misfires: </a:t>
+            </a:r>
+            <a:r>
+              <a:rPr sz="1350">
+                <a:solidFill>
+                  <a:srgbClr val="94979E"/>
+                </a:solidFill>
+                <a:latin typeface="Segoe UI"/>
+              </a:rPr>
+              <a:t>Scratching face, drinking water, or typing triggers unintended actions</a:t>
             </a:r>
           </a:p>
           <a:p>
             <a:pPr>
               <a:spcBef>
-                <a:spcPts val="600"/>
+                <a:spcPts val="700"/>
               </a:spcBef>
             </a:pPr>
             <a:r>
-              <a:rPr b="1" sz="1300">
+              <a:rPr b="1" sz="1350">
                 <a:solidFill>
                   <a:srgbClr val="D4AF6A"/>
                 </a:solidFill>
@@ -4325,32 +4357,32 @@
               <a:t>• </a:t>
             </a:r>
             <a:r>
-              <a:rPr b="1" sz="1300">
+              <a:rPr b="1" sz="1350">
                 <a:solidFill>
                   <a:srgbClr val="F2EFE9"/>
                 </a:solidFill>
                 <a:latin typeface="Segoe UI"/>
               </a:rPr>
-              <a:t>Core Frustration: </a:t>
-            </a:r>
-            <a:r>
-              <a:rPr sz="1300">
-                <a:solidFill>
-                  <a:srgbClr val="91949B"/>
-                </a:solidFill>
-                <a:latin typeface="Segoe UI"/>
-              </a:rPr>
-              <a:t>Scrambling across 10 open windows to find the mute button</a:t>
+              <a:t>Hardware Monopolies: </a:t>
+            </a:r>
+            <a:r>
+              <a:rPr sz="1350">
+                <a:solidFill>
+                  <a:srgbClr val="94979E"/>
+                </a:solidFill>
+                <a:latin typeface="Segoe UI"/>
+              </a:rPr>
+              <a:t>Standard CV apps lock the webcam, crashing Zoom, Teams, or Meet</a:t>
             </a:r>
           </a:p>
           <a:p>
             <a:pPr>
               <a:spcBef>
-                <a:spcPts val="600"/>
+                <a:spcPts val="700"/>
               </a:spcBef>
             </a:pPr>
             <a:r>
-              <a:rPr b="1" sz="1300">
+              <a:rPr b="1" sz="1350">
                 <a:solidFill>
                   <a:srgbClr val="D4AF6A"/>
                 </a:solidFill>
@@ -4359,32 +4391,32 @@
               <a:t>• </a:t>
             </a:r>
             <a:r>
-              <a:rPr b="1" sz="1300">
+              <a:rPr b="1" sz="1350">
                 <a:solidFill>
                   <a:srgbClr val="F2EFE9"/>
                 </a:solidFill>
                 <a:latin typeface="Segoe UI"/>
               </a:rPr>
-              <a:t>ZeroTouch Superpower: </a:t>
-            </a:r>
-            <a:r>
-              <a:rPr sz="1300">
-                <a:solidFill>
-                  <a:srgbClr val="91949B"/>
-                </a:solidFill>
-                <a:latin typeface="Segoe UI"/>
-              </a:rPr>
-              <a:t>Instant 'Shh' hardware mute without touching window or mouse</a:t>
+              <a:t>Cloud Privacy Risks: </a:t>
+            </a:r>
+            <a:r>
+              <a:rPr sz="1350">
+                <a:solidFill>
+                  <a:srgbClr val="94979E"/>
+                </a:solidFill>
+                <a:latin typeface="Segoe UI"/>
+              </a:rPr>
+              <a:t>Enterprises reject sending sensitive video feeds to cloud servers</a:t>
             </a:r>
           </a:p>
           <a:p>
             <a:pPr>
               <a:spcBef>
-                <a:spcPts val="600"/>
+                <a:spcPts val="700"/>
               </a:spcBef>
             </a:pPr>
             <a:r>
-              <a:rPr b="1" sz="1300">
+              <a:rPr b="1" sz="1350">
                 <a:solidFill>
                   <a:srgbClr val="D4AF6A"/>
                 </a:solidFill>
@@ -4393,22 +4425,22 @@
               <a:t>• </a:t>
             </a:r>
             <a:r>
-              <a:rPr b="1" sz="1300">
+              <a:rPr b="1" sz="1350">
                 <a:solidFill>
                   <a:srgbClr val="F2EFE9"/>
                 </a:solidFill>
                 <a:latin typeface="Segoe UI"/>
               </a:rPr>
-              <a:t>Enterprise Compliance: </a:t>
-            </a:r>
-            <a:r>
-              <a:rPr sz="1300">
-                <a:solidFill>
-                  <a:srgbClr val="91949B"/>
-                </a:solidFill>
-                <a:latin typeface="Segoe UI"/>
-              </a:rPr>
-              <a:t>Runs 100% locally; satisfies strict corporate data policies</a:t>
+              <a:t>Strict Distance Limits: </a:t>
+            </a:r>
+            <a:r>
+              <a:rPr sz="1350">
+                <a:solidFill>
+                  <a:srgbClr val="94979E"/>
+                </a:solidFill>
+                <a:latin typeface="Segoe UI"/>
+              </a:rPr>
+              <a:t>Stepping away from the desk causes tracking to immediately drop</a:t>
             </a:r>
           </a:p>
         </p:txBody>
@@ -4421,8 +4453,8 @@
         </p:nvSpPr>
         <p:spPr>
           <a:xfrm>
-            <a:off x="4389120" y="1691640"/>
-            <a:ext cx="3383280" cy="4480560"/>
+            <a:off x="6217920" y="1783080"/>
+            <a:ext cx="5212080" cy="4389120"/>
           </a:xfrm>
           <a:prstGeom prst="roundRect">
             <a:avLst/>
@@ -4466,8 +4498,8 @@
         </p:nvSpPr>
         <p:spPr>
           <a:xfrm>
-            <a:off x="4608576" y="1892808"/>
-            <a:ext cx="2944368" cy="4078224"/>
+            <a:off x="6437376" y="1984248"/>
+            <a:ext cx="4773168" cy="3986784"/>
           </a:xfrm>
           <a:prstGeom prst="rect">
             <a:avLst/>
@@ -4481,7 +4513,7 @@
           <a:lstStyle/>
           <a:p>
             <a:pPr>
-              <a:defRPr sz="1700" b="1">
+              <a:defRPr sz="1900" b="1">
                 <a:solidFill>
                   <a:srgbClr val="F2EFE9"/>
                 </a:solidFill>
@@ -4489,7 +4521,7 @@
               </a:defRPr>
             </a:pPr>
             <a:r>
-              <a:t>Speakers &amp; Educators</a:t>
+              <a:t>The ZeroTouch Breakthrough</a:t>
             </a:r>
           </a:p>
           <a:p>
@@ -4502,23 +4534,23 @@
               </a:spcAft>
               <a:defRPr sz="1000" b="1">
                 <a:solidFill>
-                  <a:srgbClr val="91949B"/>
+                  <a:srgbClr val="94979E"/>
                 </a:solidFill>
                 <a:latin typeface="Consolas"/>
               </a:defRPr>
             </a:pPr>
             <a:r>
-              <a:t>KEYNOTES, LECTURERS, PITCHES</a:t>
+              <a:t>BUILT FOR REAL DAILY WORK</a:t>
             </a:r>
           </a:p>
           <a:p>
             <a:pPr>
               <a:spcBef>
-                <a:spcPts val="600"/>
+                <a:spcPts val="700"/>
               </a:spcBef>
             </a:pPr>
             <a:r>
-              <a:rPr b="1" sz="1300">
+              <a:rPr b="1" sz="1350">
                 <a:solidFill>
                   <a:srgbClr val="F2EFE9"/>
                 </a:solidFill>
@@ -4527,32 +4559,32 @@
               <a:t>• </a:t>
             </a:r>
             <a:r>
-              <a:rPr b="1" sz="1300">
+              <a:rPr b="1" sz="1350">
                 <a:solidFill>
                   <a:srgbClr val="F2EFE9"/>
                 </a:solidFill>
                 <a:latin typeface="Segoe UI"/>
               </a:rPr>
-              <a:t>Daily Profile: </a:t>
-            </a:r>
-            <a:r>
-              <a:rPr sz="1300">
-                <a:solidFill>
-                  <a:srgbClr val="91949B"/>
-                </a:solidFill>
-                <a:latin typeface="Segoe UI"/>
-              </a:rPr>
-              <a:t>Presenting to clients, lecture halls, and live pitch judges</a:t>
+              <a:t>Multimodal Filtering: </a:t>
+            </a:r>
+            <a:r>
+              <a:rPr sz="1350">
+                <a:solidFill>
+                  <a:srgbClr val="94979E"/>
+                </a:solidFill>
+                <a:latin typeface="Segoe UI"/>
+              </a:rPr>
+              <a:t>Hardware typing lockout + gaze tracking eliminate 100% of misfires</a:t>
             </a:r>
           </a:p>
           <a:p>
             <a:pPr>
               <a:spcBef>
-                <a:spcPts val="600"/>
+                <a:spcPts val="700"/>
               </a:spcBef>
             </a:pPr>
             <a:r>
-              <a:rPr b="1" sz="1300">
+              <a:rPr b="1" sz="1350">
                 <a:solidFill>
                   <a:srgbClr val="F2EFE9"/>
                 </a:solidFill>
@@ -4561,32 +4593,32 @@
               <a:t>• </a:t>
             </a:r>
             <a:r>
-              <a:rPr b="1" sz="1300">
+              <a:rPr b="1" sz="1350">
                 <a:solidFill>
                   <a:srgbClr val="F2EFE9"/>
                 </a:solidFill>
                 <a:latin typeface="Segoe UI"/>
               </a:rPr>
-              <a:t>Core Frustration: </a:t>
-            </a:r>
-            <a:r>
-              <a:rPr sz="1300">
-                <a:solidFill>
-                  <a:srgbClr val="91949B"/>
-                </a:solidFill>
-                <a:latin typeface="Segoe UI"/>
-              </a:rPr>
-              <a:t>Tethered to podium laptop or relying on dead clicker batteries</a:t>
+              <a:t>Native OS Camera Sharing: </a:t>
+            </a:r>
+            <a:r>
+              <a:rPr sz="1350">
+                <a:solidFill>
+                  <a:srgbClr val="94979E"/>
+                </a:solidFill>
+                <a:latin typeface="Segoe UI"/>
+              </a:rPr>
+              <a:t>Windows Frame Server lets Meet and ZeroTouch use camera simultaneously</a:t>
             </a:r>
           </a:p>
           <a:p>
             <a:pPr>
               <a:spcBef>
-                <a:spcPts val="600"/>
+                <a:spcPts val="700"/>
               </a:spcBef>
             </a:pPr>
             <a:r>
-              <a:rPr b="1" sz="1300">
+              <a:rPr b="1" sz="1350">
                 <a:solidFill>
                   <a:srgbClr val="F2EFE9"/>
                 </a:solidFill>
@@ -4595,32 +4627,32 @@
               <a:t>• </a:t>
             </a:r>
             <a:r>
-              <a:rPr b="1" sz="1300">
+              <a:rPr b="1" sz="1350">
                 <a:solidFill>
                   <a:srgbClr val="F2EFE9"/>
                 </a:solidFill>
                 <a:latin typeface="Segoe UI"/>
               </a:rPr>
-              <a:t>ZeroTouch Superpower: </a:t>
-            </a:r>
-            <a:r>
-              <a:rPr sz="1300">
-                <a:solidFill>
-                  <a:srgbClr val="91949B"/>
-                </a:solidFill>
-                <a:latin typeface="Segoe UI"/>
-              </a:rPr>
-              <a:t>Walk the stage freely; advance slides from 10 feet away</a:t>
+              <a:t>100% Volatile RAM: </a:t>
+            </a:r>
+            <a:r>
+              <a:rPr sz="1350">
+                <a:solidFill>
+                  <a:srgbClr val="94979E"/>
+                </a:solidFill>
+                <a:latin typeface="Segoe UI"/>
+              </a:rPr>
+              <a:t>Zero video frames saved to disk or network; complete local privacy</a:t>
             </a:r>
           </a:p>
           <a:p>
             <a:pPr>
               <a:spcBef>
-                <a:spcPts val="600"/>
+                <a:spcPts val="700"/>
               </a:spcBef>
             </a:pPr>
             <a:r>
-              <a:rPr b="1" sz="1300">
+              <a:rPr b="1" sz="1350">
                 <a:solidFill>
                   <a:srgbClr val="F2EFE9"/>
                 </a:solidFill>
@@ -4629,258 +4661,22 @@
               <a:t>• </a:t>
             </a:r>
             <a:r>
-              <a:rPr b="1" sz="1300">
+              <a:rPr b="1" sz="1350">
                 <a:solidFill>
                   <a:srgbClr val="F2EFE9"/>
                 </a:solidFill>
                 <a:latin typeface="Segoe UI"/>
               </a:rPr>
-              <a:t>Audience Command: </a:t>
-            </a:r>
-            <a:r>
-              <a:rPr sz="1300">
-                <a:solidFill>
-                  <a:srgbClr val="91949B"/>
-                </a:solidFill>
-                <a:latin typeface="Segoe UI"/>
-              </a:rPr>
-              <a:t>Hold open palm to blank screen ('B') and hold room attention</a:t>
-            </a:r>
-          </a:p>
-        </p:txBody>
-      </p:sp>
-      <p:sp>
-        <p:nvSpPr>
-          <p:cNvPr id="8" name="Rounded Rectangle 7"/>
-          <p:cNvSpPr/>
-          <p:nvPr/>
-        </p:nvSpPr>
-        <p:spPr>
-          <a:xfrm>
-            <a:off x="8046720" y="1691640"/>
-            <a:ext cx="3383280" cy="4480560"/>
-          </a:xfrm>
-          <a:prstGeom prst="roundRect">
-            <a:avLst/>
-          </a:prstGeom>
-          <a:solidFill>
-            <a:srgbClr val="181820"/>
-          </a:solidFill>
-          <a:ln w="15240">
-            <a:solidFill>
-              <a:srgbClr val="557DB9"/>
-            </a:solidFill>
-          </a:ln>
-        </p:spPr>
-        <p:style>
-          <a:lnRef idx="1">
-            <a:schemeClr val="accent1"/>
-          </a:lnRef>
-          <a:fillRef idx="3">
-            <a:schemeClr val="accent1"/>
-          </a:fillRef>
-          <a:effectRef idx="2">
-            <a:schemeClr val="accent1"/>
-          </a:effectRef>
-          <a:fontRef idx="minor">
-            <a:schemeClr val="lt1"/>
-          </a:fontRef>
-        </p:style>
-        <p:txBody>
-          <a:bodyPr rtlCol="0" anchor="ctr"/>
-          <a:lstStyle/>
-          <a:p>
-            <a:pPr algn="ctr"/>
-          </a:p>
-        </p:txBody>
-      </p:sp>
-      <p:sp>
-        <p:nvSpPr>
-          <p:cNvPr id="9" name="TextBox 8"/>
-          <p:cNvSpPr txBox="1"/>
-          <p:nvPr/>
-        </p:nvSpPr>
-        <p:spPr>
-          <a:xfrm>
-            <a:off x="8266176" y="1892808"/>
-            <a:ext cx="2944368" cy="4078224"/>
-          </a:xfrm>
-          <a:prstGeom prst="rect">
-            <a:avLst/>
-          </a:prstGeom>
-          <a:noFill/>
-        </p:spPr>
-        <p:txBody>
-          <a:bodyPr wrap="square">
-            <a:spAutoFit/>
-          </a:bodyPr>
-          <a:lstStyle/>
-          <a:p>
-            <a:pPr>
-              <a:defRPr sz="1700" b="1">
-                <a:solidFill>
-                  <a:srgbClr val="557DB9"/>
-                </a:solidFill>
-                <a:latin typeface="Segoe UI"/>
-              </a:defRPr>
-            </a:pPr>
-            <a:r>
-              <a:t>Workstation Power Users</a:t>
-            </a:r>
-          </a:p>
-          <a:p>
-            <a:pPr>
-              <a:spcBef>
-                <a:spcPts val="200"/>
-              </a:spcBef>
-              <a:spcAft>
-                <a:spcPts val="600"/>
-              </a:spcAft>
-              <a:defRPr sz="1000" b="1">
-                <a:solidFill>
-                  <a:srgbClr val="91949B"/>
-                </a:solidFill>
-                <a:latin typeface="Consolas"/>
-              </a:defRPr>
-            </a:pPr>
-            <a:r>
-              <a:t>MULTI-MONITOR &amp; ERGONOMICS</a:t>
-            </a:r>
-          </a:p>
-          <a:p>
-            <a:pPr>
-              <a:spcBef>
-                <a:spcPts val="600"/>
-              </a:spcBef>
-            </a:pPr>
-            <a:r>
-              <a:rPr b="1" sz="1300">
-                <a:solidFill>
-                  <a:srgbClr val="557DB9"/>
-                </a:solidFill>
-                <a:latin typeface="Segoe UI"/>
-              </a:rPr>
-              <a:t>• </a:t>
-            </a:r>
-            <a:r>
-              <a:rPr b="1" sz="1300">
-                <a:solidFill>
-                  <a:srgbClr val="F2EFE9"/>
-                </a:solidFill>
-                <a:latin typeface="Segoe UI"/>
-              </a:rPr>
-              <a:t>Daily Profile: </a:t>
-            </a:r>
-            <a:r>
-              <a:rPr sz="1300">
-                <a:solidFill>
-                  <a:srgbClr val="91949B"/>
-                </a:solidFill>
-                <a:latin typeface="Segoe UI"/>
-              </a:rPr>
-              <a:t>Software developers, video editors, and heavy multi-taskers</a:t>
-            </a:r>
-          </a:p>
-          <a:p>
-            <a:pPr>
-              <a:spcBef>
-                <a:spcPts val="600"/>
-              </a:spcBef>
-            </a:pPr>
-            <a:r>
-              <a:rPr b="1" sz="1300">
-                <a:solidFill>
-                  <a:srgbClr val="557DB9"/>
-                </a:solidFill>
-                <a:latin typeface="Segoe UI"/>
-              </a:rPr>
-              <a:t>• </a:t>
-            </a:r>
-            <a:r>
-              <a:rPr b="1" sz="1300">
-                <a:solidFill>
-                  <a:srgbClr val="F2EFE9"/>
-                </a:solidFill>
-                <a:latin typeface="Segoe UI"/>
-              </a:rPr>
-              <a:t>Core Frustration: </a:t>
-            </a:r>
-            <a:r>
-              <a:rPr sz="1300">
-                <a:solidFill>
-                  <a:srgbClr val="91949B"/>
-                </a:solidFill>
-                <a:latin typeface="Segoe UI"/>
-              </a:rPr>
-              <a:t>Breaking flow and Alt-Tabbing just to adjust volume or tracks</a:t>
-            </a:r>
-          </a:p>
-          <a:p>
-            <a:pPr>
-              <a:spcBef>
-                <a:spcPts val="600"/>
-              </a:spcBef>
-            </a:pPr>
-            <a:r>
-              <a:rPr b="1" sz="1300">
-                <a:solidFill>
-                  <a:srgbClr val="557DB9"/>
-                </a:solidFill>
-                <a:latin typeface="Segoe UI"/>
-              </a:rPr>
-              <a:t>• </a:t>
-            </a:r>
-            <a:r>
-              <a:rPr b="1" sz="1300">
-                <a:solidFill>
-                  <a:srgbClr val="F2EFE9"/>
-                </a:solidFill>
-                <a:latin typeface="Segoe UI"/>
-              </a:rPr>
-              <a:t>ZeroTouch Superpower: </a:t>
-            </a:r>
-            <a:r>
-              <a:rPr sz="1300">
-                <a:solidFill>
-                  <a:srgbClr val="91949B"/>
-                </a:solidFill>
-                <a:latin typeface="Segoe UI"/>
-              </a:rPr>
-              <a:t>Spatial volume and track controls without stealing keyboard focus</a:t>
-            </a:r>
-          </a:p>
-          <a:p>
-            <a:pPr>
-              <a:spcBef>
-                <a:spcPts val="600"/>
-              </a:spcBef>
-            </a:pPr>
-            <a:r>
-              <a:rPr b="1" sz="1300">
-                <a:solidFill>
-                  <a:srgbClr val="557DB9"/>
-                </a:solidFill>
-                <a:latin typeface="Segoe UI"/>
-              </a:rPr>
-              <a:t>• </a:t>
-            </a:r>
-            <a:r>
-              <a:rPr b="1" sz="1300">
-                <a:solidFill>
-                  <a:srgbClr val="F2EFE9"/>
-                </a:solidFill>
-                <a:latin typeface="Segoe UI"/>
-              </a:rPr>
-              <a:t>Ergonomic Relief: </a:t>
-            </a:r>
-            <a:r>
-              <a:rPr sz="1300">
-                <a:solidFill>
-                  <a:srgbClr val="91949B"/>
-                </a:solidFill>
-                <a:latin typeface="Segoe UI"/>
-              </a:rPr>
-              <a:t>Hands-free micro-gestures reduce repetitive mouse-clutching strain (RSI)</a:t>
+              <a:t>Adaptive Stage Scaling: </a:t>
+            </a:r>
+            <a:r>
+              <a:rPr sz="1350">
+                <a:solidFill>
+                  <a:srgbClr val="94979E"/>
+                </a:solidFill>
+                <a:latin typeface="Segoe UI"/>
+              </a:rPr>
+              <a:t>Vision engine dynamically scales reach for presentations at 6–10 feet</a:t>
             </a:r>
           </a:p>
         </p:txBody>
@@ -4954,8 +4750,8 @@
         </p:nvSpPr>
         <p:spPr>
           <a:xfrm>
-            <a:off x="731520" y="475488"/>
-            <a:ext cx="10728655" cy="1005840"/>
+            <a:off x="731520" y="438912"/>
+            <a:ext cx="10728655" cy="1097280"/>
           </a:xfrm>
           <a:prstGeom prst="rect">
             <a:avLst/>
@@ -4977,7 +4773,7 @@
               </a:defRPr>
             </a:pPr>
             <a:r>
-              <a:t>03 • COMPUTER VISION DEFENSE</a:t>
+              <a:t>03 • WHO IT'S FOR</a:t>
             </a:r>
           </a:p>
           <a:p>
@@ -4993,7 +4789,23 @@
               </a:defRPr>
             </a:pPr>
             <a:r>
-              <a:t>Noise Defense: Eliminating False Triggers</a:t>
+              <a:t>Who It's For: Three Core Real-World Demographics</a:t>
+            </a:r>
+          </a:p>
+          <a:p>
+            <a:pPr>
+              <a:spcBef>
+                <a:spcPts val="200"/>
+              </a:spcBef>
+              <a:defRPr sz="1200">
+                <a:solidFill>
+                  <a:srgbClr val="94979E"/>
+                </a:solidFill>
+                <a:latin typeface="Segoe UI"/>
+              </a:defRPr>
+            </a:pPr>
+            <a:r>
+              <a:t>Designed for users who spend their days at workstations, in calls, or on stage.</a:t>
             </a:r>
           </a:p>
         </p:txBody>
@@ -5006,8 +4818,8 @@
         </p:nvSpPr>
         <p:spPr>
           <a:xfrm>
-            <a:off x="731520" y="1691640"/>
-            <a:ext cx="5120640" cy="2148840"/>
+            <a:off x="731520" y="1783080"/>
+            <a:ext cx="3383280" cy="4389120"/>
           </a:xfrm>
           <a:prstGeom prst="roundRect">
             <a:avLst/>
@@ -5051,8 +4863,8 @@
         </p:nvSpPr>
         <p:spPr>
           <a:xfrm>
-            <a:off x="950976" y="1892808"/>
-            <a:ext cx="4681728" cy="1746504"/>
+            <a:off x="950976" y="1984248"/>
+            <a:ext cx="2944368" cy="3986784"/>
           </a:xfrm>
           <a:prstGeom prst="rect">
             <a:avLst/>
@@ -5066,7 +4878,7 @@
           <a:lstStyle/>
           <a:p>
             <a:pPr>
-              <a:defRPr sz="1600" b="1">
+              <a:defRPr sz="1800" b="1">
                 <a:solidFill>
                   <a:srgbClr val="D4AF6A"/>
                 </a:solidFill>
@@ -5074,7 +4886,7 @@
               </a:defRPr>
             </a:pPr>
             <a:r>
-              <a:t>Smart Activity Lockout</a:t>
+              <a:t>Hybrid Knowledge Workers</a:t>
             </a:r>
           </a:p>
           <a:p>
@@ -5087,23 +4899,23 @@
               </a:spcAft>
               <a:defRPr sz="1000" b="1">
                 <a:solidFill>
-                  <a:srgbClr val="91949B"/>
+                  <a:srgbClr val="94979E"/>
                 </a:solidFill>
                 <a:latin typeface="Consolas"/>
               </a:defRPr>
             </a:pPr>
             <a:r>
-              <a:t>TYPE &amp; CLICK DETECTION</a:t>
+              <a:t>REMOTE &amp; ENTERPRISE TEAMS</a:t>
             </a:r>
           </a:p>
           <a:p>
             <a:pPr>
               <a:spcBef>
-                <a:spcPts val="600"/>
+                <a:spcPts val="700"/>
               </a:spcBef>
             </a:pPr>
             <a:r>
-              <a:rPr b="1" sz="1200">
+              <a:rPr b="1" sz="1300">
                 <a:solidFill>
                   <a:srgbClr val="D4AF6A"/>
                 </a:solidFill>
@@ -5112,32 +4924,32 @@
               <a:t>• </a:t>
             </a:r>
             <a:r>
-              <a:rPr b="1" sz="1200">
+              <a:rPr b="1" sz="1300">
                 <a:solidFill>
                   <a:srgbClr val="F2EFE9"/>
                 </a:solidFill>
                 <a:latin typeface="Segoe UI"/>
               </a:rPr>
-              <a:t>Hardware Intercept: </a:t>
-            </a:r>
-            <a:r>
-              <a:rPr sz="1200">
-                <a:solidFill>
-                  <a:srgbClr val="91949B"/>
-                </a:solidFill>
-                <a:latin typeface="Segoe UI"/>
-              </a:rPr>
-              <a:t>Global pynput hooks detect active typing &amp; mouse clicks</a:t>
+              <a:t>Daily Profile: </a:t>
+            </a:r>
+            <a:r>
+              <a:rPr sz="1300">
+                <a:solidFill>
+                  <a:srgbClr val="94979E"/>
+                </a:solidFill>
+                <a:latin typeface="Segoe UI"/>
+              </a:rPr>
+              <a:t>Spends 4–6 hours daily in Google Meet, Teams, or Zoom</a:t>
             </a:r>
           </a:p>
           <a:p>
             <a:pPr>
               <a:spcBef>
-                <a:spcPts val="600"/>
+                <a:spcPts val="700"/>
               </a:spcBef>
             </a:pPr>
             <a:r>
-              <a:rPr b="1" sz="1200">
+              <a:rPr b="1" sz="1300">
                 <a:solidFill>
                   <a:srgbClr val="D4AF6A"/>
                 </a:solidFill>
@@ -5146,22 +4958,90 @@
               <a:t>• </a:t>
             </a:r>
             <a:r>
-              <a:rPr b="1" sz="1200">
+              <a:rPr b="1" sz="1300">
                 <a:solidFill>
                   <a:srgbClr val="F2EFE9"/>
                 </a:solidFill>
                 <a:latin typeface="Segoe UI"/>
               </a:rPr>
-              <a:t>Smart Sleep: </a:t>
-            </a:r>
-            <a:r>
-              <a:rPr sz="1200">
-                <a:solidFill>
-                  <a:srgbClr val="91949B"/>
-                </a:solidFill>
-                <a:latin typeface="Segoe UI"/>
-              </a:rPr>
-              <a:t>Gestures instantly sleep while typing; zero accidental misfires</a:t>
+              <a:t>Core Pain Point: </a:t>
+            </a:r>
+            <a:r>
+              <a:rPr sz="1300">
+                <a:solidFill>
+                  <a:srgbClr val="94979E"/>
+                </a:solidFill>
+                <a:latin typeface="Segoe UI"/>
+              </a:rPr>
+              <a:t>Frantically scrambling across 10 windows to mute during coughs</a:t>
+            </a:r>
+          </a:p>
+          <a:p>
+            <a:pPr>
+              <a:spcBef>
+                <a:spcPts val="700"/>
+              </a:spcBef>
+            </a:pPr>
+            <a:r>
+              <a:rPr b="1" sz="1300">
+                <a:solidFill>
+                  <a:srgbClr val="D4AF6A"/>
+                </a:solidFill>
+                <a:latin typeface="Segoe UI"/>
+              </a:rPr>
+              <a:t>• </a:t>
+            </a:r>
+            <a:r>
+              <a:rPr b="1" sz="1300">
+                <a:solidFill>
+                  <a:srgbClr val="F2EFE9"/>
+                </a:solidFill>
+                <a:latin typeface="Segoe UI"/>
+              </a:rPr>
+              <a:t>ZeroTouch Win: </a:t>
+            </a:r>
+            <a:r>
+              <a:rPr sz="1300">
+                <a:solidFill>
+                  <a:srgbClr val="94979E"/>
+                </a:solidFill>
+                <a:latin typeface="Segoe UI"/>
+              </a:rPr>
+              <a:t>Instant 'Shh' hardware mute without touching window or mouse</a:t>
+            </a:r>
+          </a:p>
+          <a:p>
+            <a:pPr>
+              <a:spcBef>
+                <a:spcPts val="700"/>
+              </a:spcBef>
+            </a:pPr>
+            <a:r>
+              <a:rPr b="1" sz="1300">
+                <a:solidFill>
+                  <a:srgbClr val="D4AF6A"/>
+                </a:solidFill>
+                <a:latin typeface="Segoe UI"/>
+              </a:rPr>
+              <a:t>• </a:t>
+            </a:r>
+            <a:r>
+              <a:rPr b="1" sz="1300">
+                <a:solidFill>
+                  <a:srgbClr val="F2EFE9"/>
+                </a:solidFill>
+                <a:latin typeface="Segoe UI"/>
+              </a:rPr>
+              <a:t>IT Security: </a:t>
+            </a:r>
+            <a:r>
+              <a:rPr sz="1300">
+                <a:solidFill>
+                  <a:srgbClr val="94979E"/>
+                </a:solidFill>
+                <a:latin typeface="Segoe UI"/>
+              </a:rPr>
+              <a:t>Local-only processing passes corporate compliance &amp; security</a:t>
             </a:r>
           </a:p>
         </p:txBody>
@@ -5174,8 +5054,8 @@
         </p:nvSpPr>
         <p:spPr>
           <a:xfrm>
-            <a:off x="731520" y="4023360"/>
-            <a:ext cx="5120640" cy="2148840"/>
+            <a:off x="4389120" y="1783080"/>
+            <a:ext cx="3383280" cy="4389120"/>
           </a:xfrm>
           <a:prstGeom prst="roundRect">
             <a:avLst/>
@@ -5219,8 +5099,8 @@
         </p:nvSpPr>
         <p:spPr>
           <a:xfrm>
-            <a:off x="950976" y="4224528"/>
-            <a:ext cx="4681728" cy="1746504"/>
+            <a:off x="4608576" y="1984248"/>
+            <a:ext cx="2944368" cy="3986784"/>
           </a:xfrm>
           <a:prstGeom prst="rect">
             <a:avLst/>
@@ -5234,7 +5114,7 @@
           <a:lstStyle/>
           <a:p>
             <a:pPr>
-              <a:defRPr sz="1600" b="1">
+              <a:defRPr sz="1800" b="1">
                 <a:solidFill>
                   <a:srgbClr val="F2EFE9"/>
                 </a:solidFill>
@@ -5242,7 +5122,7 @@
               </a:defRPr>
             </a:pPr>
             <a:r>
-              <a:t>Gaze-Clutch™ Technology</a:t>
+              <a:t>Speakers &amp; Educators</a:t>
             </a:r>
           </a:p>
           <a:p>
@@ -5255,23 +5135,23 @@
               </a:spcAft>
               <a:defRPr sz="1000" b="1">
                 <a:solidFill>
-                  <a:srgbClr val="91949B"/>
+                  <a:srgbClr val="94979E"/>
                 </a:solidFill>
                 <a:latin typeface="Consolas"/>
               </a:defRPr>
             </a:pPr>
             <a:r>
-              <a:t>LOOK-TO-CONTROL</a:t>
+              <a:t>KEYNOTES, LECTURERS, PITCHES</a:t>
             </a:r>
           </a:p>
           <a:p>
             <a:pPr>
               <a:spcBef>
-                <a:spcPts val="600"/>
+                <a:spcPts val="700"/>
               </a:spcBef>
             </a:pPr>
             <a:r>
-              <a:rPr b="1" sz="1200">
+              <a:rPr b="1" sz="1300">
                 <a:solidFill>
                   <a:srgbClr val="F2EFE9"/>
                 </a:solidFill>
@@ -5280,32 +5160,32 @@
               <a:t>• </a:t>
             </a:r>
             <a:r>
-              <a:rPr b="1" sz="1200">
+              <a:rPr b="1" sz="1300">
                 <a:solidFill>
                   <a:srgbClr val="F2EFE9"/>
                 </a:solidFill>
                 <a:latin typeface="Segoe UI"/>
               </a:rPr>
-              <a:t>Head Yaw Telemetry: </a:t>
-            </a:r>
-            <a:r>
-              <a:rPr sz="1200">
-                <a:solidFill>
-                  <a:srgbClr val="91949B"/>
-                </a:solidFill>
-                <a:latin typeface="Segoe UI"/>
-              </a:rPr>
-              <a:t>Monitors 3D facial orientation and pupillary distance</a:t>
+              <a:t>Daily Profile: </a:t>
+            </a:r>
+            <a:r>
+              <a:rPr sz="1300">
+                <a:solidFill>
+                  <a:srgbClr val="94979E"/>
+                </a:solidFill>
+                <a:latin typeface="Segoe UI"/>
+              </a:rPr>
+              <a:t>Presenting to boardrooms, lecture halls, and live pitch judges</a:t>
             </a:r>
           </a:p>
           <a:p>
             <a:pPr>
               <a:spcBef>
-                <a:spcPts val="600"/>
+                <a:spcPts val="700"/>
               </a:spcBef>
             </a:pPr>
             <a:r>
-              <a:rPr b="1" sz="1200">
+              <a:rPr b="1" sz="1300">
                 <a:solidFill>
                   <a:srgbClr val="F2EFE9"/>
                 </a:solidFill>
@@ -5314,22 +5194,90 @@
               <a:t>• </a:t>
             </a:r>
             <a:r>
-              <a:rPr b="1" sz="1200">
+              <a:rPr b="1" sz="1300">
                 <a:solidFill>
                   <a:srgbClr val="F2EFE9"/>
                 </a:solidFill>
                 <a:latin typeface="Segoe UI"/>
               </a:rPr>
-              <a:t>Intent Verification: </a:t>
-            </a:r>
-            <a:r>
-              <a:rPr sz="1200">
-                <a:solidFill>
-                  <a:srgbClr val="91949B"/>
-                </a:solidFill>
-                <a:latin typeface="Segoe UI"/>
-              </a:rPr>
-              <a:t>Looking at other monitors automatically clutches gestures to standby</a:t>
+              <a:t>Core Pain Point: </a:t>
+            </a:r>
+            <a:r>
+              <a:rPr sz="1300">
+                <a:solidFill>
+                  <a:srgbClr val="94979E"/>
+                </a:solidFill>
+                <a:latin typeface="Segoe UI"/>
+              </a:rPr>
+              <a:t>Glued to the podium laptop or dealing with dead clicker remotes</a:t>
+            </a:r>
+          </a:p>
+          <a:p>
+            <a:pPr>
+              <a:spcBef>
+                <a:spcPts val="700"/>
+              </a:spcBef>
+            </a:pPr>
+            <a:r>
+              <a:rPr b="1" sz="1300">
+                <a:solidFill>
+                  <a:srgbClr val="F2EFE9"/>
+                </a:solidFill>
+                <a:latin typeface="Segoe UI"/>
+              </a:rPr>
+              <a:t>• </a:t>
+            </a:r>
+            <a:r>
+              <a:rPr b="1" sz="1300">
+                <a:solidFill>
+                  <a:srgbClr val="F2EFE9"/>
+                </a:solidFill>
+                <a:latin typeface="Segoe UI"/>
+              </a:rPr>
+              <a:t>ZeroTouch Win: </a:t>
+            </a:r>
+            <a:r>
+              <a:rPr sz="1300">
+                <a:solidFill>
+                  <a:srgbClr val="94979E"/>
+                </a:solidFill>
+                <a:latin typeface="Segoe UI"/>
+              </a:rPr>
+              <a:t>Walk the stage freely; navigate slides naturally from 10 feet</a:t>
+            </a:r>
+          </a:p>
+          <a:p>
+            <a:pPr>
+              <a:spcBef>
+                <a:spcPts val="700"/>
+              </a:spcBef>
+            </a:pPr>
+            <a:r>
+              <a:rPr b="1" sz="1300">
+                <a:solidFill>
+                  <a:srgbClr val="F2EFE9"/>
+                </a:solidFill>
+                <a:latin typeface="Segoe UI"/>
+              </a:rPr>
+              <a:t>• </a:t>
+            </a:r>
+            <a:r>
+              <a:rPr b="1" sz="1300">
+                <a:solidFill>
+                  <a:srgbClr val="F2EFE9"/>
+                </a:solidFill>
+                <a:latin typeface="Segoe UI"/>
+              </a:rPr>
+              <a:t>Command The Room: </a:t>
+            </a:r>
+            <a:r>
+              <a:rPr sz="1300">
+                <a:solidFill>
+                  <a:srgbClr val="94979E"/>
+                </a:solidFill>
+                <a:latin typeface="Segoe UI"/>
+              </a:rPr>
+              <a:t>Hold palm to blank screen ('B') and hold audience attention</a:t>
             </a:r>
           </a:p>
         </p:txBody>
@@ -5342,8 +5290,8 @@
         </p:nvSpPr>
         <p:spPr>
           <a:xfrm>
-            <a:off x="6217920" y="1691640"/>
-            <a:ext cx="5212080" cy="2148840"/>
+            <a:off x="8046720" y="1783080"/>
+            <a:ext cx="3383280" cy="4389120"/>
           </a:xfrm>
           <a:prstGeom prst="roundRect">
             <a:avLst/>
@@ -5387,8 +5335,8 @@
         </p:nvSpPr>
         <p:spPr>
           <a:xfrm>
-            <a:off x="6437376" y="1892808"/>
-            <a:ext cx="4773168" cy="1746504"/>
+            <a:off x="8266176" y="1984248"/>
+            <a:ext cx="2944368" cy="3986784"/>
           </a:xfrm>
           <a:prstGeom prst="rect">
             <a:avLst/>
@@ -5402,7 +5350,7 @@
           <a:lstStyle/>
           <a:p>
             <a:pPr>
-              <a:defRPr sz="1600" b="1">
+              <a:defRPr sz="1800" b="1">
                 <a:solidFill>
                   <a:srgbClr val="557DB9"/>
                 </a:solidFill>
@@ -5410,7 +5358,7 @@
               </a:defRPr>
             </a:pPr>
             <a:r>
-              <a:t>ShoulderGuard™ Intruder Shield</a:t>
+              <a:t>Power Users &amp; Ergonomics</a:t>
             </a:r>
           </a:p>
           <a:p>
@@ -5423,23 +5371,23 @@
               </a:spcAft>
               <a:defRPr sz="1000" b="1">
                 <a:solidFill>
-                  <a:srgbClr val="91949B"/>
+                  <a:srgbClr val="94979E"/>
                 </a:solidFill>
                 <a:latin typeface="Consolas"/>
               </a:defRPr>
             </a:pPr>
             <a:r>
-              <a:t>PRIVACY PROTECTION</a:t>
+              <a:t>WORKSTATION &amp; ACCESSIBILITY</a:t>
             </a:r>
           </a:p>
           <a:p>
             <a:pPr>
               <a:spcBef>
-                <a:spcPts val="600"/>
+                <a:spcPts val="700"/>
               </a:spcBef>
             </a:pPr>
             <a:r>
-              <a:rPr b="1" sz="1200">
+              <a:rPr b="1" sz="1300">
                 <a:solidFill>
                   <a:srgbClr val="557DB9"/>
                 </a:solidFill>
@@ -5448,32 +5396,32 @@
               <a:t>• </a:t>
             </a:r>
             <a:r>
-              <a:rPr b="1" sz="1200">
+              <a:rPr b="1" sz="1300">
                 <a:solidFill>
                   <a:srgbClr val="F2EFE9"/>
                 </a:solidFill>
                 <a:latin typeface="Segoe UI"/>
               </a:rPr>
-              <a:t>Background Face Scan: </a:t>
-            </a:r>
-            <a:r>
-              <a:rPr sz="1200">
-                <a:solidFill>
-                  <a:srgbClr val="91949B"/>
-                </a:solidFill>
-                <a:latin typeface="Segoe UI"/>
-              </a:rPr>
-              <a:t>BlazeFace scans continuous periphery for shoulder surfers</a:t>
+              <a:t>Daily Profile: </a:t>
+            </a:r>
+            <a:r>
+              <a:rPr sz="1300">
+                <a:solidFill>
+                  <a:srgbClr val="94979E"/>
+                </a:solidFill>
+                <a:latin typeface="Segoe UI"/>
+              </a:rPr>
+              <a:t>Developers, video editors, and heavy multi-monitor multi-taskers</a:t>
             </a:r>
           </a:p>
           <a:p>
             <a:pPr>
               <a:spcBef>
-                <a:spcPts val="600"/>
+                <a:spcPts val="700"/>
               </a:spcBef>
             </a:pPr>
             <a:r>
-              <a:rPr b="1" sz="1200">
+              <a:rPr b="1" sz="1300">
                 <a:solidFill>
                   <a:srgbClr val="557DB9"/>
                 </a:solidFill>
@@ -5482,190 +5430,90 @@
               <a:t>• </a:t>
             </a:r>
             <a:r>
-              <a:rPr b="1" sz="1200">
+              <a:rPr b="1" sz="1300">
                 <a:solidFill>
                   <a:srgbClr val="F2EFE9"/>
                 </a:solidFill>
                 <a:latin typeface="Segoe UI"/>
               </a:rPr>
-              <a:t>Instant Boss Key: </a:t>
-            </a:r>
-            <a:r>
-              <a:rPr sz="1200">
-                <a:solidFill>
-                  <a:srgbClr val="91949B"/>
-                </a:solidFill>
-                <a:latin typeface="Segoe UI"/>
-              </a:rPr>
-              <a:t>Second face detected automatically minimizes to desktop (Win+D)</a:t>
-            </a:r>
-          </a:p>
-        </p:txBody>
-      </p:sp>
-      <p:sp>
-        <p:nvSpPr>
-          <p:cNvPr id="10" name="Rounded Rectangle 9"/>
-          <p:cNvSpPr/>
-          <p:nvPr/>
-        </p:nvSpPr>
-        <p:spPr>
-          <a:xfrm>
-            <a:off x="6217920" y="4023360"/>
-            <a:ext cx="5212080" cy="2148840"/>
-          </a:xfrm>
-          <a:prstGeom prst="roundRect">
-            <a:avLst/>
-          </a:prstGeom>
-          <a:solidFill>
-            <a:srgbClr val="181820"/>
-          </a:solidFill>
-          <a:ln w="15240">
-            <a:solidFill>
-              <a:srgbClr val="D4AF6A"/>
-            </a:solidFill>
-          </a:ln>
-        </p:spPr>
-        <p:style>
-          <a:lnRef idx="1">
-            <a:schemeClr val="accent1"/>
-          </a:lnRef>
-          <a:fillRef idx="3">
-            <a:schemeClr val="accent1"/>
-          </a:fillRef>
-          <a:effectRef idx="2">
-            <a:schemeClr val="accent1"/>
-          </a:effectRef>
-          <a:fontRef idx="minor">
-            <a:schemeClr val="lt1"/>
-          </a:fontRef>
-        </p:style>
-        <p:txBody>
-          <a:bodyPr rtlCol="0" anchor="ctr"/>
-          <a:lstStyle/>
-          <a:p>
-            <a:pPr algn="ctr"/>
-          </a:p>
-        </p:txBody>
-      </p:sp>
-      <p:sp>
-        <p:nvSpPr>
-          <p:cNvPr id="11" name="TextBox 10"/>
-          <p:cNvSpPr txBox="1"/>
-          <p:nvPr/>
-        </p:nvSpPr>
-        <p:spPr>
-          <a:xfrm>
-            <a:off x="6437376" y="4224528"/>
-            <a:ext cx="4773168" cy="1746504"/>
-          </a:xfrm>
-          <a:prstGeom prst="rect">
-            <a:avLst/>
-          </a:prstGeom>
-          <a:noFill/>
-        </p:spPr>
-        <p:txBody>
-          <a:bodyPr wrap="square">
-            <a:spAutoFit/>
-          </a:bodyPr>
-          <a:lstStyle/>
-          <a:p>
-            <a:pPr>
-              <a:defRPr sz="1600" b="1">
-                <a:solidFill>
-                  <a:srgbClr val="D4AF6A"/>
-                </a:solidFill>
-                <a:latin typeface="Segoe UI"/>
-              </a:defRPr>
-            </a:pPr>
-            <a:r>
-              <a:t>Body Ownership &amp; Physics Engine</a:t>
+              <a:t>Core Pain Point: </a:t>
+            </a:r>
+            <a:r>
+              <a:rPr sz="1300">
+                <a:solidFill>
+                  <a:srgbClr val="94979E"/>
+                </a:solidFill>
+                <a:latin typeface="Segoe UI"/>
+              </a:rPr>
+              <a:t>Breaking deep flow just to Alt-Tab and adjust volume or songs</a:t>
             </a:r>
           </a:p>
           <a:p>
             <a:pPr>
               <a:spcBef>
-                <a:spcPts val="200"/>
+                <a:spcPts val="700"/>
               </a:spcBef>
-              <a:spcAft>
-                <a:spcPts val="600"/>
-              </a:spcAft>
-              <a:defRPr sz="1000" b="1">
-                <a:solidFill>
-                  <a:srgbClr val="91949B"/>
-                </a:solidFill>
-                <a:latin typeface="Consolas"/>
-              </a:defRPr>
-            </a:pPr>
-            <a:r>
-              <a:t>ANTI-JITTER &amp; REACH BOUNDS</a:t>
+            </a:pPr>
+            <a:r>
+              <a:rPr b="1" sz="1300">
+                <a:solidFill>
+                  <a:srgbClr val="557DB9"/>
+                </a:solidFill>
+                <a:latin typeface="Segoe UI"/>
+              </a:rPr>
+              <a:t>• </a:t>
+            </a:r>
+            <a:r>
+              <a:rPr b="1" sz="1300">
+                <a:solidFill>
+                  <a:srgbClr val="F2EFE9"/>
+                </a:solidFill>
+                <a:latin typeface="Segoe UI"/>
+              </a:rPr>
+              <a:t>ZeroTouch Win: </a:t>
+            </a:r>
+            <a:r>
+              <a:rPr sz="1300">
+                <a:solidFill>
+                  <a:srgbClr val="94979E"/>
+                </a:solidFill>
+                <a:latin typeface="Segoe UI"/>
+              </a:rPr>
+              <a:t>Adjust background media on the fly without losing active focus</a:t>
             </a:r>
           </a:p>
           <a:p>
             <a:pPr>
               <a:spcBef>
-                <a:spcPts val="600"/>
+                <a:spcPts val="700"/>
               </a:spcBef>
             </a:pPr>
             <a:r>
-              <a:rPr b="1" sz="1200">
-                <a:solidFill>
-                  <a:srgbClr val="D4AF6A"/>
+              <a:rPr b="1" sz="1300">
+                <a:solidFill>
+                  <a:srgbClr val="557DB9"/>
                 </a:solidFill>
                 <a:latin typeface="Segoe UI"/>
               </a:rPr>
               <a:t>• </a:t>
             </a:r>
             <a:r>
-              <a:rPr b="1" sz="1200">
+              <a:rPr b="1" sz="1300">
                 <a:solidFill>
                   <a:srgbClr val="F2EFE9"/>
                 </a:solidFill>
                 <a:latin typeface="Segoe UI"/>
               </a:rPr>
-              <a:t>Passerby Rejection: </a:t>
-            </a:r>
-            <a:r>
-              <a:rPr sz="1200">
-                <a:solidFill>
-                  <a:srgbClr val="91949B"/>
-                </a:solidFill>
-                <a:latin typeface="Segoe UI"/>
-              </a:rPr>
-              <a:t>Locks control to primary user; rejects background passerby hands</a:t>
-            </a:r>
-          </a:p>
-          <a:p>
-            <a:pPr>
-              <a:spcBef>
-                <a:spcPts val="600"/>
-              </a:spcBef>
-            </a:pPr>
-            <a:r>
-              <a:rPr b="1" sz="1200">
-                <a:solidFill>
-                  <a:srgbClr val="D4AF6A"/>
-                </a:solidFill>
-                <a:latin typeface="Segoe UI"/>
-              </a:rPr>
-              <a:t>• </a:t>
-            </a:r>
-            <a:r>
-              <a:rPr b="1" sz="1200">
-                <a:solidFill>
-                  <a:srgbClr val="F2EFE9"/>
-                </a:solidFill>
-                <a:latin typeface="Segoe UI"/>
-              </a:rPr>
-              <a:t>Bone Length Physics: </a:t>
-            </a:r>
-            <a:r>
-              <a:rPr sz="1200">
-                <a:solidFill>
-                  <a:srgbClr val="91949B"/>
-                </a:solidFill>
-                <a:latin typeface="Segoe UI"/>
-              </a:rPr>
-              <a:t>Freezes hallucinated joints when gripping phones or objects</a:t>
+              <a:t>Ergonomic Relief: </a:t>
+            </a:r>
+            <a:r>
+              <a:rPr sz="1300">
+                <a:solidFill>
+                  <a:srgbClr val="94979E"/>
+                </a:solidFill>
+                <a:latin typeface="Segoe UI"/>
+              </a:rPr>
+              <a:t>Hands-free micro-gestures relieve constant mouse-clutching strain</a:t>
             </a:r>
           </a:p>
         </p:txBody>
@@ -5739,8 +5587,8 @@
         </p:nvSpPr>
         <p:spPr>
           <a:xfrm>
-            <a:off x="731520" y="475488"/>
-            <a:ext cx="10728655" cy="1005840"/>
+            <a:off x="731520" y="438912"/>
+            <a:ext cx="10728655" cy="1097280"/>
           </a:xfrm>
           <a:prstGeom prst="rect">
             <a:avLst/>
@@ -5762,7 +5610,7 @@
               </a:defRPr>
             </a:pPr>
             <a:r>
-              <a:t>04 • ARCHITECTURE &amp; SUMMARY</a:t>
+              <a:t>04 • EXTRA DETAILS</a:t>
             </a:r>
           </a:p>
           <a:p>
@@ -5778,7 +5626,23 @@
               </a:defRPr>
             </a:pPr>
             <a:r>
-              <a:t>Engineering Architecture &amp; Why ZeroTouch Wins</a:t>
+              <a:t>Extra Details: Noise Defense &amp; System Architecture</a:t>
+            </a:r>
+          </a:p>
+          <a:p>
+            <a:pPr>
+              <a:spcBef>
+                <a:spcPts val="200"/>
+              </a:spcBef>
+              <a:defRPr sz="1200">
+                <a:solidFill>
+                  <a:srgbClr val="94979E"/>
+                </a:solidFill>
+                <a:latin typeface="Segoe UI"/>
+              </a:defRPr>
+            </a:pPr>
+            <a:r>
+              <a:t>The technical defenses and OS integrations that make ZeroTouch enterprise-ready.</a:t>
             </a:r>
           </a:p>
         </p:txBody>
@@ -5791,8 +5655,8 @@
         </p:nvSpPr>
         <p:spPr>
           <a:xfrm>
-            <a:off x="731520" y="1691640"/>
-            <a:ext cx="5120640" cy="4480560"/>
+            <a:off x="731520" y="1783080"/>
+            <a:ext cx="5120640" cy="4389120"/>
           </a:xfrm>
           <a:prstGeom prst="roundRect">
             <a:avLst/>
@@ -5836,8 +5700,8 @@
         </p:nvSpPr>
         <p:spPr>
           <a:xfrm>
-            <a:off x="950976" y="1892808"/>
-            <a:ext cx="4681728" cy="4078224"/>
+            <a:off x="950976" y="1984248"/>
+            <a:ext cx="4681728" cy="3986784"/>
           </a:xfrm>
           <a:prstGeom prst="rect">
             <a:avLst/>
@@ -5851,7 +5715,7 @@
           <a:lstStyle/>
           <a:p>
             <a:pPr>
-              <a:defRPr sz="1700" b="1">
+              <a:defRPr sz="1800" b="1">
                 <a:solidFill>
                   <a:srgbClr val="557DB9"/>
                 </a:solidFill>
@@ -5859,7 +5723,7 @@
               </a:defRPr>
             </a:pPr>
             <a:r>
-              <a:t>High-Performance Architecture</a:t>
+              <a:t>4-Layer False-Trigger Defense</a:t>
             </a:r>
           </a:p>
           <a:p>
@@ -5872,19 +5736,19 @@
               </a:spcAft>
               <a:defRPr sz="1000" b="1">
                 <a:solidFill>
-                  <a:srgbClr val="91949B"/>
+                  <a:srgbClr val="94979E"/>
                 </a:solidFill>
                 <a:latin typeface="Consolas"/>
               </a:defRPr>
             </a:pPr>
             <a:r>
-              <a:t>WINDOWS OS INTEGRATION</a:t>
+              <a:t>HOW WE STOPPED ACCIDENTAL CLICKS</a:t>
             </a:r>
           </a:p>
           <a:p>
             <a:pPr>
               <a:spcBef>
-                <a:spcPts val="600"/>
+                <a:spcPts val="700"/>
               </a:spcBef>
             </a:pPr>
             <a:r>
@@ -5903,22 +5767,22 @@
                 </a:solidFill>
                 <a:latin typeface="Segoe UI"/>
               </a:rPr>
-              <a:t>Zero-Copy Shared Memory: </a:t>
+              <a:t>Smart Activity Lockout: </a:t>
             </a:r>
             <a:r>
               <a:rPr sz="1300">
                 <a:solidFill>
-                  <a:srgbClr val="91949B"/>
-                </a:solidFill>
-                <a:latin typeface="Segoe UI"/>
-              </a:rPr>
-              <a:t>multiprocessing.shared_memory streams 30 FPS HUD previews</a:t>
+                  <a:srgbClr val="94979E"/>
+                </a:solidFill>
+                <a:latin typeface="Segoe UI"/>
+              </a:rPr>
+              <a:t>Global hooks detect keyboard/mouse; pauses gestures while typing</a:t>
             </a:r>
           </a:p>
           <a:p>
             <a:pPr>
               <a:spcBef>
-                <a:spcPts val="600"/>
+                <a:spcPts val="700"/>
               </a:spcBef>
             </a:pPr>
             <a:r>
@@ -5937,22 +5801,22 @@
                 </a:solidFill>
                 <a:latin typeface="Segoe UI"/>
               </a:rPr>
-              <a:t>Hardware Audio Core: </a:t>
+              <a:t>Gaze-Clutch™ Tracking: </a:t>
             </a:r>
             <a:r>
               <a:rPr sz="1300">
                 <a:solidFill>
-                  <a:srgbClr val="91949B"/>
-                </a:solidFill>
-                <a:latin typeface="Segoe UI"/>
-              </a:rPr>
-              <a:t>Direct Windows Core Audio (PyCAW) input endpoint volume mute</a:t>
+                  <a:srgbClr val="94979E"/>
+                </a:solidFill>
+                <a:latin typeface="Segoe UI"/>
+              </a:rPr>
+              <a:t>3D head yaw telemetry sleeps controls when looking at another monitor</a:t>
             </a:r>
           </a:p>
           <a:p>
             <a:pPr>
               <a:spcBef>
-                <a:spcPts val="600"/>
+                <a:spcPts val="700"/>
               </a:spcBef>
             </a:pPr>
             <a:r>
@@ -5971,22 +5835,22 @@
                 </a:solidFill>
                 <a:latin typeface="Segoe UI"/>
               </a:rPr>
-              <a:t>Native Camera Sharing: </a:t>
+              <a:t>ShoulderGuard™ Shield: </a:t>
             </a:r>
             <a:r>
               <a:rPr sz="1300">
                 <a:solidFill>
-                  <a:srgbClr val="91949B"/>
-                </a:solidFill>
-                <a:latin typeface="Segoe UI"/>
-              </a:rPr>
-              <a:t>OpenCV MSMF backend hooks svchost Camera for multi-app streaming</a:t>
+                  <a:srgbClr val="94979E"/>
+                </a:solidFill>
+                <a:latin typeface="Segoe UI"/>
+              </a:rPr>
+              <a:t>BlazeFace scans for passersby; auto-minimizes screen on intruders (Win+D)</a:t>
             </a:r>
           </a:p>
           <a:p>
             <a:pPr>
               <a:spcBef>
-                <a:spcPts val="600"/>
+                <a:spcPts val="700"/>
               </a:spcBef>
             </a:pPr>
             <a:r>
@@ -6005,16 +5869,16 @@
                 </a:solidFill>
                 <a:latin typeface="Segoe UI"/>
               </a:rPr>
-              <a:t>Executive Ambient HUD: </a:t>
+              <a:t>Body Ownership &amp; Physics: </a:t>
             </a:r>
             <a:r>
               <a:rPr sz="1300">
                 <a:solidFill>
-                  <a:srgbClr val="91949B"/>
-                </a:solidFill>
-                <a:latin typeface="Segoe UI"/>
-              </a:rPr>
-              <a:t>CustomTkinter dashboard + always-on-top champagne micro-pill</a:t>
+                  <a:srgbClr val="94979E"/>
+                </a:solidFill>
+                <a:latin typeface="Segoe UI"/>
+              </a:rPr>
+              <a:t>Calculates reach radius from face &amp; freezes hallucinated joint jitter</a:t>
             </a:r>
           </a:p>
         </p:txBody>
@@ -6027,8 +5891,8 @@
         </p:nvSpPr>
         <p:spPr>
           <a:xfrm>
-            <a:off x="6217920" y="1691640"/>
-            <a:ext cx="5212080" cy="4480560"/>
+            <a:off x="6217920" y="1783080"/>
+            <a:ext cx="5212080" cy="4389120"/>
           </a:xfrm>
           <a:prstGeom prst="roundRect">
             <a:avLst/>
@@ -6072,8 +5936,8 @@
         </p:nvSpPr>
         <p:spPr>
           <a:xfrm>
-            <a:off x="6437376" y="1892808"/>
-            <a:ext cx="4773168" cy="4078224"/>
+            <a:off x="6437376" y="1984248"/>
+            <a:ext cx="4773168" cy="3986784"/>
           </a:xfrm>
           <a:prstGeom prst="rect">
             <a:avLst/>
@@ -6087,7 +5951,7 @@
           <a:lstStyle/>
           <a:p>
             <a:pPr>
-              <a:defRPr sz="1700" b="1">
+              <a:defRPr sz="1800" b="1">
                 <a:solidFill>
                   <a:srgbClr val="D4AF6A"/>
                 </a:solidFill>
@@ -6095,7 +5959,7 @@
               </a:defRPr>
             </a:pPr>
             <a:r>
-              <a:t>Why ZeroTouch Wins</a:t>
+              <a:t>Under The Hood &amp; Why We Win</a:t>
             </a:r>
           </a:p>
           <a:p>
@@ -6108,19 +5972,19 @@
               </a:spcAft>
               <a:defRPr sz="1000" b="1">
                 <a:solidFill>
-                  <a:srgbClr val="91949B"/>
+                  <a:srgbClr val="94979E"/>
                 </a:solidFill>
                 <a:latin typeface="Consolas"/>
               </a:defRPr>
             </a:pPr>
             <a:r>
-              <a:t>EXECUTIVE PRODUCTION POLISH</a:t>
+              <a:t>WINDOWS NATIVE ENGINEERING</a:t>
             </a:r>
           </a:p>
           <a:p>
             <a:pPr>
               <a:spcBef>
-                <a:spcPts val="600"/>
+                <a:spcPts val="700"/>
               </a:spcBef>
             </a:pPr>
             <a:r>
@@ -6139,22 +6003,22 @@
                 </a:solidFill>
                 <a:latin typeface="Segoe UI"/>
               </a:rPr>
-              <a:t>Production Finish: </a:t>
+              <a:t>Zero-Copy Shared Memory: </a:t>
             </a:r>
             <a:r>
               <a:rPr sz="1300">
                 <a:solidFill>
-                  <a:srgbClr val="91949B"/>
-                </a:solidFill>
-                <a:latin typeface="Segoe UI"/>
-              </a:rPr>
-              <a:t>1-click silent background launcher, custom taskbar brand &amp; tray icon</a:t>
+                  <a:srgbClr val="94979E"/>
+                </a:solidFill>
+                <a:latin typeface="Segoe UI"/>
+              </a:rPr>
+              <a:t>multiprocessing.shared_memory streams 30 FPS HUD previews with 0% CPU drag</a:t>
             </a:r>
           </a:p>
           <a:p>
             <a:pPr>
               <a:spcBef>
-                <a:spcPts val="600"/>
+                <a:spcPts val="700"/>
               </a:spcBef>
             </a:pPr>
             <a:r>
@@ -6173,22 +6037,22 @@
                 </a:solidFill>
                 <a:latin typeface="Segoe UI"/>
               </a:rPr>
-              <a:t>No Hardware Needed: </a:t>
+              <a:t>Hardware Core Audio Hook: </a:t>
             </a:r>
             <a:r>
               <a:rPr sz="1300">
                 <a:solidFill>
-                  <a:srgbClr val="91949B"/>
-                </a:solidFill>
-                <a:latin typeface="Segoe UI"/>
-              </a:rPr>
-              <a:t>Works on any built-in laptop webcam or $15 USB camera</a:t>
+                  <a:srgbClr val="94979E"/>
+                </a:solidFill>
+                <a:latin typeface="Segoe UI"/>
+              </a:rPr>
+              <a:t>PyCAW toggles Windows hardware mic endpoint directly at driver level</a:t>
             </a:r>
           </a:p>
           <a:p>
             <a:pPr>
               <a:spcBef>
-                <a:spcPts val="600"/>
+                <a:spcPts val="700"/>
               </a:spcBef>
             </a:pPr>
             <a:r>
@@ -6207,22 +6071,22 @@
                 </a:solidFill>
                 <a:latin typeface="Segoe UI"/>
               </a:rPr>
-              <a:t>Solves Everyday Pain: </a:t>
+              <a:t>Native OS Camera Sharing: </a:t>
             </a:r>
             <a:r>
               <a:rPr sz="1300">
                 <a:solidFill>
-                  <a:srgbClr val="91949B"/>
-                </a:solidFill>
-                <a:latin typeface="Segoe UI"/>
-              </a:rPr>
-              <a:t>Not a tech demo; designed for daily desk and presentation workflows</a:t>
+                  <a:srgbClr val="94979E"/>
+                </a:solidFill>
+                <a:latin typeface="Segoe UI"/>
+              </a:rPr>
+              <a:t>OpenCV MSMF backend hooks svchost Camera for seamless multi-app streaming</a:t>
             </a:r>
           </a:p>
           <a:p>
             <a:pPr>
               <a:spcBef>
-                <a:spcPts val="600"/>
+                <a:spcPts val="700"/>
               </a:spcBef>
             </a:pPr>
             <a:r>
@@ -6241,16 +6105,16 @@
                 </a:solidFill>
                 <a:latin typeface="Segoe UI"/>
               </a:rPr>
-              <a:t>Open Source &amp; Live: </a:t>
+              <a:t>Production Polish: </a:t>
             </a:r>
             <a:r>
               <a:rPr sz="1300">
                 <a:solidFill>
-                  <a:srgbClr val="91949B"/>
-                </a:solidFill>
-                <a:latin typeface="Segoe UI"/>
-              </a:rPr>
-              <a:t>Tested, verified, and ready on GitHub: Philphil-org/UAT-Hackathon</a:t>
+                  <a:srgbClr val="94979E"/>
+                </a:solidFill>
+                <a:latin typeface="Segoe UI"/>
+              </a:rPr>
+              <a:t>1-click silent background launcher, custom taskbar brand &amp; system tray daemon</a:t>
             </a:r>
           </a:p>
         </p:txBody>

</xml_diff>

<commit_message>
docs: add project credits slide recognizing Phil, Gemini, and Antigravity
</commit_message>
<xml_diff>
--- a/ZeroTouch_PitchDeck.pptx
+++ b/ZeroTouch_PitchDeck.pptx
@@ -10,6 +10,7 @@
     <p:sldId id="258" r:id="rId9"/>
     <p:sldId id="259" r:id="rId10"/>
     <p:sldId id="260" r:id="rId11"/>
+    <p:sldId id="261" r:id="rId12"/>
   </p:sldIdLst>
   <p:sldSz cx="12191695" cy="6858000" type="screen4x3"/>
   <p:notesSz cx="6858000" cy="9144000"/>
@@ -6115,6 +6116,843 @@
                 <a:latin typeface="Segoe UI"/>
               </a:rPr>
               <a:t>1-click silent background launcher, custom taskbar brand &amp; system tray daemon</a:t>
+            </a:r>
+          </a:p>
+        </p:txBody>
+      </p:sp>
+    </p:spTree>
+  </p:cSld>
+  <p:clrMapOvr>
+    <a:masterClrMapping/>
+  </p:clrMapOvr>
+</p:sld>
+</file>
+
+<file path=ppt/slides/slide6.xml><?xml version="1.0" encoding="utf-8"?>
+<p:sld xmlns:a="http://schemas.openxmlformats.org/drawingml/2006/main" xmlns:p="http://schemas.openxmlformats.org/presentationml/2006/main" xmlns:r="http://schemas.openxmlformats.org/officeDocument/2006/relationships">
+  <p:cSld>
+    <p:spTree>
+      <p:nvGrpSpPr>
+        <p:cNvPr id="1" name=""/>
+        <p:cNvGrpSpPr/>
+        <p:nvPr/>
+      </p:nvGrpSpPr>
+      <p:grpSpPr/>
+      <p:sp>
+        <p:nvSpPr>
+          <p:cNvPr id="2" name="Rectangle 1"/>
+          <p:cNvSpPr/>
+          <p:nvPr/>
+        </p:nvSpPr>
+        <p:spPr>
+          <a:xfrm>
+            <a:off x="0" y="0"/>
+            <a:ext cx="12191695" cy="6858000"/>
+          </a:xfrm>
+          <a:prstGeom prst="rect">
+            <a:avLst/>
+          </a:prstGeom>
+          <a:solidFill>
+            <a:srgbClr val="0F0F14"/>
+          </a:solidFill>
+          <a:ln>
+            <a:noFill/>
+          </a:ln>
+        </p:spPr>
+        <p:style>
+          <a:lnRef idx="1">
+            <a:schemeClr val="accent1"/>
+          </a:lnRef>
+          <a:fillRef idx="3">
+            <a:schemeClr val="accent1"/>
+          </a:fillRef>
+          <a:effectRef idx="2">
+            <a:schemeClr val="accent1"/>
+          </a:effectRef>
+          <a:fontRef idx="minor">
+            <a:schemeClr val="lt1"/>
+          </a:fontRef>
+        </p:style>
+        <p:txBody>
+          <a:bodyPr rtlCol="0" anchor="ctr"/>
+          <a:lstStyle/>
+          <a:p>
+            <a:pPr algn="ctr"/>
+          </a:p>
+        </p:txBody>
+      </p:sp>
+      <p:sp>
+        <p:nvSpPr>
+          <p:cNvPr id="3" name="TextBox 2"/>
+          <p:cNvSpPr txBox="1"/>
+          <p:nvPr/>
+        </p:nvSpPr>
+        <p:spPr>
+          <a:xfrm>
+            <a:off x="731520" y="438912"/>
+            <a:ext cx="10728655" cy="1097280"/>
+          </a:xfrm>
+          <a:prstGeom prst="rect">
+            <a:avLst/>
+          </a:prstGeom>
+          <a:noFill/>
+        </p:spPr>
+        <p:txBody>
+          <a:bodyPr wrap="square">
+            <a:spAutoFit/>
+          </a:bodyPr>
+          <a:lstStyle/>
+          <a:p>
+            <a:pPr>
+              <a:defRPr sz="1100" b="1">
+                <a:solidFill>
+                  <a:srgbClr val="D4AF6A"/>
+                </a:solidFill>
+                <a:latin typeface="Consolas"/>
+              </a:defRPr>
+            </a:pPr>
+            <a:r>
+              <a:t>05 • CREDITS &amp; TEAM</a:t>
+            </a:r>
+          </a:p>
+          <a:p>
+            <a:pPr>
+              <a:spcBef>
+                <a:spcPts val="300"/>
+              </a:spcBef>
+              <a:defRPr sz="2500" b="1">
+                <a:solidFill>
+                  <a:srgbClr val="F2EFE9"/>
+                </a:solidFill>
+                <a:latin typeface="Georgia"/>
+              </a:defRPr>
+            </a:pPr>
+            <a:r>
+              <a:t>Project Credits &amp; AI-Collaborative Engineering</a:t>
+            </a:r>
+          </a:p>
+          <a:p>
+            <a:pPr>
+              <a:spcBef>
+                <a:spcPts val="200"/>
+              </a:spcBef>
+              <a:defRPr sz="1200">
+                <a:solidFill>
+                  <a:srgbClr val="94979E"/>
+                </a:solidFill>
+                <a:latin typeface="Segoe UI"/>
+              </a:defRPr>
+            </a:pPr>
+            <a:r>
+              <a:t>Rapidly conceived, engineered, and shipped through human-in-the-loop AI pair programming.</a:t>
+            </a:r>
+          </a:p>
+        </p:txBody>
+      </p:sp>
+      <p:sp>
+        <p:nvSpPr>
+          <p:cNvPr id="4" name="Rounded Rectangle 3"/>
+          <p:cNvSpPr/>
+          <p:nvPr/>
+        </p:nvSpPr>
+        <p:spPr>
+          <a:xfrm>
+            <a:off x="731520" y="1783080"/>
+            <a:ext cx="3383280" cy="4389120"/>
+          </a:xfrm>
+          <a:prstGeom prst="roundRect">
+            <a:avLst/>
+          </a:prstGeom>
+          <a:solidFill>
+            <a:srgbClr val="181820"/>
+          </a:solidFill>
+          <a:ln w="15240">
+            <a:solidFill>
+              <a:srgbClr val="D4AF6A"/>
+            </a:solidFill>
+          </a:ln>
+        </p:spPr>
+        <p:style>
+          <a:lnRef idx="1">
+            <a:schemeClr val="accent1"/>
+          </a:lnRef>
+          <a:fillRef idx="3">
+            <a:schemeClr val="accent1"/>
+          </a:fillRef>
+          <a:effectRef idx="2">
+            <a:schemeClr val="accent1"/>
+          </a:effectRef>
+          <a:fontRef idx="minor">
+            <a:schemeClr val="lt1"/>
+          </a:fontRef>
+        </p:style>
+        <p:txBody>
+          <a:bodyPr rtlCol="0" anchor="ctr"/>
+          <a:lstStyle/>
+          <a:p>
+            <a:pPr algn="ctr"/>
+          </a:p>
+        </p:txBody>
+      </p:sp>
+      <p:sp>
+        <p:nvSpPr>
+          <p:cNvPr id="5" name="TextBox 4"/>
+          <p:cNvSpPr txBox="1"/>
+          <p:nvPr/>
+        </p:nvSpPr>
+        <p:spPr>
+          <a:xfrm>
+            <a:off x="950976" y="1984248"/>
+            <a:ext cx="2944368" cy="3986784"/>
+          </a:xfrm>
+          <a:prstGeom prst="rect">
+            <a:avLst/>
+          </a:prstGeom>
+          <a:noFill/>
+        </p:spPr>
+        <p:txBody>
+          <a:bodyPr wrap="square">
+            <a:spAutoFit/>
+          </a:bodyPr>
+          <a:lstStyle/>
+          <a:p>
+            <a:pPr>
+              <a:defRPr sz="1800" b="1">
+                <a:solidFill>
+                  <a:srgbClr val="D4AF6A"/>
+                </a:solidFill>
+                <a:latin typeface="Segoe UI"/>
+              </a:defRPr>
+            </a:pPr>
+            <a:r>
+              <a:t>Phil</a:t>
+            </a:r>
+          </a:p>
+          <a:p>
+            <a:pPr>
+              <a:spcBef>
+                <a:spcPts val="200"/>
+              </a:spcBef>
+              <a:spcAft>
+                <a:spcPts val="600"/>
+              </a:spcAft>
+              <a:defRPr sz="1000" b="1">
+                <a:solidFill>
+                  <a:srgbClr val="94979E"/>
+                </a:solidFill>
+                <a:latin typeface="Consolas"/>
+              </a:defRPr>
+            </a:pPr>
+            <a:r>
+              <a:t>LEAD DIRECTION &amp; OVERSIGHT</a:t>
+            </a:r>
+          </a:p>
+          <a:p>
+            <a:pPr>
+              <a:spcBef>
+                <a:spcPts val="700"/>
+              </a:spcBef>
+            </a:pPr>
+            <a:r>
+              <a:rPr b="1" sz="1300">
+                <a:solidFill>
+                  <a:srgbClr val="D4AF6A"/>
+                </a:solidFill>
+                <a:latin typeface="Segoe UI"/>
+              </a:rPr>
+              <a:t>• </a:t>
+            </a:r>
+            <a:r>
+              <a:rPr b="1" sz="1300">
+                <a:solidFill>
+                  <a:srgbClr val="F2EFE9"/>
+                </a:solidFill>
+                <a:latin typeface="Segoe UI"/>
+              </a:rPr>
+              <a:t>Project Lead: </a:t>
+            </a:r>
+            <a:r>
+              <a:rPr sz="1300">
+                <a:solidFill>
+                  <a:srgbClr val="94979E"/>
+                </a:solidFill>
+                <a:latin typeface="Segoe UI"/>
+              </a:rPr>
+              <a:t>Conceived the ZeroTouch vision and real-world spatial interaction model</a:t>
+            </a:r>
+          </a:p>
+          <a:p>
+            <a:pPr>
+              <a:spcBef>
+                <a:spcPts val="700"/>
+              </a:spcBef>
+            </a:pPr>
+            <a:r>
+              <a:rPr b="1" sz="1300">
+                <a:solidFill>
+                  <a:srgbClr val="D4AF6A"/>
+                </a:solidFill>
+                <a:latin typeface="Segoe UI"/>
+              </a:rPr>
+              <a:t>• </a:t>
+            </a:r>
+            <a:r>
+              <a:rPr b="1" sz="1300">
+                <a:solidFill>
+                  <a:srgbClr val="F2EFE9"/>
+                </a:solidFill>
+                <a:latin typeface="Segoe UI"/>
+              </a:rPr>
+              <a:t>Human Oversight: </a:t>
+            </a:r>
+            <a:r>
+              <a:rPr sz="1300">
+                <a:solidFill>
+                  <a:srgbClr val="94979E"/>
+                </a:solidFill>
+                <a:latin typeface="Segoe UI"/>
+              </a:rPr>
+              <a:t>Directed architectural decisions, feature trade-offs, and design UX</a:t>
+            </a:r>
+          </a:p>
+          <a:p>
+            <a:pPr>
+              <a:spcBef>
+                <a:spcPts val="700"/>
+              </a:spcBef>
+            </a:pPr>
+            <a:r>
+              <a:rPr b="1" sz="1300">
+                <a:solidFill>
+                  <a:srgbClr val="D4AF6A"/>
+                </a:solidFill>
+                <a:latin typeface="Segoe UI"/>
+              </a:rPr>
+              <a:t>• </a:t>
+            </a:r>
+            <a:r>
+              <a:rPr b="1" sz="1300">
+                <a:solidFill>
+                  <a:srgbClr val="F2EFE9"/>
+                </a:solidFill>
+                <a:latin typeface="Segoe UI"/>
+              </a:rPr>
+              <a:t>Real-World Validation: </a:t>
+            </a:r>
+            <a:r>
+              <a:rPr sz="1300">
+                <a:solidFill>
+                  <a:srgbClr val="94979E"/>
+                </a:solidFill>
+                <a:latin typeface="Segoe UI"/>
+              </a:rPr>
+              <a:t>Tested hardware audio hooks, multi-app camera feeds, and desk ergonomic flow</a:t>
+            </a:r>
+          </a:p>
+          <a:p>
+            <a:pPr>
+              <a:spcBef>
+                <a:spcPts val="700"/>
+              </a:spcBef>
+            </a:pPr>
+            <a:r>
+              <a:rPr b="1" sz="1300">
+                <a:solidFill>
+                  <a:srgbClr val="D4AF6A"/>
+                </a:solidFill>
+                <a:latin typeface="Segoe UI"/>
+              </a:rPr>
+              <a:t>• </a:t>
+            </a:r>
+            <a:r>
+              <a:rPr b="1" sz="1300">
+                <a:solidFill>
+                  <a:srgbClr val="F2EFE9"/>
+                </a:solidFill>
+                <a:latin typeface="Segoe UI"/>
+              </a:rPr>
+              <a:t>Demo &amp; Presentation: </a:t>
+            </a:r>
+            <a:r>
+              <a:rPr sz="1300">
+                <a:solidFill>
+                  <a:srgbClr val="94979E"/>
+                </a:solidFill>
+                <a:latin typeface="Segoe UI"/>
+              </a:rPr>
+              <a:t>Orchestrated hackathon delivery, live demo testing, and presentation pitch</a:t>
+            </a:r>
+          </a:p>
+        </p:txBody>
+      </p:sp>
+      <p:sp>
+        <p:nvSpPr>
+          <p:cNvPr id="6" name="Rounded Rectangle 5"/>
+          <p:cNvSpPr/>
+          <p:nvPr/>
+        </p:nvSpPr>
+        <p:spPr>
+          <a:xfrm>
+            <a:off x="4389120" y="1783080"/>
+            <a:ext cx="3383280" cy="4389120"/>
+          </a:xfrm>
+          <a:prstGeom prst="roundRect">
+            <a:avLst/>
+          </a:prstGeom>
+          <a:solidFill>
+            <a:srgbClr val="181820"/>
+          </a:solidFill>
+          <a:ln w="15240">
+            <a:solidFill>
+              <a:srgbClr val="F2EFE9"/>
+            </a:solidFill>
+          </a:ln>
+        </p:spPr>
+        <p:style>
+          <a:lnRef idx="1">
+            <a:schemeClr val="accent1"/>
+          </a:lnRef>
+          <a:fillRef idx="3">
+            <a:schemeClr val="accent1"/>
+          </a:fillRef>
+          <a:effectRef idx="2">
+            <a:schemeClr val="accent1"/>
+          </a:effectRef>
+          <a:fontRef idx="minor">
+            <a:schemeClr val="lt1"/>
+          </a:fontRef>
+        </p:style>
+        <p:txBody>
+          <a:bodyPr rtlCol="0" anchor="ctr"/>
+          <a:lstStyle/>
+          <a:p>
+            <a:pPr algn="ctr"/>
+          </a:p>
+        </p:txBody>
+      </p:sp>
+      <p:sp>
+        <p:nvSpPr>
+          <p:cNvPr id="7" name="TextBox 6"/>
+          <p:cNvSpPr txBox="1"/>
+          <p:nvPr/>
+        </p:nvSpPr>
+        <p:spPr>
+          <a:xfrm>
+            <a:off x="4608576" y="1984248"/>
+            <a:ext cx="2944368" cy="3986784"/>
+          </a:xfrm>
+          <a:prstGeom prst="rect">
+            <a:avLst/>
+          </a:prstGeom>
+          <a:noFill/>
+        </p:spPr>
+        <p:txBody>
+          <a:bodyPr wrap="square">
+            <a:spAutoFit/>
+          </a:bodyPr>
+          <a:lstStyle/>
+          <a:p>
+            <a:pPr>
+              <a:defRPr sz="1800" b="1">
+                <a:solidFill>
+                  <a:srgbClr val="F2EFE9"/>
+                </a:solidFill>
+                <a:latin typeface="Segoe UI"/>
+              </a:defRPr>
+            </a:pPr>
+            <a:r>
+              <a:t>Google Gemini</a:t>
+            </a:r>
+          </a:p>
+          <a:p>
+            <a:pPr>
+              <a:spcBef>
+                <a:spcPts val="200"/>
+              </a:spcBef>
+              <a:spcAft>
+                <a:spcPts val="600"/>
+              </a:spcAft>
+              <a:defRPr sz="1000" b="1">
+                <a:solidFill>
+                  <a:srgbClr val="94979E"/>
+                </a:solidFill>
+                <a:latin typeface="Consolas"/>
+              </a:defRPr>
+            </a:pPr>
+            <a:r>
+              <a:t>CONCEPT &amp; IDEATION STAGE</a:t>
+            </a:r>
+          </a:p>
+          <a:p>
+            <a:pPr>
+              <a:spcBef>
+                <a:spcPts val="700"/>
+              </a:spcBef>
+            </a:pPr>
+            <a:r>
+              <a:rPr b="1" sz="1300">
+                <a:solidFill>
+                  <a:srgbClr val="F2EFE9"/>
+                </a:solidFill>
+                <a:latin typeface="Segoe UI"/>
+              </a:rPr>
+              <a:t>• </a:t>
+            </a:r>
+            <a:r>
+              <a:rPr b="1" sz="1300">
+                <a:solidFill>
+                  <a:srgbClr val="F2EFE9"/>
+                </a:solidFill>
+                <a:latin typeface="Segoe UI"/>
+              </a:rPr>
+              <a:t>Initial Brainstorming: </a:t>
+            </a:r>
+            <a:r>
+              <a:rPr sz="1300">
+                <a:solidFill>
+                  <a:srgbClr val="94979E"/>
+                </a:solidFill>
+                <a:latin typeface="Segoe UI"/>
+              </a:rPr>
+              <a:t>Explored concept ideation and computer vision use-case problem spaces</a:t>
+            </a:r>
+          </a:p>
+          <a:p>
+            <a:pPr>
+              <a:spcBef>
+                <a:spcPts val="700"/>
+              </a:spcBef>
+            </a:pPr>
+            <a:r>
+              <a:rPr b="1" sz="1300">
+                <a:solidFill>
+                  <a:srgbClr val="F2EFE9"/>
+                </a:solidFill>
+                <a:latin typeface="Segoe UI"/>
+              </a:rPr>
+              <a:t>• </a:t>
+            </a:r>
+            <a:r>
+              <a:rPr b="1" sz="1300">
+                <a:solidFill>
+                  <a:srgbClr val="F2EFE9"/>
+                </a:solidFill>
+                <a:latin typeface="Segoe UI"/>
+              </a:rPr>
+              <a:t>Interaction Taxonomy: </a:t>
+            </a:r>
+            <a:r>
+              <a:rPr sz="1300">
+                <a:solidFill>
+                  <a:srgbClr val="94979E"/>
+                </a:solidFill>
+                <a:latin typeface="Segoe UI"/>
+              </a:rPr>
+              <a:t>Framed touchless spatial control paradigms for Windows workflows</a:t>
+            </a:r>
+          </a:p>
+          <a:p>
+            <a:pPr>
+              <a:spcBef>
+                <a:spcPts val="700"/>
+              </a:spcBef>
+            </a:pPr>
+            <a:r>
+              <a:rPr b="1" sz="1300">
+                <a:solidFill>
+                  <a:srgbClr val="F2EFE9"/>
+                </a:solidFill>
+                <a:latin typeface="Segoe UI"/>
+              </a:rPr>
+              <a:t>• </a:t>
+            </a:r>
+            <a:r>
+              <a:rPr b="1" sz="1300">
+                <a:solidFill>
+                  <a:srgbClr val="F2EFE9"/>
+                </a:solidFill>
+                <a:latin typeface="Segoe UI"/>
+              </a:rPr>
+              <a:t>Feature Framing: </a:t>
+            </a:r>
+            <a:r>
+              <a:rPr sz="1300">
+                <a:solidFill>
+                  <a:srgbClr val="94979E"/>
+                </a:solidFill>
+                <a:latin typeface="Segoe UI"/>
+              </a:rPr>
+              <a:t>Assisted in identifying core friction points in video calls and slide presenting</a:t>
+            </a:r>
+          </a:p>
+          <a:p>
+            <a:pPr>
+              <a:spcBef>
+                <a:spcPts val="700"/>
+              </a:spcBef>
+            </a:pPr>
+            <a:r>
+              <a:rPr b="1" sz="1300">
+                <a:solidFill>
+                  <a:srgbClr val="F2EFE9"/>
+                </a:solidFill>
+                <a:latin typeface="Segoe UI"/>
+              </a:rPr>
+              <a:t>• </a:t>
+            </a:r>
+            <a:r>
+              <a:rPr b="1" sz="1300">
+                <a:solidFill>
+                  <a:srgbClr val="F2EFE9"/>
+                </a:solidFill>
+                <a:latin typeface="Segoe UI"/>
+              </a:rPr>
+              <a:t>Hackathon Thesis: </a:t>
+            </a:r>
+            <a:r>
+              <a:rPr sz="1300">
+                <a:solidFill>
+                  <a:srgbClr val="94979E"/>
+                </a:solidFill>
+                <a:latin typeface="Segoe UI"/>
+              </a:rPr>
+              <a:t>Helped articulate the 'invisible peripheral' design philosophy</a:t>
+            </a:r>
+          </a:p>
+        </p:txBody>
+      </p:sp>
+      <p:sp>
+        <p:nvSpPr>
+          <p:cNvPr id="8" name="Rounded Rectangle 7"/>
+          <p:cNvSpPr/>
+          <p:nvPr/>
+        </p:nvSpPr>
+        <p:spPr>
+          <a:xfrm>
+            <a:off x="8046720" y="1783080"/>
+            <a:ext cx="3383280" cy="4389120"/>
+          </a:xfrm>
+          <a:prstGeom prst="roundRect">
+            <a:avLst/>
+          </a:prstGeom>
+          <a:solidFill>
+            <a:srgbClr val="181820"/>
+          </a:solidFill>
+          <a:ln w="15240">
+            <a:solidFill>
+              <a:srgbClr val="557DB9"/>
+            </a:solidFill>
+          </a:ln>
+        </p:spPr>
+        <p:style>
+          <a:lnRef idx="1">
+            <a:schemeClr val="accent1"/>
+          </a:lnRef>
+          <a:fillRef idx="3">
+            <a:schemeClr val="accent1"/>
+          </a:fillRef>
+          <a:effectRef idx="2">
+            <a:schemeClr val="accent1"/>
+          </a:effectRef>
+          <a:fontRef idx="minor">
+            <a:schemeClr val="lt1"/>
+          </a:fontRef>
+        </p:style>
+        <p:txBody>
+          <a:bodyPr rtlCol="0" anchor="ctr"/>
+          <a:lstStyle/>
+          <a:p>
+            <a:pPr algn="ctr"/>
+          </a:p>
+        </p:txBody>
+      </p:sp>
+      <p:sp>
+        <p:nvSpPr>
+          <p:cNvPr id="9" name="TextBox 8"/>
+          <p:cNvSpPr txBox="1"/>
+          <p:nvPr/>
+        </p:nvSpPr>
+        <p:spPr>
+          <a:xfrm>
+            <a:off x="8266176" y="1984248"/>
+            <a:ext cx="2944368" cy="3986784"/>
+          </a:xfrm>
+          <a:prstGeom prst="rect">
+            <a:avLst/>
+          </a:prstGeom>
+          <a:noFill/>
+        </p:spPr>
+        <p:txBody>
+          <a:bodyPr wrap="square">
+            <a:spAutoFit/>
+          </a:bodyPr>
+          <a:lstStyle/>
+          <a:p>
+            <a:pPr>
+              <a:defRPr sz="1800" b="1">
+                <a:solidFill>
+                  <a:srgbClr val="557DB9"/>
+                </a:solidFill>
+                <a:latin typeface="Segoe UI"/>
+              </a:defRPr>
+            </a:pPr>
+            <a:r>
+              <a:t>Antigravity</a:t>
+            </a:r>
+          </a:p>
+          <a:p>
+            <a:pPr>
+              <a:spcBef>
+                <a:spcPts val="200"/>
+              </a:spcBef>
+              <a:spcAft>
+                <a:spcPts val="600"/>
+              </a:spcAft>
+              <a:defRPr sz="1000" b="1">
+                <a:solidFill>
+                  <a:srgbClr val="94979E"/>
+                </a:solidFill>
+                <a:latin typeface="Consolas"/>
+              </a:defRPr>
+            </a:pPr>
+            <a:r>
+              <a:t>DEEPMIND AUTONOMOUS CODING AGENT</a:t>
+            </a:r>
+          </a:p>
+          <a:p>
+            <a:pPr>
+              <a:spcBef>
+                <a:spcPts val="700"/>
+              </a:spcBef>
+            </a:pPr>
+            <a:r>
+              <a:rPr b="1" sz="1300">
+                <a:solidFill>
+                  <a:srgbClr val="557DB9"/>
+                </a:solidFill>
+                <a:latin typeface="Segoe UI"/>
+              </a:rPr>
+              <a:t>• </a:t>
+            </a:r>
+            <a:r>
+              <a:rPr b="1" sz="1300">
+                <a:solidFill>
+                  <a:srgbClr val="F2EFE9"/>
+                </a:solidFill>
+                <a:latin typeface="Segoe UI"/>
+              </a:rPr>
+              <a:t>Full-Stack Implementation: </a:t>
+            </a:r>
+            <a:r>
+              <a:rPr sz="1300">
+                <a:solidFill>
+                  <a:srgbClr val="94979E"/>
+                </a:solidFill>
+                <a:latin typeface="Segoe UI"/>
+              </a:rPr>
+              <a:t>Wrote the complete Python, OpenCV, MediaPipe, and PyCAW codebase</a:t>
+            </a:r>
+          </a:p>
+          <a:p>
+            <a:pPr>
+              <a:spcBef>
+                <a:spcPts val="700"/>
+              </a:spcBef>
+            </a:pPr>
+            <a:r>
+              <a:rPr b="1" sz="1300">
+                <a:solidFill>
+                  <a:srgbClr val="557DB9"/>
+                </a:solidFill>
+                <a:latin typeface="Segoe UI"/>
+              </a:rPr>
+              <a:t>• </a:t>
+            </a:r>
+            <a:r>
+              <a:rPr b="1" sz="1300">
+                <a:solidFill>
+                  <a:srgbClr val="F2EFE9"/>
+                </a:solidFill>
+                <a:latin typeface="Segoe UI"/>
+              </a:rPr>
+              <a:t>Defense Physics Engine: </a:t>
+            </a:r>
+            <a:r>
+              <a:rPr sz="1300">
+                <a:solidFill>
+                  <a:srgbClr val="94979E"/>
+                </a:solidFill>
+                <a:latin typeface="Segoe UI"/>
+              </a:rPr>
+              <a:t>Built Gaze-Clutch, ShoulderGuard, and anti-jitter bone physics algorithms</a:t>
+            </a:r>
+          </a:p>
+          <a:p>
+            <a:pPr>
+              <a:spcBef>
+                <a:spcPts val="700"/>
+              </a:spcBef>
+            </a:pPr>
+            <a:r>
+              <a:rPr b="1" sz="1300">
+                <a:solidFill>
+                  <a:srgbClr val="557DB9"/>
+                </a:solidFill>
+                <a:latin typeface="Segoe UI"/>
+              </a:rPr>
+              <a:t>• </a:t>
+            </a:r>
+            <a:r>
+              <a:rPr b="1" sz="1300">
+                <a:solidFill>
+                  <a:srgbClr val="F2EFE9"/>
+                </a:solidFill>
+                <a:latin typeface="Segoe UI"/>
+              </a:rPr>
+              <a:t>OS &amp; Hardware Integration: </a:t>
+            </a:r>
+            <a:r>
+              <a:rPr sz="1300">
+                <a:solidFill>
+                  <a:srgbClr val="94979E"/>
+                </a:solidFill>
+                <a:latin typeface="Segoe UI"/>
+              </a:rPr>
+              <a:t>Engineered shared memory IPC, camera sharing, and zero-console launchers</a:t>
+            </a:r>
+          </a:p>
+          <a:p>
+            <a:pPr>
+              <a:spcBef>
+                <a:spcPts val="700"/>
+              </a:spcBef>
+            </a:pPr>
+            <a:r>
+              <a:rPr b="1" sz="1300">
+                <a:solidFill>
+                  <a:srgbClr val="557DB9"/>
+                </a:solidFill>
+                <a:latin typeface="Segoe UI"/>
+              </a:rPr>
+              <a:t>• </a:t>
+            </a:r>
+            <a:r>
+              <a:rPr b="1" sz="1300">
+                <a:solidFill>
+                  <a:srgbClr val="F2EFE9"/>
+                </a:solidFill>
+                <a:latin typeface="Segoe UI"/>
+              </a:rPr>
+              <a:t>Presentation &amp; Polish: </a:t>
+            </a:r>
+            <a:r>
+              <a:rPr sz="1300">
+                <a:solidFill>
+                  <a:srgbClr val="94979E"/>
+                </a:solidFill>
+                <a:latin typeface="Segoe UI"/>
+              </a:rPr>
+              <a:t>Generated executive pitch decks, HUD micro-capsules, and system tray integration</a:t>
             </a:r>
           </a:p>
         </p:txBody>

</xml_diff>